<commit_message>
docs(rules): update slide rules with heading emoji, 1 accent color per slide, and zero-overflow layout
</commit_message>
<xml_diff>
--- a/IELTS/07_YouTube_Studio/01_Slides_Writing_Task1_Map.pptx
+++ b/IELTS/07_YouTube_Studio/01_Slides_Writing_Task1_Map.pptx
@@ -3114,8 +3114,8 @@
         </p:nvSpPr>
         <p:spPr>
           <a:xfrm>
-            <a:off x="731520" y="548640"/>
-            <a:ext cx="10728655" cy="822960"/>
+            <a:off x="731520" y="457200"/>
+            <a:ext cx="10728655" cy="731520"/>
           </a:xfrm>
           <a:prstGeom prst="rect">
             <a:avLst/>
@@ -3129,15 +3129,15 @@
           <a:lstStyle/>
           <a:p>
             <a:pPr>
-              <a:defRPr sz="3600" b="1">
-                <a:solidFill>
-                  <a:srgbClr val="0F172A"/>
-                </a:solidFill>
-                <a:latin typeface="Montserrat"/>
-              </a:defRPr>
-            </a:pPr>
-            <a:r>
-              <a:t>PHÂN LOẠI CÁC DẠNG BÀI MAP</a:t>
+              <a:defRPr sz="3400" b="1">
+                <a:solidFill>
+                  <a:srgbClr val="DC2626"/>
+                </a:solidFill>
+                <a:latin typeface="Montserrat"/>
+              </a:defRPr>
+            </a:pPr>
+            <a:r>
+              <a:t>🗺️ PHÂN LOẠI CÁC DẠNG BÀI MAP</a:t>
             </a:r>
           </a:p>
         </p:txBody>
@@ -3158,8 +3158,8 @@
         </p:blipFill>
         <p:spPr>
           <a:xfrm>
-            <a:off x="731520" y="1645920"/>
-            <a:ext cx="4206240" cy="4144513"/>
+            <a:off x="731520" y="1463040"/>
+            <a:ext cx="4023360" cy="3964317"/>
           </a:xfrm>
           <a:prstGeom prst="rect">
             <a:avLst/>
@@ -3174,8 +3174,8 @@
         </p:nvSpPr>
         <p:spPr>
           <a:xfrm>
-            <a:off x="5303520" y="1645920"/>
-            <a:ext cx="6217920" cy="4754880"/>
+            <a:off x="5120640" y="1463040"/>
+            <a:ext cx="6309360" cy="4754880"/>
           </a:xfrm>
           <a:prstGeom prst="rect">
             <a:avLst/>
@@ -3190,7 +3190,7 @@
           <a:p>
             <a:pPr>
               <a:spcAft>
-                <a:spcPts val="800"/>
+                <a:spcPts val="400"/>
               </a:spcAft>
               <a:defRPr b="1" i="0" sz="2600">
                 <a:solidFill>
@@ -3206,7 +3206,7 @@
           <a:p>
             <a:pPr>
               <a:spcAft>
-                <a:spcPts val="2400"/>
+                <a:spcPts val="1800"/>
               </a:spcAft>
               <a:defRPr b="0" i="1" sz="2400">
                 <a:solidFill>
@@ -3222,7 +3222,7 @@
           <a:p>
             <a:pPr>
               <a:spcAft>
-                <a:spcPts val="800"/>
+                <a:spcPts val="400"/>
               </a:spcAft>
               <a:defRPr b="1" i="0" sz="2600">
                 <a:solidFill>
@@ -3238,7 +3238,7 @@
           <a:p>
             <a:pPr>
               <a:spcAft>
-                <a:spcPts val="2400"/>
+                <a:spcPts val="1800"/>
               </a:spcAft>
               <a:defRPr b="0" i="1" sz="2400">
                 <a:solidFill>
@@ -3254,7 +3254,7 @@
           <a:p>
             <a:pPr>
               <a:spcAft>
-                <a:spcPts val="800"/>
+                <a:spcPts val="400"/>
               </a:spcAft>
               <a:defRPr b="1" i="0" sz="2600">
                 <a:solidFill>
@@ -3270,7 +3270,7 @@
           <a:p>
             <a:pPr>
               <a:spcAft>
-                <a:spcPts val="2400"/>
+                <a:spcPts val="1800"/>
               </a:spcAft>
               <a:defRPr b="0" i="1" sz="2400">
                 <a:solidFill>
@@ -3286,7 +3286,7 @@
           <a:p>
             <a:pPr>
               <a:spcAft>
-                <a:spcPts val="800"/>
+                <a:spcPts val="400"/>
               </a:spcAft>
               <a:defRPr b="1" i="0" sz="2600">
                 <a:solidFill>
@@ -3351,8 +3351,8 @@
         </p:nvSpPr>
         <p:spPr>
           <a:xfrm>
-            <a:off x="731520" y="548640"/>
-            <a:ext cx="10728655" cy="822960"/>
+            <a:off x="731520" y="457200"/>
+            <a:ext cx="10728655" cy="731520"/>
           </a:xfrm>
           <a:prstGeom prst="rect">
             <a:avLst/>
@@ -3366,15 +3366,15 @@
           <a:lstStyle/>
           <a:p>
             <a:pPr>
-              <a:defRPr sz="3600" b="1">
-                <a:solidFill>
-                  <a:srgbClr val="0F172A"/>
-                </a:solidFill>
-                <a:latin typeface="Montserrat"/>
-              </a:defRPr>
-            </a:pPr>
-            <a:r>
-              <a:t>ĐỀ THI THẬT #1: THÂN BÀI BODY 1 &amp; BODY 2</a:t>
+              <a:defRPr sz="3400" b="1">
+                <a:solidFill>
+                  <a:srgbClr val="7C3AED"/>
+                </a:solidFill>
+                <a:latin typeface="Montserrat"/>
+              </a:defRPr>
+            </a:pPr>
+            <a:r>
+              <a:t>📝 ĐỀ THI THẬT #1: THÂN BÀI BODY 1 &amp; BODY 2</a:t>
             </a:r>
           </a:p>
         </p:txBody>
@@ -3395,8 +3395,8 @@
         </p:blipFill>
         <p:spPr>
           <a:xfrm>
-            <a:off x="731520" y="1645920"/>
-            <a:ext cx="4023360" cy="2105656"/>
+            <a:off x="731520" y="1463040"/>
+            <a:ext cx="3931920" cy="2057800"/>
           </a:xfrm>
           <a:prstGeom prst="rect">
             <a:avLst/>
@@ -3411,8 +3411,8 @@
         </p:nvSpPr>
         <p:spPr>
           <a:xfrm>
-            <a:off x="5029200" y="1645920"/>
-            <a:ext cx="6400800" cy="4754880"/>
+            <a:off x="4937760" y="1463040"/>
+            <a:ext cx="6492240" cy="4754880"/>
           </a:xfrm>
           <a:prstGeom prst="rect">
             <a:avLst/>
@@ -3427,7 +3427,7 @@
           <a:p>
             <a:pPr>
               <a:spcAft>
-                <a:spcPts val="600"/>
+                <a:spcPts val="400"/>
               </a:spcAft>
               <a:defRPr b="1" i="0" sz="2600">
                 <a:solidFill>
@@ -3469,13 +3469,13 @@
               </a:defRPr>
             </a:pPr>
             <a:r>
-              <a:t>Farmland in the north-east was completely cleared to make way for new housing.</a:t>
-            </a:r>
-          </a:p>
-          <a:p>
-            <a:pPr>
-              <a:spcAft>
-                <a:spcPts val="2600"/>
+              <a:t>Farmland in north-east was cleared to make way for new roads lined with houses.</a:t>
+            </a:r>
+          </a:p>
+          <a:p>
+            <a:pPr>
+              <a:spcAft>
+                <a:spcPts val="1800"/>
               </a:spcAft>
               <a:defRPr b="0" i="1" sz="2400">
                 <a:solidFill>
@@ -3485,13 +3485,13 @@
               </a:defRPr>
             </a:pPr>
             <a:r>
-              <a:t>Post office stayed intact, while shops adjacent to it were demolished and replaced by houses.</a:t>
-            </a:r>
-          </a:p>
-          <a:p>
-            <a:pPr>
-              <a:spcAft>
-                <a:spcPts val="600"/>
+              <a:t>Post office stayed intact, while adjacent shops were replaced by houses.</a:t>
+            </a:r>
+          </a:p>
+          <a:p>
+            <a:pPr>
+              <a:spcAft>
+                <a:spcPts val="400"/>
               </a:spcAft>
               <a:defRPr b="1" i="0" sz="2600">
                 <a:solidFill>
@@ -3517,7 +3517,7 @@
               </a:defRPr>
             </a:pPr>
             <a:r>
-              <a:t>Located to the east of the road, the primary school was significantly extended.</a:t>
+              <a:t>Primary school located to the east of road was significantly extended.</a:t>
             </a:r>
           </a:p>
           <a:p>
@@ -3533,7 +3533,7 @@
               </a:defRPr>
             </a:pPr>
             <a:r>
-              <a:t>Large house was converted into a retirement home at the expense of gardens.</a:t>
+              <a:t>Large house was converted into a retirement home at expense of gardens.</a:t>
             </a:r>
           </a:p>
           <a:p>
@@ -3549,7 +3549,7 @@
               </a:defRPr>
             </a:pPr>
             <a:r>
-              <a:t>Farmland in the south-west gave way to new houses.</a:t>
+              <a:t>Farmland in south-west gave way to new houses.</a:t>
             </a:r>
           </a:p>
         </p:txBody>
@@ -3588,8 +3588,8 @@
         </p:nvSpPr>
         <p:spPr>
           <a:xfrm>
-            <a:off x="731520" y="548640"/>
-            <a:ext cx="10728655" cy="822960"/>
+            <a:off x="731520" y="457200"/>
+            <a:ext cx="10728655" cy="731520"/>
           </a:xfrm>
           <a:prstGeom prst="rect">
             <a:avLst/>
@@ -3603,15 +3603,15 @@
           <a:lstStyle/>
           <a:p>
             <a:pPr>
-              <a:defRPr sz="3600" b="1">
-                <a:solidFill>
-                  <a:srgbClr val="0F172A"/>
-                </a:solidFill>
-                <a:latin typeface="Montserrat"/>
-              </a:defRPr>
-            </a:pPr>
-            <a:r>
-              <a:t>ĐỀ THI THẬT #2: THƯ VIỆN (CAMBRIDGE 18 TEST 3)</a:t>
+              <a:defRPr sz="3400" b="1">
+                <a:solidFill>
+                  <a:srgbClr val="EA580C"/>
+                </a:solidFill>
+                <a:latin typeface="Montserrat"/>
+              </a:defRPr>
+            </a:pPr>
+            <a:r>
+              <a:t>📚 ĐỀ THI THẬT #2: THƯ VIỆN (CAMBRIDGE 18)</a:t>
             </a:r>
           </a:p>
         </p:txBody>
@@ -3632,8 +3632,8 @@
         </p:blipFill>
         <p:spPr>
           <a:xfrm>
-            <a:off x="731520" y="1645920"/>
-            <a:ext cx="4114800" cy="4674952"/>
+            <a:off x="731520" y="1463040"/>
+            <a:ext cx="4023360" cy="4571064"/>
           </a:xfrm>
           <a:prstGeom prst="rect">
             <a:avLst/>
@@ -3648,8 +3648,8 @@
         </p:nvSpPr>
         <p:spPr>
           <a:xfrm>
-            <a:off x="5120640" y="1645920"/>
-            <a:ext cx="6309360" cy="4754880"/>
+            <a:off x="5029200" y="1463040"/>
+            <a:ext cx="6400800" cy="4754880"/>
           </a:xfrm>
           <a:prstGeom prst="rect">
             <a:avLst/>
@@ -3664,7 +3664,7 @@
           <a:p>
             <a:pPr>
               <a:spcAft>
-                <a:spcPts val="600"/>
+                <a:spcPts val="400"/>
               </a:spcAft>
               <a:defRPr b="1" i="0" sz="2600">
                 <a:solidFill>
@@ -3680,7 +3680,7 @@
           <a:p>
             <a:pPr>
               <a:spcAft>
-                <a:spcPts val="2400"/>
+                <a:spcPts val="1800"/>
               </a:spcAft>
               <a:defRPr b="0" i="1" sz="2400">
                 <a:solidFill>
@@ -3690,13 +3690,13 @@
               </a:defRPr>
             </a:pPr>
             <a:r>
-              <a:t>The library has been significantly modernized, while the central area has been opened up by removing seating.</a:t>
-            </a:r>
-          </a:p>
-          <a:p>
-            <a:pPr>
-              <a:spcAft>
-                <a:spcPts val="600"/>
+              <a:t>The library has been modernized, while central tables have been removed.</a:t>
+            </a:r>
+          </a:p>
+          <a:p>
+            <a:pPr>
+              <a:spcAft>
+                <a:spcPts val="400"/>
               </a:spcAft>
               <a:defRPr b="1" i="0" sz="2600">
                 <a:solidFill>
@@ -3722,13 +3722,13 @@
               </a:defRPr>
             </a:pPr>
             <a:r>
-              <a:t>Tables and chairs in the middle have been completely removed.</a:t>
-            </a:r>
-          </a:p>
-          <a:p>
-            <a:pPr>
-              <a:spcAft>
-                <a:spcPts val="2400"/>
+              <a:t>Reading room has been replaced by computer room.</a:t>
+            </a:r>
+          </a:p>
+          <a:p>
+            <a:pPr>
+              <a:spcAft>
+                <a:spcPts val="1800"/>
               </a:spcAft>
               <a:defRPr b="0" i="1" sz="2400">
                 <a:solidFill>
@@ -3738,13 +3738,13 @@
               </a:defRPr>
             </a:pPr>
             <a:r>
-              <a:t>Reading room has been replaced by a computer room, and enquiry desk has given way to a café.</a:t>
-            </a:r>
-          </a:p>
-          <a:p>
-            <a:pPr>
-              <a:spcAft>
-                <a:spcPts val="600"/>
+              <a:t>Enquiry desk has given way to a café and self-service machines.</a:t>
+            </a:r>
+          </a:p>
+          <a:p>
+            <a:pPr>
+              <a:spcAft>
+                <a:spcPts val="400"/>
               </a:spcAft>
               <a:defRPr b="1" i="0" sz="2600">
                 <a:solidFill>
@@ -3825,8 +3825,8 @@
         </p:nvSpPr>
         <p:spPr>
           <a:xfrm>
-            <a:off x="731520" y="548640"/>
-            <a:ext cx="10728655" cy="822960"/>
+            <a:off x="731520" y="457200"/>
+            <a:ext cx="10728655" cy="731520"/>
           </a:xfrm>
           <a:prstGeom prst="rect">
             <a:avLst/>
@@ -3840,15 +3840,15 @@
           <a:lstStyle/>
           <a:p>
             <a:pPr>
-              <a:defRPr sz="3600" b="1">
-                <a:solidFill>
-                  <a:srgbClr val="0F172A"/>
-                </a:solidFill>
-                <a:latin typeface="Montserrat"/>
-              </a:defRPr>
-            </a:pPr>
-            <a:r>
-              <a:t>4 TIÊU CHÍ CHẤM ĐIỂM (BAND 7.5+)</a:t>
+              <a:defRPr sz="3400" b="1">
+                <a:solidFill>
+                  <a:srgbClr val="7C3AED"/>
+                </a:solidFill>
+                <a:latin typeface="Montserrat"/>
+              </a:defRPr>
+            </a:pPr>
+            <a:r>
+              <a:t>🎯 4 TIÊU CHÍ CHẤM ĐIỂM (BAND 7.5+)</a:t>
             </a:r>
           </a:p>
         </p:txBody>
@@ -3861,7 +3861,7 @@
         </p:nvSpPr>
         <p:spPr>
           <a:xfrm>
-            <a:off x="731520" y="1645920"/>
+            <a:off x="731520" y="1463040"/>
             <a:ext cx="5120640" cy="4754880"/>
           </a:xfrm>
           <a:prstGeom prst="rect">
@@ -3877,9 +3877,9 @@
           <a:p>
             <a:pPr>
               <a:spcAft>
-                <a:spcPts val="800"/>
-              </a:spcAft>
-              <a:defRPr b="1" i="0" sz="2800">
+                <a:spcPts val="600"/>
+              </a:spcAft>
+              <a:defRPr b="1" i="0" sz="2600">
                 <a:solidFill>
                   <a:srgbClr val="0F172A"/>
                 </a:solidFill>
@@ -3893,7 +3893,7 @@
           <a:p>
             <a:pPr>
               <a:spcAft>
-                <a:spcPts val="800"/>
+                <a:spcPts val="600"/>
               </a:spcAft>
               <a:defRPr b="0" i="0" sz="2400">
                 <a:solidFill>
@@ -3909,7 +3909,7 @@
           <a:p>
             <a:pPr>
               <a:spcAft>
-                <a:spcPts val="3200"/>
+                <a:spcPts val="2600"/>
               </a:spcAft>
               <a:defRPr b="0" i="1" sz="2400">
                 <a:solidFill>
@@ -3925,9 +3925,9 @@
           <a:p>
             <a:pPr>
               <a:spcAft>
-                <a:spcPts val="800"/>
-              </a:spcAft>
-              <a:defRPr b="1" i="0" sz="2800">
+                <a:spcPts val="600"/>
+              </a:spcAft>
+              <a:defRPr b="1" i="0" sz="2600">
                 <a:solidFill>
                   <a:srgbClr val="0F172A"/>
                 </a:solidFill>
@@ -3941,7 +3941,7 @@
           <a:p>
             <a:pPr>
               <a:spcAft>
-                <a:spcPts val="800"/>
+                <a:spcPts val="600"/>
               </a:spcAft>
               <a:defRPr b="0" i="0" sz="2400">
                 <a:solidFill>
@@ -3980,7 +3980,7 @@
         </p:nvSpPr>
         <p:spPr>
           <a:xfrm>
-            <a:off x="6217920" y="1645920"/>
+            <a:off x="6217920" y="1463040"/>
             <a:ext cx="5120640" cy="4754880"/>
           </a:xfrm>
           <a:prstGeom prst="rect">
@@ -3996,9 +3996,9 @@
           <a:p>
             <a:pPr>
               <a:spcAft>
-                <a:spcPts val="800"/>
-              </a:spcAft>
-              <a:defRPr b="1" i="0" sz="2800">
+                <a:spcPts val="600"/>
+              </a:spcAft>
+              <a:defRPr b="1" i="0" sz="2600">
                 <a:solidFill>
                   <a:srgbClr val="0F172A"/>
                 </a:solidFill>
@@ -4012,7 +4012,7 @@
           <a:p>
             <a:pPr>
               <a:spcAft>
-                <a:spcPts val="800"/>
+                <a:spcPts val="600"/>
               </a:spcAft>
               <a:defRPr b="0" i="0" sz="2400">
                 <a:solidFill>
@@ -4028,7 +4028,7 @@
           <a:p>
             <a:pPr>
               <a:spcAft>
-                <a:spcPts val="3200"/>
+                <a:spcPts val="2600"/>
               </a:spcAft>
               <a:defRPr b="0" i="1" sz="2400">
                 <a:solidFill>
@@ -4038,15 +4038,15 @@
               </a:defRPr>
             </a:pPr>
             <a:r>
-              <a:t>Chính xác giới từ in và to khi chỉ phương hướng</a:t>
-            </a:r>
-          </a:p>
-          <a:p>
-            <a:pPr>
-              <a:spcAft>
-                <a:spcPts val="800"/>
-              </a:spcAft>
-              <a:defRPr b="1" i="0" sz="2800">
+              <a:t>Chính xác giới từ in và to khi chỉ hướng</a:t>
+            </a:r>
+          </a:p>
+          <a:p>
+            <a:pPr>
+              <a:spcAft>
+                <a:spcPts val="600"/>
+              </a:spcAft>
+              <a:defRPr b="1" i="0" sz="2600">
                 <a:solidFill>
                   <a:srgbClr val="0F172A"/>
                 </a:solidFill>
@@ -4060,7 +4060,7 @@
           <a:p>
             <a:pPr>
               <a:spcAft>
-                <a:spcPts val="800"/>
+                <a:spcPts val="600"/>
               </a:spcAft>
               <a:defRPr b="0" i="0" sz="2400">
                 <a:solidFill>
@@ -4086,7 +4086,7 @@
               </a:defRPr>
             </a:pPr>
             <a:r>
-              <a:t>Kết hợp danh từ hóa và mệnh đề phân từ rút gọn</a:t>
+              <a:t>Kết hợp danh từ hóa và mệnh đề phân từ</a:t>
             </a:r>
           </a:p>
         </p:txBody>
@@ -4125,8 +4125,8 @@
         </p:nvSpPr>
         <p:spPr>
           <a:xfrm>
-            <a:off x="731520" y="548640"/>
-            <a:ext cx="10728655" cy="822960"/>
+            <a:off x="731520" y="457200"/>
+            <a:ext cx="10728655" cy="731520"/>
           </a:xfrm>
           <a:prstGeom prst="rect">
             <a:avLst/>
@@ -4140,15 +4140,15 @@
           <a:lstStyle/>
           <a:p>
             <a:pPr>
-              <a:defRPr sz="3600" b="1">
-                <a:solidFill>
-                  <a:srgbClr val="0F172A"/>
-                </a:solidFill>
-                <a:latin typeface="Montserrat"/>
-              </a:defRPr>
-            </a:pPr>
-            <a:r>
-              <a:t>CẤU TRÚC BÀI VIẾT VÀ CÁCH CHIA BODY</a:t>
+              <a:defRPr sz="3400" b="1">
+                <a:solidFill>
+                  <a:srgbClr val="EA580C"/>
+                </a:solidFill>
+                <a:latin typeface="Montserrat"/>
+              </a:defRPr>
+            </a:pPr>
+            <a:r>
+              <a:t>📐 CẤU TRÚC BÀI VIẾT VÀ CÁCH CHIA BODY</a:t>
             </a:r>
           </a:p>
         </p:txBody>
@@ -4161,7 +4161,7 @@
         </p:nvSpPr>
         <p:spPr>
           <a:xfrm>
-            <a:off x="731520" y="1645920"/>
+            <a:off x="731520" y="1463040"/>
             <a:ext cx="10728655" cy="4754880"/>
           </a:xfrm>
           <a:prstGeom prst="rect">
@@ -4177,9 +4177,9 @@
           <a:p>
             <a:pPr>
               <a:spcAft>
-                <a:spcPts val="1000"/>
-              </a:spcAft>
-              <a:defRPr b="1" i="0" sz="2800">
+                <a:spcPts val="600"/>
+              </a:spcAft>
+              <a:defRPr b="1" i="0" sz="2600">
                 <a:solidFill>
                   <a:srgbClr val="0F172A"/>
                 </a:solidFill>
@@ -4193,9 +4193,9 @@
           <a:p>
             <a:pPr>
               <a:spcAft>
-                <a:spcPts val="3200"/>
-              </a:spcAft>
-              <a:defRPr b="1" i="1" sz="2600">
+                <a:spcPts val="2400"/>
+              </a:spcAft>
+              <a:defRPr b="1" i="1" sz="2400">
                 <a:solidFill>
                   <a:srgbClr val="0F172A"/>
                 </a:solidFill>
@@ -4209,7 +4209,7 @@
           <a:p>
             <a:pPr>
               <a:spcAft>
-                <a:spcPts val="800"/>
+                <a:spcPts val="600"/>
               </a:spcAft>
               <a:defRPr b="1" i="0" sz="2600">
                 <a:solidFill>
@@ -4225,7 +4225,7 @@
           <a:p>
             <a:pPr>
               <a:spcAft>
-                <a:spcPts val="2400"/>
+                <a:spcPts val="2000"/>
               </a:spcAft>
               <a:defRPr b="0" i="1" sz="2400">
                 <a:solidFill>
@@ -4241,7 +4241,7 @@
           <a:p>
             <a:pPr>
               <a:spcAft>
-                <a:spcPts val="800"/>
+                <a:spcPts val="600"/>
               </a:spcAft>
               <a:defRPr b="1" i="0" sz="2600">
                 <a:solidFill>
@@ -4257,7 +4257,7 @@
           <a:p>
             <a:pPr>
               <a:spcAft>
-                <a:spcPts val="2400"/>
+                <a:spcPts val="2000"/>
               </a:spcAft>
               <a:defRPr b="0" i="1" sz="2400">
                 <a:solidFill>
@@ -4273,7 +4273,7 @@
           <a:p>
             <a:pPr>
               <a:spcAft>
-                <a:spcPts val="800"/>
+                <a:spcPts val="600"/>
               </a:spcAft>
               <a:defRPr b="1" i="0" sz="2600">
                 <a:solidFill>
@@ -4338,8 +4338,8 @@
         </p:nvSpPr>
         <p:spPr>
           <a:xfrm>
-            <a:off x="731520" y="548640"/>
-            <a:ext cx="10728655" cy="822960"/>
+            <a:off x="731520" y="457200"/>
+            <a:ext cx="10728655" cy="731520"/>
           </a:xfrm>
           <a:prstGeom prst="rect">
             <a:avLst/>
@@ -4353,15 +4353,15 @@
           <a:lstStyle/>
           <a:p>
             <a:pPr>
-              <a:defRPr sz="3600" b="1">
-                <a:solidFill>
-                  <a:srgbClr val="0F172A"/>
-                </a:solidFill>
-                <a:latin typeface="Montserrat"/>
-              </a:defRPr>
-            </a:pPr>
-            <a:r>
-              <a:t>KHUNG CÂU INTRODUCTION &amp; OVERVIEW</a:t>
+              <a:defRPr sz="3400" b="1">
+                <a:solidFill>
+                  <a:srgbClr val="DB2777"/>
+                </a:solidFill>
+                <a:latin typeface="Montserrat"/>
+              </a:defRPr>
+            </a:pPr>
+            <a:r>
+              <a:t>✍️ KHUNG CÂU INTRODUCTION &amp; OVERVIEW</a:t>
             </a:r>
           </a:p>
         </p:txBody>
@@ -4374,7 +4374,7 @@
         </p:nvSpPr>
         <p:spPr>
           <a:xfrm>
-            <a:off x="731520" y="1645920"/>
+            <a:off x="731520" y="1463040"/>
             <a:ext cx="10728655" cy="4754880"/>
           </a:xfrm>
           <a:prstGeom prst="rect">
@@ -4390,24 +4390,24 @@
           <a:p>
             <a:pPr>
               <a:spcAft>
+                <a:spcPts val="600"/>
+              </a:spcAft>
+              <a:defRPr b="1" i="0" sz="2600">
+                <a:solidFill>
+                  <a:srgbClr val="0F172A"/>
+                </a:solidFill>
+                <a:latin typeface="Montserrat"/>
+              </a:defRPr>
+            </a:pPr>
+            <a:r>
+              <a:t>INTRODUCTION (1 CÂU PARAPHRASE)</a:t>
+            </a:r>
+          </a:p>
+          <a:p>
+            <a:pPr>
+              <a:spcAft>
                 <a:spcPts val="800"/>
               </a:spcAft>
-              <a:defRPr b="1" i="0" sz="2800">
-                <a:solidFill>
-                  <a:srgbClr val="0F172A"/>
-                </a:solidFill>
-                <a:latin typeface="Montserrat"/>
-              </a:defRPr>
-            </a:pPr>
-            <a:r>
-              <a:t>INTRODUCTION (1 CÂU PARAPHRASE)</a:t>
-            </a:r>
-          </a:p>
-          <a:p>
-            <a:pPr>
-              <a:spcAft>
-                <a:spcPts val="1200"/>
-              </a:spcAft>
               <a:defRPr b="0" i="1" sz="2400">
                 <a:solidFill>
                   <a:srgbClr val="0F172A"/>
@@ -4422,7 +4422,7 @@
           <a:p>
             <a:pPr>
               <a:spcAft>
-                <a:spcPts val="3200"/>
+                <a:spcPts val="2400"/>
               </a:spcAft>
               <a:defRPr b="0" i="1" sz="2400">
                 <a:solidFill>
@@ -4438,23 +4438,23 @@
           <a:p>
             <a:pPr>
               <a:spcAft>
+                <a:spcPts val="600"/>
+              </a:spcAft>
+              <a:defRPr b="1" i="0" sz="2600">
+                <a:solidFill>
+                  <a:srgbClr val="0F172A"/>
+                </a:solidFill>
+                <a:latin typeface="Montserrat"/>
+              </a:defRPr>
+            </a:pPr>
+            <a:r>
+              <a:t>OVERVIEW (2 CÂU BỨC TRANH TỔNG THỂ)</a:t>
+            </a:r>
+          </a:p>
+          <a:p>
+            <a:pPr>
+              <a:spcAft>
                 <a:spcPts val="800"/>
-              </a:spcAft>
-              <a:defRPr b="1" i="0" sz="2800">
-                <a:solidFill>
-                  <a:srgbClr val="0F172A"/>
-                </a:solidFill>
-                <a:latin typeface="Montserrat"/>
-              </a:defRPr>
-            </a:pPr>
-            <a:r>
-              <a:t>OVERVIEW (2 CÂU NÊU BẢN CHẤT VÀ ĐIỂM NHẤN)</a:t>
-            </a:r>
-          </a:p>
-          <a:p>
-            <a:pPr>
-              <a:spcAft>
-                <a:spcPts val="1200"/>
               </a:spcAft>
               <a:defRPr b="0" i="1" sz="2400">
                 <a:solidFill>
@@ -4519,8 +4519,8 @@
         </p:nvSpPr>
         <p:spPr>
           <a:xfrm>
-            <a:off x="731520" y="548640"/>
-            <a:ext cx="10728655" cy="822960"/>
+            <a:off x="731520" y="457200"/>
+            <a:ext cx="10728655" cy="731520"/>
           </a:xfrm>
           <a:prstGeom prst="rect">
             <a:avLst/>
@@ -4534,15 +4534,15 @@
           <a:lstStyle/>
           <a:p>
             <a:pPr>
-              <a:defRPr sz="3600" b="1">
-                <a:solidFill>
-                  <a:srgbClr val="0F172A"/>
-                </a:solidFill>
-                <a:latin typeface="Montserrat"/>
-              </a:defRPr>
-            </a:pPr>
-            <a:r>
-              <a:t>8 HƯỚNG LA BÀN VÀ GIỚI TỪ IN VS TO</a:t>
+              <a:defRPr sz="3400" b="1">
+                <a:solidFill>
+                  <a:srgbClr val="DC2626"/>
+                </a:solidFill>
+                <a:latin typeface="Montserrat"/>
+              </a:defRPr>
+            </a:pPr>
+            <a:r>
+              <a:t>🧭 8 HƯỚNG LA BÀN VÀ GIỚI TỪ IN VS TO</a:t>
             </a:r>
           </a:p>
         </p:txBody>
@@ -4563,8 +4563,8 @@
         </p:blipFill>
         <p:spPr>
           <a:xfrm>
-            <a:off x="731520" y="1645920"/>
-            <a:ext cx="3474720" cy="3525819"/>
+            <a:off x="731520" y="1554480"/>
+            <a:ext cx="3291840" cy="3340249"/>
           </a:xfrm>
           <a:prstGeom prst="rect">
             <a:avLst/>
@@ -4579,8 +4579,8 @@
         </p:nvSpPr>
         <p:spPr>
           <a:xfrm>
-            <a:off x="4572000" y="1645920"/>
-            <a:ext cx="6858000" cy="4754880"/>
+            <a:off x="4389120" y="1463040"/>
+            <a:ext cx="7040880" cy="4754880"/>
           </a:xfrm>
           <a:prstGeom prst="rect">
             <a:avLst/>
@@ -4595,7 +4595,7 @@
           <a:p>
             <a:pPr>
               <a:spcAft>
-                <a:spcPts val="800"/>
+                <a:spcPts val="400"/>
               </a:spcAft>
               <a:defRPr b="1" i="0" sz="2600">
                 <a:solidFill>
@@ -4611,7 +4611,7 @@
           <a:p>
             <a:pPr>
               <a:spcAft>
-                <a:spcPts val="2800"/>
+                <a:spcPts val="1800"/>
               </a:spcAft>
               <a:defRPr b="0" i="1" sz="2400">
                 <a:solidFill>
@@ -4627,7 +4627,7 @@
           <a:p>
             <a:pPr>
               <a:spcAft>
-                <a:spcPts val="800"/>
+                <a:spcPts val="400"/>
               </a:spcAft>
               <a:defRPr b="1" i="0" sz="2600">
                 <a:solidFill>
@@ -4643,7 +4643,7 @@
           <a:p>
             <a:pPr>
               <a:spcAft>
-                <a:spcPts val="2800"/>
+                <a:spcPts val="1800"/>
               </a:spcAft>
               <a:defRPr b="0" i="1" sz="2400">
                 <a:solidFill>
@@ -4659,7 +4659,7 @@
           <a:p>
             <a:pPr>
               <a:spcAft>
-                <a:spcPts val="800"/>
+                <a:spcPts val="400"/>
               </a:spcAft>
               <a:defRPr b="1" i="0" sz="2600">
                 <a:solidFill>
@@ -4675,7 +4675,7 @@
           <a:p>
             <a:pPr>
               <a:spcAft>
-                <a:spcPts val="2800"/>
+                <a:spcPts val="1800"/>
               </a:spcAft>
               <a:defRPr b="0" i="1" sz="2400">
                 <a:solidFill>
@@ -4691,7 +4691,7 @@
           <a:p>
             <a:pPr>
               <a:spcAft>
-                <a:spcPts val="800"/>
+                <a:spcPts val="400"/>
               </a:spcAft>
               <a:defRPr b="1" i="0" sz="2600">
                 <a:solidFill>
@@ -4756,8 +4756,8 @@
         </p:nvSpPr>
         <p:spPr>
           <a:xfrm>
-            <a:off x="731520" y="548640"/>
-            <a:ext cx="10728655" cy="822960"/>
+            <a:off x="731520" y="457200"/>
+            <a:ext cx="10728655" cy="731520"/>
           </a:xfrm>
           <a:prstGeom prst="rect">
             <a:avLst/>
@@ -4771,15 +4771,15 @@
           <a:lstStyle/>
           <a:p>
             <a:pPr>
-              <a:defRPr sz="3600" b="1">
-                <a:solidFill>
-                  <a:srgbClr val="0F172A"/>
-                </a:solidFill>
-                <a:latin typeface="Montserrat"/>
-              </a:defRPr>
-            </a:pPr>
-            <a:r>
-              <a:t>ĐỊNH VỊ SƠ ĐỒ TRONG NHÀ (FLOOR PLAN)</a:t>
+              <a:defRPr sz="3400" b="1">
+                <a:solidFill>
+                  <a:srgbClr val="7C3AED"/>
+                </a:solidFill>
+                <a:latin typeface="Montserrat"/>
+              </a:defRPr>
+            </a:pPr>
+            <a:r>
+              <a:t>🏢 ĐỊNH VỊ SƠ ĐỒ TRONG NHÀ (FLOOR PLAN)</a:t>
             </a:r>
           </a:p>
         </p:txBody>
@@ -4800,8 +4800,8 @@
         </p:blipFill>
         <p:spPr>
           <a:xfrm>
-            <a:off x="731520" y="1645920"/>
-            <a:ext cx="4114800" cy="4674952"/>
+            <a:off x="731520" y="1463040"/>
+            <a:ext cx="4023360" cy="4571064"/>
           </a:xfrm>
           <a:prstGeom prst="rect">
             <a:avLst/>
@@ -4816,8 +4816,8 @@
         </p:nvSpPr>
         <p:spPr>
           <a:xfrm>
-            <a:off x="5212080" y="1645920"/>
-            <a:ext cx="6217920" cy="4754880"/>
+            <a:off x="5120640" y="1463040"/>
+            <a:ext cx="6309360" cy="4754880"/>
           </a:xfrm>
           <a:prstGeom prst="rect">
             <a:avLst/>
@@ -4832,7 +4832,7 @@
           <a:p>
             <a:pPr>
               <a:spcAft>
-                <a:spcPts val="800"/>
+                <a:spcPts val="400"/>
               </a:spcAft>
               <a:defRPr b="1" i="0" sz="2600">
                 <a:solidFill>
@@ -4848,7 +4848,7 @@
           <a:p>
             <a:pPr>
               <a:spcAft>
-                <a:spcPts val="2800"/>
+                <a:spcPts val="1800"/>
               </a:spcAft>
               <a:defRPr b="0" i="1" sz="2400">
                 <a:solidFill>
@@ -4864,7 +4864,7 @@
           <a:p>
             <a:pPr>
               <a:spcAft>
-                <a:spcPts val="800"/>
+                <a:spcPts val="400"/>
               </a:spcAft>
               <a:defRPr b="1" i="0" sz="2600">
                 <a:solidFill>
@@ -4880,7 +4880,7 @@
           <a:p>
             <a:pPr>
               <a:spcAft>
-                <a:spcPts val="2800"/>
+                <a:spcPts val="1800"/>
               </a:spcAft>
               <a:defRPr b="0" i="1" sz="2400">
                 <a:solidFill>
@@ -4896,7 +4896,7 @@
           <a:p>
             <a:pPr>
               <a:spcAft>
-                <a:spcPts val="800"/>
+                <a:spcPts val="400"/>
               </a:spcAft>
               <a:defRPr b="1" i="0" sz="2600">
                 <a:solidFill>
@@ -4912,7 +4912,7 @@
           <a:p>
             <a:pPr>
               <a:spcAft>
-                <a:spcPts val="2800"/>
+                <a:spcPts val="1800"/>
               </a:spcAft>
               <a:defRPr b="0" i="1" sz="2400">
                 <a:solidFill>
@@ -4928,7 +4928,7 @@
           <a:p>
             <a:pPr>
               <a:spcAft>
-                <a:spcPts val="800"/>
+                <a:spcPts val="400"/>
               </a:spcAft>
               <a:defRPr b="1" i="0" sz="2600">
                 <a:solidFill>
@@ -4993,8 +4993,8 @@
         </p:nvSpPr>
         <p:spPr>
           <a:xfrm>
-            <a:off x="731520" y="548640"/>
-            <a:ext cx="10728655" cy="822960"/>
+            <a:off x="731520" y="457200"/>
+            <a:ext cx="10728655" cy="731520"/>
           </a:xfrm>
           <a:prstGeom prst="rect">
             <a:avLst/>
@@ -5008,15 +5008,15 @@
           <a:lstStyle/>
           <a:p>
             <a:pPr>
-              <a:defRPr sz="3600" b="1">
-                <a:solidFill>
-                  <a:srgbClr val="0F172A"/>
-                </a:solidFill>
-                <a:latin typeface="Montserrat"/>
-              </a:defRPr>
-            </a:pPr>
-            <a:r>
-              <a:t>5 NHÓM ĐỘNG TỪ VÀ DANH TỪ HÓA</a:t>
+              <a:defRPr sz="3400" b="1">
+                <a:solidFill>
+                  <a:srgbClr val="EA580C"/>
+                </a:solidFill>
+                <a:latin typeface="Montserrat"/>
+              </a:defRPr>
+            </a:pPr>
+            <a:r>
+              <a:t>🔄 5 NHÓM ĐỘNG TỪ VÀ DANH TỪ HÓA</a:t>
             </a:r>
           </a:p>
         </p:txBody>
@@ -5029,7 +5029,7 @@
         </p:nvSpPr>
         <p:spPr>
           <a:xfrm>
-            <a:off x="731520" y="1645920"/>
+            <a:off x="731520" y="1463040"/>
             <a:ext cx="5120640" cy="4754880"/>
           </a:xfrm>
           <a:prstGeom prst="rect">
@@ -5045,7 +5045,7 @@
           <a:p>
             <a:pPr>
               <a:spcAft>
-                <a:spcPts val="800"/>
+                <a:spcPts val="400"/>
               </a:spcAft>
               <a:defRPr b="1" i="0" sz="2600">
                 <a:solidFill>
@@ -5077,7 +5077,7 @@
           <a:p>
             <a:pPr>
               <a:spcAft>
-                <a:spcPts val="2800"/>
+                <a:spcPts val="2000"/>
               </a:spcAft>
               <a:defRPr b="1" i="1" sz="2400">
                 <a:solidFill>
@@ -5093,7 +5093,7 @@
           <a:p>
             <a:pPr>
               <a:spcAft>
-                <a:spcPts val="800"/>
+                <a:spcPts val="400"/>
               </a:spcAft>
               <a:defRPr b="1" i="0" sz="2600">
                 <a:solidFill>
@@ -5164,7 +5164,7 @@
         </p:nvSpPr>
         <p:spPr>
           <a:xfrm>
-            <a:off x="6217920" y="1645920"/>
+            <a:off x="6217920" y="1463040"/>
             <a:ext cx="5120640" cy="4754880"/>
           </a:xfrm>
           <a:prstGeom prst="rect">
@@ -5180,7 +5180,7 @@
           <a:p>
             <a:pPr>
               <a:spcAft>
-                <a:spcPts val="800"/>
+                <a:spcPts val="400"/>
               </a:spcAft>
               <a:defRPr b="1" i="0" sz="2600">
                 <a:solidFill>
@@ -5212,7 +5212,7 @@
           <a:p>
             <a:pPr>
               <a:spcAft>
-                <a:spcPts val="2800"/>
+                <a:spcPts val="2000"/>
               </a:spcAft>
               <a:defRPr b="1" i="1" sz="2400">
                 <a:solidFill>
@@ -5228,7 +5228,7 @@
           <a:p>
             <a:pPr>
               <a:spcAft>
-                <a:spcPts val="800"/>
+                <a:spcPts val="400"/>
               </a:spcAft>
               <a:defRPr b="1" i="0" sz="2600">
                 <a:solidFill>
@@ -5260,7 +5260,7 @@
           <a:p>
             <a:pPr>
               <a:spcAft>
-                <a:spcPts val="2800"/>
+                <a:spcPts val="2000"/>
               </a:spcAft>
               <a:defRPr b="0" i="1" sz="2400">
                 <a:solidFill>
@@ -5276,7 +5276,7 @@
           <a:p>
             <a:pPr>
               <a:spcAft>
-                <a:spcPts val="800"/>
+                <a:spcPts val="400"/>
               </a:spcAft>
               <a:defRPr b="1" i="0" sz="2600">
                 <a:solidFill>
@@ -5341,8 +5341,8 @@
         </p:nvSpPr>
         <p:spPr>
           <a:xfrm>
-            <a:off x="731520" y="548640"/>
-            <a:ext cx="10728655" cy="822960"/>
+            <a:off x="731520" y="457200"/>
+            <a:ext cx="10728655" cy="731520"/>
           </a:xfrm>
           <a:prstGeom prst="rect">
             <a:avLst/>
@@ -5356,15 +5356,15 @@
           <a:lstStyle/>
           <a:p>
             <a:pPr>
-              <a:defRPr sz="3600" b="1">
-                <a:solidFill>
-                  <a:srgbClr val="0F172A"/>
-                </a:solidFill>
-                <a:latin typeface="Montserrat"/>
-              </a:defRPr>
-            </a:pPr>
-            <a:r>
-              <a:t>4 CẤU TRÚC NGỮ PHÁP ĂN ĐIỂM GRA</a:t>
+              <a:defRPr sz="3400" b="1">
+                <a:solidFill>
+                  <a:srgbClr val="DB2777"/>
+                </a:solidFill>
+                <a:latin typeface="Montserrat"/>
+              </a:defRPr>
+            </a:pPr>
+            <a:r>
+              <a:t>💡 4 CẤU TRÚC NGỮ PHÁP ĂN ĐIỂM GRA</a:t>
             </a:r>
           </a:p>
         </p:txBody>
@@ -5377,7 +5377,7 @@
         </p:nvSpPr>
         <p:spPr>
           <a:xfrm>
-            <a:off x="731520" y="1645920"/>
+            <a:off x="731520" y="1463040"/>
             <a:ext cx="10728655" cy="4754880"/>
           </a:xfrm>
           <a:prstGeom prst="rect">
@@ -5393,7 +5393,7 @@
           <a:p>
             <a:pPr>
               <a:spcAft>
-                <a:spcPts val="600"/>
+                <a:spcPts val="400"/>
               </a:spcAft>
               <a:defRPr b="1" i="0" sz="2600">
                 <a:solidFill>
@@ -5409,7 +5409,7 @@
           <a:p>
             <a:pPr>
               <a:spcAft>
-                <a:spcPts val="2400"/>
+                <a:spcPts val="1800"/>
               </a:spcAft>
               <a:defRPr b="0" i="1" sz="2400">
                 <a:solidFill>
@@ -5419,13 +5419,13 @@
               </a:defRPr>
             </a:pPr>
             <a:r>
-              <a:t>Located to the east of the main road, the primary school was significantly extended.</a:t>
-            </a:r>
-          </a:p>
-          <a:p>
-            <a:pPr>
-              <a:spcAft>
-                <a:spcPts val="600"/>
+              <a:t>Located to the east of the road, the primary school was significantly extended.</a:t>
+            </a:r>
+          </a:p>
+          <a:p>
+            <a:pPr>
+              <a:spcAft>
+                <a:spcPts val="400"/>
               </a:spcAft>
               <a:defRPr b="1" i="0" sz="2600">
                 <a:solidFill>
@@ -5441,7 +5441,7 @@
           <a:p>
             <a:pPr>
               <a:spcAft>
-                <a:spcPts val="2400"/>
+                <a:spcPts val="1800"/>
               </a:spcAft>
               <a:defRPr b="0" i="1" sz="2400">
                 <a:solidFill>
@@ -5457,7 +5457,7 @@
           <a:p>
             <a:pPr>
               <a:spcAft>
-                <a:spcPts val="600"/>
+                <a:spcPts val="400"/>
               </a:spcAft>
               <a:defRPr b="1" i="0" sz="2600">
                 <a:solidFill>
@@ -5473,7 +5473,7 @@
           <a:p>
             <a:pPr>
               <a:spcAft>
-                <a:spcPts val="2400"/>
+                <a:spcPts val="1800"/>
               </a:spcAft>
               <a:defRPr b="0" i="1" sz="2400">
                 <a:solidFill>
@@ -5489,7 +5489,7 @@
           <a:p>
             <a:pPr>
               <a:spcAft>
-                <a:spcPts val="600"/>
+                <a:spcPts val="400"/>
               </a:spcAft>
               <a:defRPr b="1" i="0" sz="2600">
                 <a:solidFill>
@@ -5554,8 +5554,8 @@
         </p:nvSpPr>
         <p:spPr>
           <a:xfrm>
-            <a:off x="731520" y="548640"/>
-            <a:ext cx="10728655" cy="822960"/>
+            <a:off x="731520" y="457200"/>
+            <a:ext cx="10728655" cy="731520"/>
           </a:xfrm>
           <a:prstGeom prst="rect">
             <a:avLst/>
@@ -5569,15 +5569,15 @@
           <a:lstStyle/>
           <a:p>
             <a:pPr>
-              <a:defRPr sz="3600" b="1">
-                <a:solidFill>
-                  <a:srgbClr val="0F172A"/>
-                </a:solidFill>
-                <a:latin typeface="Montserrat"/>
-              </a:defRPr>
-            </a:pPr>
-            <a:r>
-              <a:t>ĐỀ THI THẬT #1: NGÔI LÀNG STOKEFORD (1930 - 2010)</a:t>
+              <a:defRPr sz="3400" b="1">
+                <a:solidFill>
+                  <a:srgbClr val="DC2626"/>
+                </a:solidFill>
+                <a:latin typeface="Montserrat"/>
+              </a:defRPr>
+            </a:pPr>
+            <a:r>
+              <a:t>🏡 ĐỀ THI THẬT #1: LÀNG STOKEFORD (1930 - 2010)</a:t>
             </a:r>
           </a:p>
         </p:txBody>
@@ -5598,8 +5598,8 @@
         </p:blipFill>
         <p:spPr>
           <a:xfrm>
-            <a:off x="731520" y="1645920"/>
-            <a:ext cx="4206240" cy="2201368"/>
+            <a:off x="731520" y="1463040"/>
+            <a:ext cx="4114800" cy="2153512"/>
           </a:xfrm>
           <a:prstGeom prst="rect">
             <a:avLst/>
@@ -5614,8 +5614,8 @@
         </p:nvSpPr>
         <p:spPr>
           <a:xfrm>
-            <a:off x="5212080" y="1645920"/>
-            <a:ext cx="6217920" cy="4754880"/>
+            <a:off x="5120640" y="1463040"/>
+            <a:ext cx="6309360" cy="4754880"/>
           </a:xfrm>
           <a:prstGeom prst="rect">
             <a:avLst/>
@@ -5630,24 +5630,56 @@
           <a:p>
             <a:pPr>
               <a:spcAft>
+                <a:spcPts val="400"/>
+              </a:spcAft>
+              <a:defRPr b="1" i="0" sz="2600">
+                <a:solidFill>
+                  <a:srgbClr val="0F172A"/>
+                </a:solidFill>
+                <a:latin typeface="Montserrat"/>
+              </a:defRPr>
+            </a:pPr>
+            <a:r>
+              <a:t>INTRODUCTION (QUÁ KHỨ ĐƠN)</a:t>
+            </a:r>
+          </a:p>
+          <a:p>
+            <a:pPr>
+              <a:spcAft>
+                <a:spcPts val="2200"/>
+              </a:spcAft>
+              <a:defRPr b="0" i="1" sz="2400">
+                <a:solidFill>
+                  <a:srgbClr val="0F172A"/>
+                </a:solidFill>
+                <a:latin typeface="Montserrat"/>
+              </a:defRPr>
+            </a:pPr>
+            <a:r>
+              <a:t>The two maps illustrate how Stokeford developed over an 80-year period from 1930 to 2010.</a:t>
+            </a:r>
+          </a:p>
+          <a:p>
+            <a:pPr>
+              <a:spcAft>
+                <a:spcPts val="400"/>
+              </a:spcAft>
+              <a:defRPr b="1" i="0" sz="2600">
+                <a:solidFill>
+                  <a:srgbClr val="0F172A"/>
+                </a:solidFill>
+                <a:latin typeface="Montserrat"/>
+              </a:defRPr>
+            </a:pPr>
+            <a:r>
+              <a:t>OVERVIEW (2 CÂU BỨC TRANH TỔNG THỂ)</a:t>
+            </a:r>
+          </a:p>
+          <a:p>
+            <a:pPr>
+              <a:spcAft>
                 <a:spcPts val="800"/>
               </a:spcAft>
-              <a:defRPr b="1" i="0" sz="2600">
-                <a:solidFill>
-                  <a:srgbClr val="0F172A"/>
-                </a:solidFill>
-                <a:latin typeface="Montserrat"/>
-              </a:defRPr>
-            </a:pPr>
-            <a:r>
-              <a:t>INTRODUCTION (QUÁ KHỨ ĐƠN)</a:t>
-            </a:r>
-          </a:p>
-          <a:p>
-            <a:pPr>
-              <a:spcAft>
-                <a:spcPts val="3000"/>
-              </a:spcAft>
               <a:defRPr b="0" i="1" sz="2400">
                 <a:solidFill>
                   <a:srgbClr val="0F172A"/>
@@ -5656,29 +5688,13 @@
               </a:defRPr>
             </a:pPr>
             <a:r>
-              <a:t>The two maps illustrate how the village of Stokeford developed over an 80-year period from 1930 to 2010.</a:t>
-            </a:r>
-          </a:p>
-          <a:p>
-            <a:pPr>
-              <a:spcAft>
-                <a:spcPts val="800"/>
-              </a:spcAft>
-              <a:defRPr b="1" i="0" sz="2600">
-                <a:solidFill>
-                  <a:srgbClr val="0F172A"/>
-                </a:solidFill>
-                <a:latin typeface="Montserrat"/>
-              </a:defRPr>
-            </a:pPr>
-            <a:r>
-              <a:t>OVERVIEW (2 CÂU BỨC TRANH TỔNG THỂ)</a:t>
-            </a:r>
-          </a:p>
-          <a:p>
-            <a:pPr>
-              <a:spcAft>
-                <a:spcPts val="1200"/>
+              <a:t>Overall, the village underwent a dramatic transformation from a rural agricultural community into a residential area.</a:t>
+            </a:r>
+          </a:p>
+          <a:p>
+            <a:pPr>
+              <a:spcAft>
+                <a:spcPts val="0"/>
               </a:spcAft>
               <a:defRPr b="0" i="1" sz="2400">
                 <a:solidFill>
@@ -5688,23 +5704,7 @@
               </a:defRPr>
             </a:pPr>
             <a:r>
-              <a:t>Overall, the village underwent a dramatic transformation from a rural agricultural community into a densely populated residential area.</a:t>
-            </a:r>
-          </a:p>
-          <a:p>
-            <a:pPr>
-              <a:spcAft>
-                <a:spcPts val="0"/>
-              </a:spcAft>
-              <a:defRPr b="0" i="1" sz="2400">
-                <a:solidFill>
-                  <a:srgbClr val="0F172A"/>
-                </a:solidFill>
-                <a:latin typeface="Montserrat"/>
-              </a:defRPr>
-            </a:pPr>
-            <a:r>
-              <a:t>The most notable changes include the complete clearance of farmland to construct new housing and the expansion of educational and care facilities.</a:t>
+              <a:t>The most notable changes include the complete clearance of farmland to construct new housing.</a:t>
             </a:r>
           </a:p>
         </p:txBody>

</xml_diff>

<commit_message>
style(slides): add quote accent bars, 1-emoji headings, and fix text overflow
</commit_message>
<xml_diff>
--- a/IELTS/07_YouTube_Studio/01_Slides_Writing_Task1_Map.pptx
+++ b/IELTS/07_YouTube_Studio/01_Slides_Writing_Task1_Map.pptx
@@ -16,6 +16,7 @@
     <p:sldId id="264" r:id="rId15"/>
     <p:sldId id="265" r:id="rId16"/>
     <p:sldId id="266" r:id="rId17"/>
+    <p:sldId id="267" r:id="rId18"/>
   </p:sldIdLst>
   <p:sldSz cx="12191695" cy="6858000" type="screen4x3"/>
   <p:notesSz cx="6858000" cy="9144000"/>
@@ -3114,8 +3115,8 @@
         </p:nvSpPr>
         <p:spPr>
           <a:xfrm>
-            <a:off x="731520" y="457200"/>
-            <a:ext cx="10728655" cy="731520"/>
+            <a:off x="731520" y="411480"/>
+            <a:ext cx="10728655" cy="685800"/>
           </a:xfrm>
           <a:prstGeom prst="rect">
             <a:avLst/>
@@ -3129,7 +3130,7 @@
           <a:lstStyle/>
           <a:p>
             <a:pPr>
-              <a:defRPr sz="3400" b="1">
+              <a:defRPr sz="3200" b="1">
                 <a:solidFill>
                   <a:srgbClr val="DC2626"/>
                 </a:solidFill>
@@ -3158,7 +3159,7 @@
         </p:blipFill>
         <p:spPr>
           <a:xfrm>
-            <a:off x="731520" y="1463040"/>
+            <a:off x="731520" y="1371600"/>
             <a:ext cx="4023360" cy="3964317"/>
           </a:xfrm>
           <a:prstGeom prst="rect">
@@ -3168,14 +3169,57 @@
       </p:pic>
       <p:sp>
         <p:nvSpPr>
-          <p:cNvPr id="4" name="TextBox 3"/>
+          <p:cNvPr id="4" name="Rectangle 3"/>
+          <p:cNvSpPr/>
+          <p:nvPr/>
+        </p:nvSpPr>
+        <p:spPr>
+          <a:xfrm>
+            <a:off x="5120640" y="1371600"/>
+            <a:ext cx="45720" cy="960120"/>
+          </a:xfrm>
+          <a:prstGeom prst="rect">
+            <a:avLst/>
+          </a:prstGeom>
+          <a:solidFill>
+            <a:srgbClr val="DC2626"/>
+          </a:solidFill>
+          <a:ln>
+            <a:noFill/>
+          </a:ln>
+        </p:spPr>
+        <p:style>
+          <a:lnRef idx="1">
+            <a:schemeClr val="accent1"/>
+          </a:lnRef>
+          <a:fillRef idx="3">
+            <a:schemeClr val="accent1"/>
+          </a:fillRef>
+          <a:effectRef idx="2">
+            <a:schemeClr val="accent1"/>
+          </a:effectRef>
+          <a:fontRef idx="minor">
+            <a:schemeClr val="lt1"/>
+          </a:fontRef>
+        </p:style>
+        <p:txBody>
+          <a:bodyPr rtlCol="0" anchor="ctr"/>
+          <a:lstStyle/>
+          <a:p>
+            <a:pPr algn="ctr"/>
+          </a:p>
+        </p:txBody>
+      </p:sp>
+      <p:sp>
+        <p:nvSpPr>
+          <p:cNvPr id="5" name="TextBox 4"/>
           <p:cNvSpPr txBox="1"/>
           <p:nvPr/>
         </p:nvSpPr>
         <p:spPr>
           <a:xfrm>
-            <a:off x="5120640" y="1463040"/>
-            <a:ext cx="6309360" cy="4754880"/>
+            <a:off x="5285232" y="1371600"/>
+            <a:ext cx="6144768" cy="960120"/>
           </a:xfrm>
           <a:prstGeom prst="rect">
             <a:avLst/>
@@ -3190,9 +3234,9 @@
           <a:p>
             <a:pPr>
               <a:spcAft>
-                <a:spcPts val="400"/>
+                <a:spcPts val="300"/>
               </a:spcAft>
-              <a:defRPr b="1" i="0" sz="2600">
+              <a:defRPr b="1" sz="2400">
                 <a:solidFill>
                   <a:srgbClr val="0F172A"/>
                 </a:solidFill>
@@ -3205,10 +3249,89 @@
           </a:p>
           <a:p>
             <a:pPr>
+              <a:defRPr i="1" sz="2400">
+                <a:solidFill>
+                  <a:srgbClr val="0F172A"/>
+                </a:solidFill>
+                <a:latin typeface="Montserrat"/>
+              </a:defRPr>
+            </a:pPr>
+            <a:r>
+              <a:t>was constructed / had been demolished</a:t>
+            </a:r>
+          </a:p>
+        </p:txBody>
+      </p:sp>
+      <p:sp>
+        <p:nvSpPr>
+          <p:cNvPr id="6" name="Rectangle 5"/>
+          <p:cNvSpPr/>
+          <p:nvPr/>
+        </p:nvSpPr>
+        <p:spPr>
+          <a:xfrm>
+            <a:off x="5120640" y="2560320"/>
+            <a:ext cx="45720" cy="960120"/>
+          </a:xfrm>
+          <a:prstGeom prst="rect">
+            <a:avLst/>
+          </a:prstGeom>
+          <a:solidFill>
+            <a:srgbClr val="DC2626"/>
+          </a:solidFill>
+          <a:ln>
+            <a:noFill/>
+          </a:ln>
+        </p:spPr>
+        <p:style>
+          <a:lnRef idx="1">
+            <a:schemeClr val="accent1"/>
+          </a:lnRef>
+          <a:fillRef idx="3">
+            <a:schemeClr val="accent1"/>
+          </a:fillRef>
+          <a:effectRef idx="2">
+            <a:schemeClr val="accent1"/>
+          </a:effectRef>
+          <a:fontRef idx="minor">
+            <a:schemeClr val="lt1"/>
+          </a:fontRef>
+        </p:style>
+        <p:txBody>
+          <a:bodyPr rtlCol="0" anchor="ctr"/>
+          <a:lstStyle/>
+          <a:p>
+            <a:pPr algn="ctr"/>
+          </a:p>
+        </p:txBody>
+      </p:sp>
+      <p:sp>
+        <p:nvSpPr>
+          <p:cNvPr id="7" name="TextBox 6"/>
+          <p:cNvSpPr txBox="1"/>
+          <p:nvPr/>
+        </p:nvSpPr>
+        <p:spPr>
+          <a:xfrm>
+            <a:off x="5285232" y="2560320"/>
+            <a:ext cx="6144768" cy="960120"/>
+          </a:xfrm>
+          <a:prstGeom prst="rect">
+            <a:avLst/>
+          </a:prstGeom>
+          <a:noFill/>
+        </p:spPr>
+        <p:txBody>
+          <a:bodyPr wrap="square" lIns="0" tIns="0" rIns="0" bIns="0">
+            <a:spAutoFit/>
+          </a:bodyPr>
+          <a:lstStyle/>
+          <a:p>
+            <a:pPr>
               <a:spcAft>
-                <a:spcPts val="1800"/>
+                <a:spcPts val="300"/>
               </a:spcAft>
-              <a:defRPr b="0" i="1" sz="2400">
+              <a:defRPr b="1" sz="2400">
                 <a:solidFill>
                   <a:srgbClr val="0F172A"/>
                 </a:solidFill>
@@ -3216,15 +3339,94 @@
               </a:defRPr>
             </a:pPr>
             <a:r>
-              <a:t>was constructed / had been demolished</a:t>
-            </a:r>
-          </a:p>
+              <a:t>QUÁ KHỨ ➔ HIỆN TẠI (20 YEARS AGO - TODAY)</a:t>
+            </a:r>
+          </a:p>
+          <a:p>
+            <a:pPr>
+              <a:defRPr i="1" sz="2400">
+                <a:solidFill>
+                  <a:srgbClr val="0F172A"/>
+                </a:solidFill>
+                <a:latin typeface="Montserrat"/>
+              </a:defRPr>
+            </a:pPr>
+            <a:r>
+              <a:t>has been converted into / have been removed</a:t>
+            </a:r>
+          </a:p>
+        </p:txBody>
+      </p:sp>
+      <p:sp>
+        <p:nvSpPr>
+          <p:cNvPr id="8" name="Rectangle 7"/>
+          <p:cNvSpPr/>
+          <p:nvPr/>
+        </p:nvSpPr>
+        <p:spPr>
+          <a:xfrm>
+            <a:off x="5120640" y="3749039"/>
+            <a:ext cx="45720" cy="960120"/>
+          </a:xfrm>
+          <a:prstGeom prst="rect">
+            <a:avLst/>
+          </a:prstGeom>
+          <a:solidFill>
+            <a:srgbClr val="DC2626"/>
+          </a:solidFill>
+          <a:ln>
+            <a:noFill/>
+          </a:ln>
+        </p:spPr>
+        <p:style>
+          <a:lnRef idx="1">
+            <a:schemeClr val="accent1"/>
+          </a:lnRef>
+          <a:fillRef idx="3">
+            <a:schemeClr val="accent1"/>
+          </a:fillRef>
+          <a:effectRef idx="2">
+            <a:schemeClr val="accent1"/>
+          </a:effectRef>
+          <a:fontRef idx="minor">
+            <a:schemeClr val="lt1"/>
+          </a:fontRef>
+        </p:style>
+        <p:txBody>
+          <a:bodyPr rtlCol="0" anchor="ctr"/>
+          <a:lstStyle/>
+          <a:p>
+            <a:pPr algn="ctr"/>
+          </a:p>
+        </p:txBody>
+      </p:sp>
+      <p:sp>
+        <p:nvSpPr>
+          <p:cNvPr id="9" name="TextBox 8"/>
+          <p:cNvSpPr txBox="1"/>
+          <p:nvPr/>
+        </p:nvSpPr>
+        <p:spPr>
+          <a:xfrm>
+            <a:off x="5285232" y="3749039"/>
+            <a:ext cx="6144768" cy="960120"/>
+          </a:xfrm>
+          <a:prstGeom prst="rect">
+            <a:avLst/>
+          </a:prstGeom>
+          <a:noFill/>
+        </p:spPr>
+        <p:txBody>
+          <a:bodyPr wrap="square" lIns="0" tIns="0" rIns="0" bIns="0">
+            <a:spAutoFit/>
+          </a:bodyPr>
+          <a:lstStyle/>
           <a:p>
             <a:pPr>
               <a:spcAft>
-                <a:spcPts val="400"/>
+                <a:spcPts val="300"/>
               </a:spcAft>
-              <a:defRPr b="1" i="0" sz="2600">
+              <a:defRPr b="1" sz="2400">
                 <a:solidFill>
                   <a:srgbClr val="0F172A"/>
                 </a:solidFill>
@@ -3232,15 +3434,94 @@
               </a:defRPr>
             </a:pPr>
             <a:r>
-              <a:t>QUÁ KHỨ ➔ HIỆN TẠI (20 YEARS AGO - TODAY)</a:t>
-            </a:r>
-          </a:p>
+              <a:t>HIỆN TẠI ➔ TƯƠNG LAI (NOW - 2035)</a:t>
+            </a:r>
+          </a:p>
+          <a:p>
+            <a:pPr>
+              <a:defRPr i="1" sz="2400">
+                <a:solidFill>
+                  <a:srgbClr val="0F172A"/>
+                </a:solidFill>
+                <a:latin typeface="Montserrat"/>
+              </a:defRPr>
+            </a:pPr>
+            <a:r>
+              <a:t>is planned to be built / is projected to be converted</a:t>
+            </a:r>
+          </a:p>
+        </p:txBody>
+      </p:sp>
+      <p:sp>
+        <p:nvSpPr>
+          <p:cNvPr id="10" name="Rectangle 9"/>
+          <p:cNvSpPr/>
+          <p:nvPr/>
+        </p:nvSpPr>
+        <p:spPr>
+          <a:xfrm>
+            <a:off x="5120640" y="4937760"/>
+            <a:ext cx="45720" cy="960120"/>
+          </a:xfrm>
+          <a:prstGeom prst="rect">
+            <a:avLst/>
+          </a:prstGeom>
+          <a:solidFill>
+            <a:srgbClr val="DC2626"/>
+          </a:solidFill>
+          <a:ln>
+            <a:noFill/>
+          </a:ln>
+        </p:spPr>
+        <p:style>
+          <a:lnRef idx="1">
+            <a:schemeClr val="accent1"/>
+          </a:lnRef>
+          <a:fillRef idx="3">
+            <a:schemeClr val="accent1"/>
+          </a:fillRef>
+          <a:effectRef idx="2">
+            <a:schemeClr val="accent1"/>
+          </a:effectRef>
+          <a:fontRef idx="minor">
+            <a:schemeClr val="lt1"/>
+          </a:fontRef>
+        </p:style>
+        <p:txBody>
+          <a:bodyPr rtlCol="0" anchor="ctr"/>
+          <a:lstStyle/>
+          <a:p>
+            <a:pPr algn="ctr"/>
+          </a:p>
+        </p:txBody>
+      </p:sp>
+      <p:sp>
+        <p:nvSpPr>
+          <p:cNvPr id="11" name="TextBox 10"/>
+          <p:cNvSpPr txBox="1"/>
+          <p:nvPr/>
+        </p:nvSpPr>
+        <p:spPr>
+          <a:xfrm>
+            <a:off x="5285232" y="4937760"/>
+            <a:ext cx="6144768" cy="960120"/>
+          </a:xfrm>
+          <a:prstGeom prst="rect">
+            <a:avLst/>
+          </a:prstGeom>
+          <a:noFill/>
+        </p:spPr>
+        <p:txBody>
+          <a:bodyPr wrap="square" lIns="0" tIns="0" rIns="0" bIns="0">
+            <a:spAutoFit/>
+          </a:bodyPr>
+          <a:lstStyle/>
           <a:p>
             <a:pPr>
               <a:spcAft>
-                <a:spcPts val="1800"/>
+                <a:spcPts val="300"/>
               </a:spcAft>
-              <a:defRPr b="0" i="1" sz="2400">
+              <a:defRPr b="1" sz="2400">
                 <a:solidFill>
                   <a:srgbClr val="0F172A"/>
                 </a:solidFill>
@@ -3248,63 +3529,12 @@
               </a:defRPr>
             </a:pPr>
             <a:r>
-              <a:t>has been converted into / have been removed</a:t>
-            </a:r>
-          </a:p>
-          <a:p>
-            <a:pPr>
-              <a:spcAft>
-                <a:spcPts val="400"/>
-              </a:spcAft>
-              <a:defRPr b="1" i="0" sz="2600">
-                <a:solidFill>
-                  <a:srgbClr val="0F172A"/>
-                </a:solidFill>
-                <a:latin typeface="Montserrat"/>
-              </a:defRPr>
-            </a:pPr>
-            <a:r>
-              <a:t>HIỆN TẠI ➔ TƯƠNG LAI (NOW - 2035)</a:t>
-            </a:r>
-          </a:p>
-          <a:p>
-            <a:pPr>
-              <a:spcAft>
-                <a:spcPts val="1800"/>
-              </a:spcAft>
-              <a:defRPr b="0" i="1" sz="2400">
-                <a:solidFill>
-                  <a:srgbClr val="0F172A"/>
-                </a:solidFill>
-                <a:latin typeface="Montserrat"/>
-              </a:defRPr>
-            </a:pPr>
-            <a:r>
-              <a:t>is planned to be built / is projected to be converted</a:t>
-            </a:r>
-          </a:p>
-          <a:p>
-            <a:pPr>
-              <a:spcAft>
-                <a:spcPts val="400"/>
-              </a:spcAft>
-              <a:defRPr b="1" i="0" sz="2600">
-                <a:solidFill>
-                  <a:srgbClr val="0F172A"/>
-                </a:solidFill>
-                <a:latin typeface="Montserrat"/>
-              </a:defRPr>
-            </a:pPr>
-            <a:r>
               <a:t>STATIC MAP (SO SÁNH 2 VỊ TRÍ S1 VS S2)</a:t>
             </a:r>
           </a:p>
           <a:p>
             <a:pPr>
-              <a:spcAft>
-                <a:spcPts val="0"/>
-              </a:spcAft>
-              <a:defRPr b="0" i="1" sz="2400">
+              <a:defRPr i="1" sz="2400">
                 <a:solidFill>
                   <a:srgbClr val="0F172A"/>
                 </a:solidFill>
@@ -3351,8 +3581,8 @@
         </p:nvSpPr>
         <p:spPr>
           <a:xfrm>
-            <a:off x="731520" y="457200"/>
-            <a:ext cx="10728655" cy="731520"/>
+            <a:off x="731520" y="411480"/>
+            <a:ext cx="10728655" cy="685800"/>
           </a:xfrm>
           <a:prstGeom prst="rect">
             <a:avLst/>
@@ -3366,7 +3596,7 @@
           <a:lstStyle/>
           <a:p>
             <a:pPr>
-              <a:defRPr sz="3400" b="1">
+              <a:defRPr sz="3200" b="1">
                 <a:solidFill>
                   <a:srgbClr val="7C3AED"/>
                 </a:solidFill>
@@ -3395,8 +3625,8 @@
         </p:blipFill>
         <p:spPr>
           <a:xfrm>
-            <a:off x="731520" y="1463040"/>
-            <a:ext cx="3931920" cy="2057800"/>
+            <a:off x="731520" y="1371600"/>
+            <a:ext cx="4023360" cy="2105656"/>
           </a:xfrm>
           <a:prstGeom prst="rect">
             <a:avLst/>
@@ -3405,14 +3635,57 @@
       </p:pic>
       <p:sp>
         <p:nvSpPr>
-          <p:cNvPr id="4" name="TextBox 3"/>
+          <p:cNvPr id="4" name="Rectangle 3"/>
+          <p:cNvSpPr/>
+          <p:nvPr/>
+        </p:nvSpPr>
+        <p:spPr>
+          <a:xfrm>
+            <a:off x="5120640" y="1371600"/>
+            <a:ext cx="45720" cy="2011680"/>
+          </a:xfrm>
+          <a:prstGeom prst="rect">
+            <a:avLst/>
+          </a:prstGeom>
+          <a:solidFill>
+            <a:srgbClr val="7C3AED"/>
+          </a:solidFill>
+          <a:ln>
+            <a:noFill/>
+          </a:ln>
+        </p:spPr>
+        <p:style>
+          <a:lnRef idx="1">
+            <a:schemeClr val="accent1"/>
+          </a:lnRef>
+          <a:fillRef idx="3">
+            <a:schemeClr val="accent1"/>
+          </a:fillRef>
+          <a:effectRef idx="2">
+            <a:schemeClr val="accent1"/>
+          </a:effectRef>
+          <a:fontRef idx="minor">
+            <a:schemeClr val="lt1"/>
+          </a:fontRef>
+        </p:style>
+        <p:txBody>
+          <a:bodyPr rtlCol="0" anchor="ctr"/>
+          <a:lstStyle/>
+          <a:p>
+            <a:pPr algn="ctr"/>
+          </a:p>
+        </p:txBody>
+      </p:sp>
+      <p:sp>
+        <p:nvSpPr>
+          <p:cNvPr id="5" name="TextBox 4"/>
           <p:cNvSpPr txBox="1"/>
           <p:nvPr/>
         </p:nvSpPr>
         <p:spPr>
           <a:xfrm>
-            <a:off x="4937760" y="1463040"/>
-            <a:ext cx="6492240" cy="4754880"/>
+            <a:off x="5285232" y="1371600"/>
+            <a:ext cx="6144768" cy="2011680"/>
           </a:xfrm>
           <a:prstGeom prst="rect">
             <a:avLst/>
@@ -3427,9 +3700,9 @@
           <a:p>
             <a:pPr>
               <a:spcAft>
-                <a:spcPts val="400"/>
+                <a:spcPts val="300"/>
               </a:spcAft>
-              <a:defRPr b="1" i="0" sz="2600">
+              <a:defRPr b="1" sz="2400">
                 <a:solidFill>
                   <a:srgbClr val="0F172A"/>
                 </a:solidFill>
@@ -3442,10 +3715,97 @@
           </a:p>
           <a:p>
             <a:pPr>
+              <a:defRPr i="1" sz="2400">
+                <a:solidFill>
+                  <a:srgbClr val="0F172A"/>
+                </a:solidFill>
+                <a:latin typeface="Montserrat"/>
+              </a:defRPr>
+            </a:pPr>
+            <a:r>
+              <a:t>River Stoke and bridge remained unchanged.</a:t>
+            </a:r>
+            <a:br/>
+            <a:r>
+              <a:t>Farmland in north-east was cleared for new housing.</a:t>
+            </a:r>
+            <a:br/>
+            <a:r>
+              <a:t>Post office stayed intact, while shops were replaced by houses.</a:t>
+            </a:r>
+          </a:p>
+        </p:txBody>
+      </p:sp>
+      <p:sp>
+        <p:nvSpPr>
+          <p:cNvPr id="6" name="Rectangle 5"/>
+          <p:cNvSpPr/>
+          <p:nvPr/>
+        </p:nvSpPr>
+        <p:spPr>
+          <a:xfrm>
+            <a:off x="5120640" y="3657600"/>
+            <a:ext cx="45720" cy="2011680"/>
+          </a:xfrm>
+          <a:prstGeom prst="rect">
+            <a:avLst/>
+          </a:prstGeom>
+          <a:solidFill>
+            <a:srgbClr val="7C3AED"/>
+          </a:solidFill>
+          <a:ln>
+            <a:noFill/>
+          </a:ln>
+        </p:spPr>
+        <p:style>
+          <a:lnRef idx="1">
+            <a:schemeClr val="accent1"/>
+          </a:lnRef>
+          <a:fillRef idx="3">
+            <a:schemeClr val="accent1"/>
+          </a:fillRef>
+          <a:effectRef idx="2">
+            <a:schemeClr val="accent1"/>
+          </a:effectRef>
+          <a:fontRef idx="minor">
+            <a:schemeClr val="lt1"/>
+          </a:fontRef>
+        </p:style>
+        <p:txBody>
+          <a:bodyPr rtlCol="0" anchor="ctr"/>
+          <a:lstStyle/>
+          <a:p>
+            <a:pPr algn="ctr"/>
+          </a:p>
+        </p:txBody>
+      </p:sp>
+      <p:sp>
+        <p:nvSpPr>
+          <p:cNvPr id="7" name="TextBox 6"/>
+          <p:cNvSpPr txBox="1"/>
+          <p:nvPr/>
+        </p:nvSpPr>
+        <p:spPr>
+          <a:xfrm>
+            <a:off x="5285232" y="3657600"/>
+            <a:ext cx="6144768" cy="2011680"/>
+          </a:xfrm>
+          <a:prstGeom prst="rect">
+            <a:avLst/>
+          </a:prstGeom>
+          <a:noFill/>
+        </p:spPr>
+        <p:txBody>
+          <a:bodyPr wrap="square" lIns="0" tIns="0" rIns="0" bIns="0">
+            <a:spAutoFit/>
+          </a:bodyPr>
+          <a:lstStyle/>
+          <a:p>
+            <a:pPr>
               <a:spcAft>
-                <a:spcPts val="400"/>
+                <a:spcPts val="300"/>
               </a:spcAft>
-              <a:defRPr b="1" i="1" sz="2400">
+              <a:defRPr b="1" sz="2400">
                 <a:solidFill>
                   <a:srgbClr val="0F172A"/>
                 </a:solidFill>
@@ -3453,15 +3813,12 @@
               </a:defRPr>
             </a:pPr>
             <a:r>
-              <a:t>River Stoke and bridge remained unchanged.</a:t>
-            </a:r>
-          </a:p>
-          <a:p>
-            <a:pPr>
-              <a:spcAft>
-                <a:spcPts val="400"/>
-              </a:spcAft>
-              <a:defRPr b="0" i="1" sz="2400">
+              <a:t>BODY 2 ➔ NỬA PHÍA NAM</a:t>
+            </a:r>
+          </a:p>
+          <a:p>
+            <a:pPr>
+              <a:defRPr i="1" sz="2400">
                 <a:solidFill>
                   <a:srgbClr val="0F172A"/>
                 </a:solidFill>
@@ -3469,85 +3826,13 @@
               </a:defRPr>
             </a:pPr>
             <a:r>
-              <a:t>Farmland in north-east was cleared to make way for new roads lined with houses.</a:t>
-            </a:r>
-          </a:p>
-          <a:p>
-            <a:pPr>
-              <a:spcAft>
-                <a:spcPts val="1800"/>
-              </a:spcAft>
-              <a:defRPr b="0" i="1" sz="2400">
-                <a:solidFill>
-                  <a:srgbClr val="0F172A"/>
-                </a:solidFill>
-                <a:latin typeface="Montserrat"/>
-              </a:defRPr>
-            </a:pPr>
-            <a:r>
-              <a:t>Post office stayed intact, while adjacent shops were replaced by houses.</a:t>
-            </a:r>
-          </a:p>
-          <a:p>
-            <a:pPr>
-              <a:spcAft>
-                <a:spcPts val="400"/>
-              </a:spcAft>
-              <a:defRPr b="1" i="0" sz="2600">
-                <a:solidFill>
-                  <a:srgbClr val="0F172A"/>
-                </a:solidFill>
-                <a:latin typeface="Montserrat"/>
-              </a:defRPr>
-            </a:pPr>
-            <a:r>
-              <a:t>BODY 2 ➔ NỬA PHÍA NAM</a:t>
-            </a:r>
-          </a:p>
-          <a:p>
-            <a:pPr>
-              <a:spcAft>
-                <a:spcPts val="400"/>
-              </a:spcAft>
-              <a:defRPr b="0" i="1" sz="2400">
-                <a:solidFill>
-                  <a:srgbClr val="0F172A"/>
-                </a:solidFill>
-                <a:latin typeface="Montserrat"/>
-              </a:defRPr>
-            </a:pPr>
-            <a:r>
-              <a:t>Primary school located to the east of road was significantly extended.</a:t>
-            </a:r>
-          </a:p>
-          <a:p>
-            <a:pPr>
-              <a:spcAft>
-                <a:spcPts val="400"/>
-              </a:spcAft>
-              <a:defRPr b="0" i="1" sz="2400">
-                <a:solidFill>
-                  <a:srgbClr val="0F172A"/>
-                </a:solidFill>
-                <a:latin typeface="Montserrat"/>
-              </a:defRPr>
-            </a:pPr>
-            <a:r>
-              <a:t>Large house was converted into a retirement home at expense of gardens.</a:t>
-            </a:r>
-          </a:p>
-          <a:p>
-            <a:pPr>
-              <a:spcAft>
-                <a:spcPts val="0"/>
-              </a:spcAft>
-              <a:defRPr b="0" i="1" sz="2400">
-                <a:solidFill>
-                  <a:srgbClr val="0F172A"/>
-                </a:solidFill>
-                <a:latin typeface="Montserrat"/>
-              </a:defRPr>
-            </a:pPr>
+              <a:t>Primary school to the east of road was significantly extended.</a:t>
+            </a:r>
+            <a:br/>
+            <a:r>
+              <a:t>Large house became a retirement home at expense of gardens.</a:t>
+            </a:r>
+            <a:br/>
             <a:r>
               <a:t>Farmland in south-west gave way to new houses.</a:t>
             </a:r>
@@ -3588,8 +3873,8 @@
         </p:nvSpPr>
         <p:spPr>
           <a:xfrm>
-            <a:off x="731520" y="457200"/>
-            <a:ext cx="10728655" cy="731520"/>
+            <a:off x="731520" y="411480"/>
+            <a:ext cx="10728655" cy="685800"/>
           </a:xfrm>
           <a:prstGeom prst="rect">
             <a:avLst/>
@@ -3603,7 +3888,7 @@
           <a:lstStyle/>
           <a:p>
             <a:pPr>
-              <a:defRPr sz="3400" b="1">
+              <a:defRPr sz="3200" b="1">
                 <a:solidFill>
                   <a:srgbClr val="EA580C"/>
                 </a:solidFill>
@@ -3611,7 +3896,7 @@
               </a:defRPr>
             </a:pPr>
             <a:r>
-              <a:t>📚 ĐỀ THI THẬT #2: THƯ VIỆN (CAMBRIDGE 18)</a:t>
+              <a:t>📚 ĐỀ THI THẬT #2: THƯ VIỆN (CAMBRIDGE 18) - P1</a:t>
             </a:r>
           </a:p>
         </p:txBody>
@@ -3632,7 +3917,7 @@
         </p:blipFill>
         <p:spPr>
           <a:xfrm>
-            <a:off x="731520" y="1463040"/>
+            <a:off x="731520" y="1371600"/>
             <a:ext cx="4023360" cy="4571064"/>
           </a:xfrm>
           <a:prstGeom prst="rect">
@@ -3642,14 +3927,57 @@
       </p:pic>
       <p:sp>
         <p:nvSpPr>
-          <p:cNvPr id="4" name="TextBox 3"/>
+          <p:cNvPr id="4" name="Rectangle 3"/>
+          <p:cNvSpPr/>
+          <p:nvPr/>
+        </p:nvSpPr>
+        <p:spPr>
+          <a:xfrm>
+            <a:off x="5120640" y="1371600"/>
+            <a:ext cx="45720" cy="1737360"/>
+          </a:xfrm>
+          <a:prstGeom prst="rect">
+            <a:avLst/>
+          </a:prstGeom>
+          <a:solidFill>
+            <a:srgbClr val="EA580C"/>
+          </a:solidFill>
+          <a:ln>
+            <a:noFill/>
+          </a:ln>
+        </p:spPr>
+        <p:style>
+          <a:lnRef idx="1">
+            <a:schemeClr val="accent1"/>
+          </a:lnRef>
+          <a:fillRef idx="3">
+            <a:schemeClr val="accent1"/>
+          </a:fillRef>
+          <a:effectRef idx="2">
+            <a:schemeClr val="accent1"/>
+          </a:effectRef>
+          <a:fontRef idx="minor">
+            <a:schemeClr val="lt1"/>
+          </a:fontRef>
+        </p:style>
+        <p:txBody>
+          <a:bodyPr rtlCol="0" anchor="ctr"/>
+          <a:lstStyle/>
+          <a:p>
+            <a:pPr algn="ctr"/>
+          </a:p>
+        </p:txBody>
+      </p:sp>
+      <p:sp>
+        <p:nvSpPr>
+          <p:cNvPr id="5" name="TextBox 4"/>
           <p:cNvSpPr txBox="1"/>
           <p:nvPr/>
         </p:nvSpPr>
         <p:spPr>
           <a:xfrm>
-            <a:off x="5029200" y="1463040"/>
-            <a:ext cx="6400800" cy="4754880"/>
+            <a:off x="5285232" y="1371600"/>
+            <a:ext cx="6144768" cy="1737360"/>
           </a:xfrm>
           <a:prstGeom prst="rect">
             <a:avLst/>
@@ -3664,9 +3992,9 @@
           <a:p>
             <a:pPr>
               <a:spcAft>
-                <a:spcPts val="400"/>
+                <a:spcPts val="300"/>
               </a:spcAft>
-              <a:defRPr b="1" i="0" sz="2600">
+              <a:defRPr b="1" sz="2400">
                 <a:solidFill>
                   <a:srgbClr val="0F172A"/>
                 </a:solidFill>
@@ -3679,10 +4007,89 @@
           </a:p>
           <a:p>
             <a:pPr>
+              <a:defRPr i="1" sz="2400">
+                <a:solidFill>
+                  <a:srgbClr val="0F172A"/>
+                </a:solidFill>
+                <a:latin typeface="Montserrat"/>
+              </a:defRPr>
+            </a:pPr>
+            <a:r>
+              <a:t>The library has been significantly modernized, while the central tables and chairs have been completely removed.</a:t>
+            </a:r>
+          </a:p>
+        </p:txBody>
+      </p:sp>
+      <p:sp>
+        <p:nvSpPr>
+          <p:cNvPr id="6" name="Rectangle 5"/>
+          <p:cNvSpPr/>
+          <p:nvPr/>
+        </p:nvSpPr>
+        <p:spPr>
+          <a:xfrm>
+            <a:off x="5120640" y="3474720"/>
+            <a:ext cx="45720" cy="2011680"/>
+          </a:xfrm>
+          <a:prstGeom prst="rect">
+            <a:avLst/>
+          </a:prstGeom>
+          <a:solidFill>
+            <a:srgbClr val="EA580C"/>
+          </a:solidFill>
+          <a:ln>
+            <a:noFill/>
+          </a:ln>
+        </p:spPr>
+        <p:style>
+          <a:lnRef idx="1">
+            <a:schemeClr val="accent1"/>
+          </a:lnRef>
+          <a:fillRef idx="3">
+            <a:schemeClr val="accent1"/>
+          </a:fillRef>
+          <a:effectRef idx="2">
+            <a:schemeClr val="accent1"/>
+          </a:effectRef>
+          <a:fontRef idx="minor">
+            <a:schemeClr val="lt1"/>
+          </a:fontRef>
+        </p:style>
+        <p:txBody>
+          <a:bodyPr rtlCol="0" anchor="ctr"/>
+          <a:lstStyle/>
+          <a:p>
+            <a:pPr algn="ctr"/>
+          </a:p>
+        </p:txBody>
+      </p:sp>
+      <p:sp>
+        <p:nvSpPr>
+          <p:cNvPr id="7" name="TextBox 6"/>
+          <p:cNvSpPr txBox="1"/>
+          <p:nvPr/>
+        </p:nvSpPr>
+        <p:spPr>
+          <a:xfrm>
+            <a:off x="5285232" y="3474720"/>
+            <a:ext cx="6144768" cy="2011680"/>
+          </a:xfrm>
+          <a:prstGeom prst="rect">
+            <a:avLst/>
+          </a:prstGeom>
+          <a:noFill/>
+        </p:spPr>
+        <p:txBody>
+          <a:bodyPr wrap="square" lIns="0" tIns="0" rIns="0" bIns="0">
+            <a:spAutoFit/>
+          </a:bodyPr>
+          <a:lstStyle/>
+          <a:p>
+            <a:pPr>
               <a:spcAft>
-                <a:spcPts val="1800"/>
+                <a:spcPts val="300"/>
               </a:spcAft>
-              <a:defRPr b="0" i="1" sz="2400">
+              <a:defRPr b="1" sz="2400">
                 <a:solidFill>
                   <a:srgbClr val="0F172A"/>
                 </a:solidFill>
@@ -3690,15 +4097,188 @@
               </a:defRPr>
             </a:pPr>
             <a:r>
-              <a:t>The library has been modernized, while central tables have been removed.</a:t>
-            </a:r>
-          </a:p>
+              <a:t>BODY 1 ➔ LỐI VÀO VÀ TRUNG TÂM</a:t>
+            </a:r>
+          </a:p>
+          <a:p>
+            <a:pPr>
+              <a:defRPr i="1" sz="2400">
+                <a:solidFill>
+                  <a:srgbClr val="0F172A"/>
+                </a:solidFill>
+                <a:latin typeface="Montserrat"/>
+              </a:defRPr>
+            </a:pPr>
+            <a:r>
+              <a:t>Main entrance has remained in the same location.</a:t>
+            </a:r>
+            <a:br/>
+            <a:r>
+              <a:t>Reading room has been replaced by a computer room.</a:t>
+            </a:r>
+            <a:br/>
+            <a:r>
+              <a:t>Enquiry desk has given way to a café and self-service machines.</a:t>
+            </a:r>
+          </a:p>
+        </p:txBody>
+      </p:sp>
+    </p:spTree>
+  </p:cSld>
+  <p:clrMapOvr>
+    <a:masterClrMapping/>
+  </p:clrMapOvr>
+</p:sld>
+</file>
+
+<file path=ppt/slides/slide12.xml><?xml version="1.0" encoding="utf-8"?>
+<p:sld xmlns:a="http://schemas.openxmlformats.org/drawingml/2006/main" xmlns:p="http://schemas.openxmlformats.org/presentationml/2006/main" xmlns:r="http://schemas.openxmlformats.org/officeDocument/2006/relationships">
+  <p:cSld>
+    <p:bg>
+      <p:bgPr>
+        <a:solidFill>
+          <a:srgbClr val="FFFFFF"/>
+        </a:solidFill>
+        <a:effectLst/>
+      </p:bgPr>
+    </p:bg>
+    <p:spTree>
+      <p:nvGrpSpPr>
+        <p:cNvPr id="1" name=""/>
+        <p:cNvGrpSpPr/>
+        <p:nvPr/>
+      </p:nvGrpSpPr>
+      <p:grpSpPr/>
+      <p:sp>
+        <p:nvSpPr>
+          <p:cNvPr id="2" name="TextBox 1"/>
+          <p:cNvSpPr txBox="1"/>
+          <p:nvPr/>
+        </p:nvSpPr>
+        <p:spPr>
+          <a:xfrm>
+            <a:off x="731520" y="411480"/>
+            <a:ext cx="10728655" cy="685800"/>
+          </a:xfrm>
+          <a:prstGeom prst="rect">
+            <a:avLst/>
+          </a:prstGeom>
+          <a:noFill/>
+        </p:spPr>
+        <p:txBody>
+          <a:bodyPr wrap="square" lIns="0" tIns="0" rIns="0" bIns="0">
+            <a:spAutoFit/>
+          </a:bodyPr>
+          <a:lstStyle/>
+          <a:p>
+            <a:pPr>
+              <a:defRPr sz="3200" b="1">
+                <a:solidFill>
+                  <a:srgbClr val="DB2777"/>
+                </a:solidFill>
+                <a:latin typeface="Montserrat"/>
+              </a:defRPr>
+            </a:pPr>
+            <a:r>
+              <a:t>📚 ĐỀ THI THẬT #2: THƯ VIỆN (CAMBRIDGE 18) - P2</a:t>
+            </a:r>
+          </a:p>
+        </p:txBody>
+      </p:sp>
+      <p:pic>
+        <p:nvPicPr>
+          <p:cNvPr id="3" name="Picture 2" descr="cambridge_18_library_floorplan.png"/>
+          <p:cNvPicPr>
+            <a:picLocks noChangeAspect="1"/>
+          </p:cNvPicPr>
+          <p:nvPr/>
+        </p:nvPicPr>
+        <p:blipFill>
+          <a:blip r:embed="rId2"/>
+          <a:stretch>
+            <a:fillRect/>
+          </a:stretch>
+        </p:blipFill>
+        <p:spPr>
+          <a:xfrm>
+            <a:off x="731520" y="1371600"/>
+            <a:ext cx="4023360" cy="4571064"/>
+          </a:xfrm>
+          <a:prstGeom prst="rect">
+            <a:avLst/>
+          </a:prstGeom>
+        </p:spPr>
+      </p:pic>
+      <p:sp>
+        <p:nvSpPr>
+          <p:cNvPr id="4" name="Rectangle 3"/>
+          <p:cNvSpPr/>
+          <p:nvPr/>
+        </p:nvSpPr>
+        <p:spPr>
+          <a:xfrm>
+            <a:off x="5120640" y="1371600"/>
+            <a:ext cx="45720" cy="2011680"/>
+          </a:xfrm>
+          <a:prstGeom prst="rect">
+            <a:avLst/>
+          </a:prstGeom>
+          <a:solidFill>
+            <a:srgbClr val="DB2777"/>
+          </a:solidFill>
+          <a:ln>
+            <a:noFill/>
+          </a:ln>
+        </p:spPr>
+        <p:style>
+          <a:lnRef idx="1">
+            <a:schemeClr val="accent1"/>
+          </a:lnRef>
+          <a:fillRef idx="3">
+            <a:schemeClr val="accent1"/>
+          </a:fillRef>
+          <a:effectRef idx="2">
+            <a:schemeClr val="accent1"/>
+          </a:effectRef>
+          <a:fontRef idx="minor">
+            <a:schemeClr val="lt1"/>
+          </a:fontRef>
+        </p:style>
+        <p:txBody>
+          <a:bodyPr rtlCol="0" anchor="ctr"/>
+          <a:lstStyle/>
+          <a:p>
+            <a:pPr algn="ctr"/>
+          </a:p>
+        </p:txBody>
+      </p:sp>
+      <p:sp>
+        <p:nvSpPr>
+          <p:cNvPr id="5" name="TextBox 4"/>
+          <p:cNvSpPr txBox="1"/>
+          <p:nvPr/>
+        </p:nvSpPr>
+        <p:spPr>
+          <a:xfrm>
+            <a:off x="5285232" y="1371600"/>
+            <a:ext cx="6144768" cy="2011680"/>
+          </a:xfrm>
+          <a:prstGeom prst="rect">
+            <a:avLst/>
+          </a:prstGeom>
+          <a:noFill/>
+        </p:spPr>
+        <p:txBody>
+          <a:bodyPr wrap="square" lIns="0" tIns="0" rIns="0" bIns="0">
+            <a:spAutoFit/>
+          </a:bodyPr>
+          <a:lstStyle/>
           <a:p>
             <a:pPr>
               <a:spcAft>
-                <a:spcPts val="400"/>
+                <a:spcPts val="300"/>
               </a:spcAft>
-              <a:defRPr b="1" i="0" sz="2600">
+              <a:defRPr b="1" sz="2400">
                 <a:solidFill>
                   <a:srgbClr val="0F172A"/>
                 </a:solidFill>
@@ -3706,15 +4286,98 @@
               </a:defRPr>
             </a:pPr>
             <a:r>
-              <a:t>BODY 1 ➔ LỐI VÀO VÀ TRUNG TÂM</a:t>
-            </a:r>
-          </a:p>
+              <a:t>BODY 2 ➔ CÁC GÓC CUỐI THƯ VIỆN</a:t>
+            </a:r>
+          </a:p>
+          <a:p>
+            <a:pPr>
+              <a:defRPr i="1" sz="2400">
+                <a:solidFill>
+                  <a:srgbClr val="0F172A"/>
+                </a:solidFill>
+                <a:latin typeface="Montserrat"/>
+              </a:defRPr>
+            </a:pPr>
+            <a:r>
+              <a:t>Room in top-left corner has been enlarged and converted into a storytelling space equipped with sofas.</a:t>
+            </a:r>
+            <a:br/>
+            <a:r>
+              <a:t>Former children's book area has been turned into a lecture room.</a:t>
+            </a:r>
+          </a:p>
+        </p:txBody>
+      </p:sp>
+      <p:sp>
+        <p:nvSpPr>
+          <p:cNvPr id="6" name="Rectangle 5"/>
+          <p:cNvSpPr/>
+          <p:nvPr/>
+        </p:nvSpPr>
+        <p:spPr>
+          <a:xfrm>
+            <a:off x="5120640" y="3657600"/>
+            <a:ext cx="45720" cy="1737360"/>
+          </a:xfrm>
+          <a:prstGeom prst="rect">
+            <a:avLst/>
+          </a:prstGeom>
+          <a:solidFill>
+            <a:srgbClr val="DB2777"/>
+          </a:solidFill>
+          <a:ln>
+            <a:noFill/>
+          </a:ln>
+        </p:spPr>
+        <p:style>
+          <a:lnRef idx="1">
+            <a:schemeClr val="accent1"/>
+          </a:lnRef>
+          <a:fillRef idx="3">
+            <a:schemeClr val="accent1"/>
+          </a:fillRef>
+          <a:effectRef idx="2">
+            <a:schemeClr val="accent1"/>
+          </a:effectRef>
+          <a:fontRef idx="minor">
+            <a:schemeClr val="lt1"/>
+          </a:fontRef>
+        </p:style>
+        <p:txBody>
+          <a:bodyPr rtlCol="0" anchor="ctr"/>
+          <a:lstStyle/>
+          <a:p>
+            <a:pPr algn="ctr"/>
+          </a:p>
+        </p:txBody>
+      </p:sp>
+      <p:sp>
+        <p:nvSpPr>
+          <p:cNvPr id="7" name="TextBox 6"/>
+          <p:cNvSpPr txBox="1"/>
+          <p:nvPr/>
+        </p:nvSpPr>
+        <p:spPr>
+          <a:xfrm>
+            <a:off x="5285232" y="3657600"/>
+            <a:ext cx="6144768" cy="1737360"/>
+          </a:xfrm>
+          <a:prstGeom prst="rect">
+            <a:avLst/>
+          </a:prstGeom>
+          <a:noFill/>
+        </p:spPr>
+        <p:txBody>
+          <a:bodyPr wrap="square" lIns="0" tIns="0" rIns="0" bIns="0">
+            <a:spAutoFit/>
+          </a:bodyPr>
+          <a:lstStyle/>
           <a:p>
             <a:pPr>
               <a:spcAft>
-                <a:spcPts val="400"/>
+                <a:spcPts val="300"/>
               </a:spcAft>
-              <a:defRPr b="0" i="1" sz="2400">
+              <a:defRPr b="1" sz="2400">
                 <a:solidFill>
                   <a:srgbClr val="0F172A"/>
                 </a:solidFill>
@@ -3722,15 +4385,12 @@
               </a:defRPr>
             </a:pPr>
             <a:r>
-              <a:t>Reading room has been replaced by computer room.</a:t>
-            </a:r>
-          </a:p>
-          <a:p>
-            <a:pPr>
-              <a:spcAft>
-                <a:spcPts val="1800"/>
-              </a:spcAft>
-              <a:defRPr b="0" i="1" sz="2400">
+              <a:t>CẤU TRÚC ĐẢO NGỮ NƠI CHỐN ĂN ĐIỂM</a:t>
+            </a:r>
+          </a:p>
+          <a:p>
+            <a:pPr>
+              <a:defRPr i="1" sz="2400">
                 <a:solidFill>
                   <a:srgbClr val="0F172A"/>
                 </a:solidFill>
@@ -3738,55 +4398,7 @@
               </a:defRPr>
             </a:pPr>
             <a:r>
-              <a:t>Enquiry desk has given way to a café and self-service machines.</a:t>
-            </a:r>
-          </a:p>
-          <a:p>
-            <a:pPr>
-              <a:spcAft>
-                <a:spcPts val="400"/>
-              </a:spcAft>
-              <a:defRPr b="1" i="0" sz="2600">
-                <a:solidFill>
-                  <a:srgbClr val="0F172A"/>
-                </a:solidFill>
-                <a:latin typeface="Montserrat"/>
-              </a:defRPr>
-            </a:pPr>
-            <a:r>
-              <a:t>BODY 2 ➔ CÁC GÓC CUỐI THƯ VIỆN</a:t>
-            </a:r>
-          </a:p>
-          <a:p>
-            <a:pPr>
-              <a:spcAft>
-                <a:spcPts val="400"/>
-              </a:spcAft>
-              <a:defRPr b="0" i="1" sz="2400">
-                <a:solidFill>
-                  <a:srgbClr val="0F172A"/>
-                </a:solidFill>
-                <a:latin typeface="Montserrat"/>
-              </a:defRPr>
-            </a:pPr>
-            <a:r>
-              <a:t>Room in top-left corner has been enlarged for storytelling.</a:t>
-            </a:r>
-          </a:p>
-          <a:p>
-            <a:pPr>
-              <a:spcAft>
-                <a:spcPts val="0"/>
-              </a:spcAft>
-              <a:defRPr b="1" i="1" sz="2400">
-                <a:solidFill>
-                  <a:srgbClr val="0F172A"/>
-                </a:solidFill>
-                <a:latin typeface="Montserrat"/>
-              </a:defRPr>
-            </a:pPr>
-            <a:r>
-              <a:t>In the top-right corner now stands a lecture room.</a:t>
+              <a:t>In the top-right corner now stands a newly constructed lecture room.</a:t>
             </a:r>
           </a:p>
         </p:txBody>
@@ -3825,8 +4437,8 @@
         </p:nvSpPr>
         <p:spPr>
           <a:xfrm>
-            <a:off x="731520" y="457200"/>
-            <a:ext cx="10728655" cy="731520"/>
+            <a:off x="731520" y="411480"/>
+            <a:ext cx="10728655" cy="685800"/>
           </a:xfrm>
           <a:prstGeom prst="rect">
             <a:avLst/>
@@ -3840,7 +4452,7 @@
           <a:lstStyle/>
           <a:p>
             <a:pPr>
-              <a:defRPr sz="3400" b="1">
+              <a:defRPr sz="3200" b="1">
                 <a:solidFill>
                   <a:srgbClr val="7C3AED"/>
                 </a:solidFill>
@@ -3855,14 +4467,57 @@
       </p:sp>
       <p:sp>
         <p:nvSpPr>
-          <p:cNvPr id="3" name="TextBox 2"/>
+          <p:cNvPr id="3" name="Rectangle 2"/>
+          <p:cNvSpPr/>
+          <p:nvPr/>
+        </p:nvSpPr>
+        <p:spPr>
+          <a:xfrm>
+            <a:off x="731520" y="1463040"/>
+            <a:ext cx="45720" cy="1645920"/>
+          </a:xfrm>
+          <a:prstGeom prst="rect">
+            <a:avLst/>
+          </a:prstGeom>
+          <a:solidFill>
+            <a:srgbClr val="7C3AED"/>
+          </a:solidFill>
+          <a:ln>
+            <a:noFill/>
+          </a:ln>
+        </p:spPr>
+        <p:style>
+          <a:lnRef idx="1">
+            <a:schemeClr val="accent1"/>
+          </a:lnRef>
+          <a:fillRef idx="3">
+            <a:schemeClr val="accent1"/>
+          </a:fillRef>
+          <a:effectRef idx="2">
+            <a:schemeClr val="accent1"/>
+          </a:effectRef>
+          <a:fontRef idx="minor">
+            <a:schemeClr val="lt1"/>
+          </a:fontRef>
+        </p:style>
+        <p:txBody>
+          <a:bodyPr rtlCol="0" anchor="ctr"/>
+          <a:lstStyle/>
+          <a:p>
+            <a:pPr algn="ctr"/>
+          </a:p>
+        </p:txBody>
+      </p:sp>
+      <p:sp>
+        <p:nvSpPr>
+          <p:cNvPr id="4" name="TextBox 3"/>
           <p:cNvSpPr txBox="1"/>
           <p:nvPr/>
         </p:nvSpPr>
         <p:spPr>
           <a:xfrm>
-            <a:off x="731520" y="1463040"/>
-            <a:ext cx="5120640" cy="4754880"/>
+            <a:off x="896112" y="1463040"/>
+            <a:ext cx="4956048" cy="1645920"/>
           </a:xfrm>
           <a:prstGeom prst="rect">
             <a:avLst/>
@@ -3877,9 +4532,9 @@
           <a:p>
             <a:pPr>
               <a:spcAft>
-                <a:spcPts val="600"/>
+                <a:spcPts val="300"/>
               </a:spcAft>
-              <a:defRPr b="1" i="0" sz="2600">
+              <a:defRPr b="1" sz="2400">
                 <a:solidFill>
                   <a:srgbClr val="0F172A"/>
                 </a:solidFill>
@@ -3892,10 +4547,7 @@
           </a:p>
           <a:p>
             <a:pPr>
-              <a:spcAft>
-                <a:spcPts val="600"/>
-              </a:spcAft>
-              <a:defRPr b="0" i="0" sz="2400">
+              <a:defRPr i="1" sz="2400">
                 <a:solidFill>
                   <a:srgbClr val="0F172A"/>
                 </a:solidFill>
@@ -3903,85 +4555,68 @@
               </a:defRPr>
             </a:pPr>
             <a:r>
-              <a:t>Bắt buộc có Overview nêu bức tranh tổng thể</a:t>
-            </a:r>
-          </a:p>
-          <a:p>
-            <a:pPr>
-              <a:spcAft>
-                <a:spcPts val="2600"/>
-              </a:spcAft>
-              <a:defRPr b="0" i="1" sz="2400">
-                <a:solidFill>
-                  <a:srgbClr val="0F172A"/>
-                </a:solidFill>
-                <a:latin typeface="Montserrat"/>
-              </a:defRPr>
-            </a:pPr>
-            <a:r>
-              <a:t>Bắt buộc mô tả cả những chi tiết giữ nguyên</a:t>
-            </a:r>
-          </a:p>
-          <a:p>
-            <a:pPr>
-              <a:spcAft>
-                <a:spcPts val="600"/>
-              </a:spcAft>
-              <a:defRPr b="1" i="0" sz="2600">
-                <a:solidFill>
-                  <a:srgbClr val="0F172A"/>
-                </a:solidFill>
-                <a:latin typeface="Montserrat"/>
-              </a:defRPr>
-            </a:pPr>
-            <a:r>
-              <a:t>COHERENCE AND COHESION</a:t>
-            </a:r>
-          </a:p>
-          <a:p>
-            <a:pPr>
-              <a:spcAft>
-                <a:spcPts val="600"/>
-              </a:spcAft>
-              <a:defRPr b="0" i="0" sz="2400">
-                <a:solidFill>
-                  <a:srgbClr val="0F172A"/>
-                </a:solidFill>
-                <a:latin typeface="Montserrat"/>
-              </a:defRPr>
-            </a:pPr>
-            <a:r>
-              <a:t>Chia đoạn theo trật tự không gian rõ ràng</a:t>
-            </a:r>
-          </a:p>
-          <a:p>
-            <a:pPr>
-              <a:spcAft>
-                <a:spcPts val="0"/>
-              </a:spcAft>
-              <a:defRPr b="0" i="1" sz="2400">
-                <a:solidFill>
-                  <a:srgbClr val="0F172A"/>
-                </a:solidFill>
-                <a:latin typeface="Montserrat"/>
-              </a:defRPr>
-            </a:pPr>
-            <a:r>
-              <a:t>Không nhảy cóc vị trí lộn xộn trên bản đồ</a:t>
-            </a:r>
-          </a:p>
-        </p:txBody>
-      </p:sp>
-      <p:sp>
-        <p:nvSpPr>
-          <p:cNvPr id="4" name="TextBox 3"/>
+              <a:t>Bắt buộc có Overview tổng thể.</a:t>
+            </a:r>
+            <a:br/>
+            <a:r>
+              <a:t>Mô tả cả những chi tiết giữ nguyên.</a:t>
+            </a:r>
+          </a:p>
+        </p:txBody>
+      </p:sp>
+      <p:sp>
+        <p:nvSpPr>
+          <p:cNvPr id="5" name="Rectangle 4"/>
+          <p:cNvSpPr/>
+          <p:nvPr/>
+        </p:nvSpPr>
+        <p:spPr>
+          <a:xfrm>
+            <a:off x="731520" y="3566160"/>
+            <a:ext cx="45720" cy="1645920"/>
+          </a:xfrm>
+          <a:prstGeom prst="rect">
+            <a:avLst/>
+          </a:prstGeom>
+          <a:solidFill>
+            <a:srgbClr val="7C3AED"/>
+          </a:solidFill>
+          <a:ln>
+            <a:noFill/>
+          </a:ln>
+        </p:spPr>
+        <p:style>
+          <a:lnRef idx="1">
+            <a:schemeClr val="accent1"/>
+          </a:lnRef>
+          <a:fillRef idx="3">
+            <a:schemeClr val="accent1"/>
+          </a:fillRef>
+          <a:effectRef idx="2">
+            <a:schemeClr val="accent1"/>
+          </a:effectRef>
+          <a:fontRef idx="minor">
+            <a:schemeClr val="lt1"/>
+          </a:fontRef>
+        </p:style>
+        <p:txBody>
+          <a:bodyPr rtlCol="0" anchor="ctr"/>
+          <a:lstStyle/>
+          <a:p>
+            <a:pPr algn="ctr"/>
+          </a:p>
+        </p:txBody>
+      </p:sp>
+      <p:sp>
+        <p:nvSpPr>
+          <p:cNvPr id="6" name="TextBox 5"/>
           <p:cNvSpPr txBox="1"/>
           <p:nvPr/>
         </p:nvSpPr>
         <p:spPr>
           <a:xfrm>
-            <a:off x="6217920" y="1463040"/>
-            <a:ext cx="5120640" cy="4754880"/>
+            <a:off x="896112" y="3566160"/>
+            <a:ext cx="4956048" cy="1645920"/>
           </a:xfrm>
           <a:prstGeom prst="rect">
             <a:avLst/>
@@ -3996,9 +4631,9 @@
           <a:p>
             <a:pPr>
               <a:spcAft>
-                <a:spcPts val="600"/>
+                <a:spcPts val="300"/>
               </a:spcAft>
-              <a:defRPr b="1" i="0" sz="2600">
+              <a:defRPr b="1" sz="2400">
                 <a:solidFill>
                   <a:srgbClr val="0F172A"/>
                 </a:solidFill>
@@ -4006,15 +4641,197 @@
               </a:defRPr>
             </a:pPr>
             <a:r>
+              <a:t>COHERENCE AND COHESION</a:t>
+            </a:r>
+          </a:p>
+          <a:p>
+            <a:pPr>
+              <a:defRPr i="1" sz="2400">
+                <a:solidFill>
+                  <a:srgbClr val="0F172A"/>
+                </a:solidFill>
+                <a:latin typeface="Montserrat"/>
+              </a:defRPr>
+            </a:pPr>
+            <a:r>
+              <a:t>Chia đoạn theo trật tự không gian rõ ràng.</a:t>
+            </a:r>
+            <a:br/>
+            <a:r>
+              <a:t>Không nhảy cóc vị trí lộn xộn trên bản đồ.</a:t>
+            </a:r>
+          </a:p>
+        </p:txBody>
+      </p:sp>
+      <p:sp>
+        <p:nvSpPr>
+          <p:cNvPr id="7" name="Rectangle 6"/>
+          <p:cNvSpPr/>
+          <p:nvPr/>
+        </p:nvSpPr>
+        <p:spPr>
+          <a:xfrm>
+            <a:off x="6217920" y="1463040"/>
+            <a:ext cx="45720" cy="1645920"/>
+          </a:xfrm>
+          <a:prstGeom prst="rect">
+            <a:avLst/>
+          </a:prstGeom>
+          <a:solidFill>
+            <a:srgbClr val="7C3AED"/>
+          </a:solidFill>
+          <a:ln>
+            <a:noFill/>
+          </a:ln>
+        </p:spPr>
+        <p:style>
+          <a:lnRef idx="1">
+            <a:schemeClr val="accent1"/>
+          </a:lnRef>
+          <a:fillRef idx="3">
+            <a:schemeClr val="accent1"/>
+          </a:fillRef>
+          <a:effectRef idx="2">
+            <a:schemeClr val="accent1"/>
+          </a:effectRef>
+          <a:fontRef idx="minor">
+            <a:schemeClr val="lt1"/>
+          </a:fontRef>
+        </p:style>
+        <p:txBody>
+          <a:bodyPr rtlCol="0" anchor="ctr"/>
+          <a:lstStyle/>
+          <a:p>
+            <a:pPr algn="ctr"/>
+          </a:p>
+        </p:txBody>
+      </p:sp>
+      <p:sp>
+        <p:nvSpPr>
+          <p:cNvPr id="8" name="TextBox 7"/>
+          <p:cNvSpPr txBox="1"/>
+          <p:nvPr/>
+        </p:nvSpPr>
+        <p:spPr>
+          <a:xfrm>
+            <a:off x="6382512" y="1463040"/>
+            <a:ext cx="4956048" cy="1645920"/>
+          </a:xfrm>
+          <a:prstGeom prst="rect">
+            <a:avLst/>
+          </a:prstGeom>
+          <a:noFill/>
+        </p:spPr>
+        <p:txBody>
+          <a:bodyPr wrap="square" lIns="0" tIns="0" rIns="0" bIns="0">
+            <a:spAutoFit/>
+          </a:bodyPr>
+          <a:lstStyle/>
+          <a:p>
+            <a:pPr>
+              <a:spcAft>
+                <a:spcPts val="300"/>
+              </a:spcAft>
+              <a:defRPr b="1" sz="2400">
+                <a:solidFill>
+                  <a:srgbClr val="0F172A"/>
+                </a:solidFill>
+                <a:latin typeface="Montserrat"/>
+              </a:defRPr>
+            </a:pPr>
+            <a:r>
               <a:t>LEXICAL RESOURCE</a:t>
             </a:r>
           </a:p>
           <a:p>
             <a:pPr>
+              <a:defRPr i="1" sz="2400">
+                <a:solidFill>
+                  <a:srgbClr val="0F172A"/>
+                </a:solidFill>
+                <a:latin typeface="Montserrat"/>
+              </a:defRPr>
+            </a:pPr>
+            <a:r>
+              <a:t>Đa dạng 5 nhóm động từ thay đổi.</a:t>
+            </a:r>
+            <a:br/>
+            <a:r>
+              <a:t>Chính xác giới từ in và to khi chỉ hướng.</a:t>
+            </a:r>
+          </a:p>
+        </p:txBody>
+      </p:sp>
+      <p:sp>
+        <p:nvSpPr>
+          <p:cNvPr id="9" name="Rectangle 8"/>
+          <p:cNvSpPr/>
+          <p:nvPr/>
+        </p:nvSpPr>
+        <p:spPr>
+          <a:xfrm>
+            <a:off x="6217920" y="3566160"/>
+            <a:ext cx="45720" cy="1645920"/>
+          </a:xfrm>
+          <a:prstGeom prst="rect">
+            <a:avLst/>
+          </a:prstGeom>
+          <a:solidFill>
+            <a:srgbClr val="7C3AED"/>
+          </a:solidFill>
+          <a:ln>
+            <a:noFill/>
+          </a:ln>
+        </p:spPr>
+        <p:style>
+          <a:lnRef idx="1">
+            <a:schemeClr val="accent1"/>
+          </a:lnRef>
+          <a:fillRef idx="3">
+            <a:schemeClr val="accent1"/>
+          </a:fillRef>
+          <a:effectRef idx="2">
+            <a:schemeClr val="accent1"/>
+          </a:effectRef>
+          <a:fontRef idx="minor">
+            <a:schemeClr val="lt1"/>
+          </a:fontRef>
+        </p:style>
+        <p:txBody>
+          <a:bodyPr rtlCol="0" anchor="ctr"/>
+          <a:lstStyle/>
+          <a:p>
+            <a:pPr algn="ctr"/>
+          </a:p>
+        </p:txBody>
+      </p:sp>
+      <p:sp>
+        <p:nvSpPr>
+          <p:cNvPr id="10" name="TextBox 9"/>
+          <p:cNvSpPr txBox="1"/>
+          <p:nvPr/>
+        </p:nvSpPr>
+        <p:spPr>
+          <a:xfrm>
+            <a:off x="6382512" y="3566160"/>
+            <a:ext cx="4956048" cy="1645920"/>
+          </a:xfrm>
+          <a:prstGeom prst="rect">
+            <a:avLst/>
+          </a:prstGeom>
+          <a:noFill/>
+        </p:spPr>
+        <p:txBody>
+          <a:bodyPr wrap="square" lIns="0" tIns="0" rIns="0" bIns="0">
+            <a:spAutoFit/>
+          </a:bodyPr>
+          <a:lstStyle/>
+          <a:p>
+            <a:pPr>
               <a:spcAft>
-                <a:spcPts val="600"/>
+                <a:spcPts val="300"/>
               </a:spcAft>
-              <a:defRPr b="0" i="0" sz="2400">
+              <a:defRPr b="1" sz="2400">
                 <a:solidFill>
                   <a:srgbClr val="0F172A"/>
                 </a:solidFill>
@@ -4022,15 +4839,12 @@
               </a:defRPr>
             </a:pPr>
             <a:r>
-              <a:t>Đa dạng 5 nhóm động từ thay đổi</a:t>
-            </a:r>
-          </a:p>
-          <a:p>
-            <a:pPr>
-              <a:spcAft>
-                <a:spcPts val="2600"/>
-              </a:spcAft>
-              <a:defRPr b="0" i="1" sz="2400">
+              <a:t>GRAMMATICAL RANGE AND ACCURACY</a:t>
+            </a:r>
+          </a:p>
+          <a:p>
+            <a:pPr>
+              <a:defRPr i="1" sz="2400">
                 <a:solidFill>
                   <a:srgbClr val="0F172A"/>
                 </a:solidFill>
@@ -4038,55 +4852,11 @@
               </a:defRPr>
             </a:pPr>
             <a:r>
-              <a:t>Chính xác giới từ in và to khi chỉ hướng</a:t>
-            </a:r>
-          </a:p>
-          <a:p>
-            <a:pPr>
-              <a:spcAft>
-                <a:spcPts val="600"/>
-              </a:spcAft>
-              <a:defRPr b="1" i="0" sz="2600">
-                <a:solidFill>
-                  <a:srgbClr val="0F172A"/>
-                </a:solidFill>
-                <a:latin typeface="Montserrat"/>
-              </a:defRPr>
-            </a:pPr>
-            <a:r>
-              <a:t>GRAMMATICAL RANGE AND ACCURACY</a:t>
-            </a:r>
-          </a:p>
-          <a:p>
-            <a:pPr>
-              <a:spcAft>
-                <a:spcPts val="600"/>
-              </a:spcAft>
-              <a:defRPr b="0" i="0" sz="2400">
-                <a:solidFill>
-                  <a:srgbClr val="0F172A"/>
-                </a:solidFill>
-                <a:latin typeface="Montserrat"/>
-              </a:defRPr>
-            </a:pPr>
-            <a:r>
-              <a:t>80% sử dụng thể bị động</a:t>
-            </a:r>
-          </a:p>
-          <a:p>
-            <a:pPr>
-              <a:spcAft>
-                <a:spcPts val="0"/>
-              </a:spcAft>
-              <a:defRPr b="0" i="1" sz="2400">
-                <a:solidFill>
-                  <a:srgbClr val="0F172A"/>
-                </a:solidFill>
-                <a:latin typeface="Montserrat"/>
-              </a:defRPr>
-            </a:pPr>
-            <a:r>
-              <a:t>Kết hợp danh từ hóa và mệnh đề phân từ</a:t>
+              <a:t>80% sử dụng thể bị động.</a:t>
+            </a:r>
+            <a:br/>
+            <a:r>
+              <a:t>Kết hợp danh từ hóa và mệnh đề phân từ.</a:t>
             </a:r>
           </a:p>
         </p:txBody>
@@ -4125,8 +4895,8 @@
         </p:nvSpPr>
         <p:spPr>
           <a:xfrm>
-            <a:off x="731520" y="457200"/>
-            <a:ext cx="10728655" cy="731520"/>
+            <a:off x="731520" y="411480"/>
+            <a:ext cx="10728655" cy="685800"/>
           </a:xfrm>
           <a:prstGeom prst="rect">
             <a:avLst/>
@@ -4140,7 +4910,7 @@
           <a:lstStyle/>
           <a:p>
             <a:pPr>
-              <a:defRPr sz="3400" b="1">
+              <a:defRPr sz="3200" b="1">
                 <a:solidFill>
                   <a:srgbClr val="EA580C"/>
                 </a:solidFill>
@@ -4155,14 +4925,57 @@
       </p:sp>
       <p:sp>
         <p:nvSpPr>
-          <p:cNvPr id="3" name="TextBox 2"/>
+          <p:cNvPr id="3" name="Rectangle 2"/>
+          <p:cNvSpPr/>
+          <p:nvPr/>
+        </p:nvSpPr>
+        <p:spPr>
+          <a:xfrm>
+            <a:off x="731520" y="1371600"/>
+            <a:ext cx="45720" cy="868680"/>
+          </a:xfrm>
+          <a:prstGeom prst="rect">
+            <a:avLst/>
+          </a:prstGeom>
+          <a:solidFill>
+            <a:srgbClr val="EA580C"/>
+          </a:solidFill>
+          <a:ln>
+            <a:noFill/>
+          </a:ln>
+        </p:spPr>
+        <p:style>
+          <a:lnRef idx="1">
+            <a:schemeClr val="accent1"/>
+          </a:lnRef>
+          <a:fillRef idx="3">
+            <a:schemeClr val="accent1"/>
+          </a:fillRef>
+          <a:effectRef idx="2">
+            <a:schemeClr val="accent1"/>
+          </a:effectRef>
+          <a:fontRef idx="minor">
+            <a:schemeClr val="lt1"/>
+          </a:fontRef>
+        </p:style>
+        <p:txBody>
+          <a:bodyPr rtlCol="0" anchor="ctr"/>
+          <a:lstStyle/>
+          <a:p>
+            <a:pPr algn="ctr"/>
+          </a:p>
+        </p:txBody>
+      </p:sp>
+      <p:sp>
+        <p:nvSpPr>
+          <p:cNvPr id="4" name="TextBox 3"/>
           <p:cNvSpPr txBox="1"/>
           <p:nvPr/>
         </p:nvSpPr>
         <p:spPr>
           <a:xfrm>
-            <a:off x="731520" y="1463040"/>
-            <a:ext cx="10728655" cy="4754880"/>
+            <a:off x="896112" y="1371600"/>
+            <a:ext cx="10564063" cy="868680"/>
           </a:xfrm>
           <a:prstGeom prst="rect">
             <a:avLst/>
@@ -4177,9 +4990,9 @@
           <a:p>
             <a:pPr>
               <a:spcAft>
-                <a:spcPts val="600"/>
+                <a:spcPts val="300"/>
               </a:spcAft>
-              <a:defRPr b="1" i="0" sz="2600">
+              <a:defRPr b="1" sz="2400">
                 <a:solidFill>
                   <a:srgbClr val="0F172A"/>
                 </a:solidFill>
@@ -4192,10 +5005,89 @@
           </a:p>
           <a:p>
             <a:pPr>
+              <a:defRPr i="1" sz="2400">
+                <a:solidFill>
+                  <a:srgbClr val="0F172A"/>
+                </a:solidFill>
+                <a:latin typeface="Montserrat"/>
+              </a:defRPr>
+            </a:pPr>
+            <a:r>
+              <a:t>Introduction ➔ Overview ➔ Body 1 ➔ Body 2</a:t>
+            </a:r>
+          </a:p>
+        </p:txBody>
+      </p:sp>
+      <p:sp>
+        <p:nvSpPr>
+          <p:cNvPr id="5" name="Rectangle 4"/>
+          <p:cNvSpPr/>
+          <p:nvPr/>
+        </p:nvSpPr>
+        <p:spPr>
+          <a:xfrm>
+            <a:off x="731520" y="2514600"/>
+            <a:ext cx="45720" cy="868680"/>
+          </a:xfrm>
+          <a:prstGeom prst="rect">
+            <a:avLst/>
+          </a:prstGeom>
+          <a:solidFill>
+            <a:srgbClr val="EA580C"/>
+          </a:solidFill>
+          <a:ln>
+            <a:noFill/>
+          </a:ln>
+        </p:spPr>
+        <p:style>
+          <a:lnRef idx="1">
+            <a:schemeClr val="accent1"/>
+          </a:lnRef>
+          <a:fillRef idx="3">
+            <a:schemeClr val="accent1"/>
+          </a:fillRef>
+          <a:effectRef idx="2">
+            <a:schemeClr val="accent1"/>
+          </a:effectRef>
+          <a:fontRef idx="minor">
+            <a:schemeClr val="lt1"/>
+          </a:fontRef>
+        </p:style>
+        <p:txBody>
+          <a:bodyPr rtlCol="0" anchor="ctr"/>
+          <a:lstStyle/>
+          <a:p>
+            <a:pPr algn="ctr"/>
+          </a:p>
+        </p:txBody>
+      </p:sp>
+      <p:sp>
+        <p:nvSpPr>
+          <p:cNvPr id="6" name="TextBox 5"/>
+          <p:cNvSpPr txBox="1"/>
+          <p:nvPr/>
+        </p:nvSpPr>
+        <p:spPr>
+          <a:xfrm>
+            <a:off x="896112" y="2514600"/>
+            <a:ext cx="10564063" cy="868680"/>
+          </a:xfrm>
+          <a:prstGeom prst="rect">
+            <a:avLst/>
+          </a:prstGeom>
+          <a:noFill/>
+        </p:spPr>
+        <p:txBody>
+          <a:bodyPr wrap="square" lIns="0" tIns="0" rIns="0" bIns="0">
+            <a:spAutoFit/>
+          </a:bodyPr>
+          <a:lstStyle/>
+          <a:p>
+            <a:pPr>
               <a:spcAft>
-                <a:spcPts val="2400"/>
+                <a:spcPts val="300"/>
               </a:spcAft>
-              <a:defRPr b="1" i="1" sz="2400">
+              <a:defRPr b="1" sz="2400">
                 <a:solidFill>
                   <a:srgbClr val="0F172A"/>
                 </a:solidFill>
@@ -4203,15 +5095,94 @@
               </a:defRPr>
             </a:pPr>
             <a:r>
-              <a:t>Introduction ➔ Overview ➔ Body 1 ➔ Body 2</a:t>
-            </a:r>
-          </a:p>
+              <a:t>CÁCH 1 ➔ CHIA ĐÔI KHÔNG GIAN BẮC VÀ NAM</a:t>
+            </a:r>
+          </a:p>
+          <a:p>
+            <a:pPr>
+              <a:defRPr i="1" sz="2400">
+                <a:solidFill>
+                  <a:srgbClr val="0F172A"/>
+                </a:solidFill>
+                <a:latin typeface="Montserrat"/>
+              </a:defRPr>
+            </a:pPr>
+            <a:r>
+              <a:t>Áp dụng khi có con sông hoặc trục đường lớn cắt ngang.</a:t>
+            </a:r>
+          </a:p>
+        </p:txBody>
+      </p:sp>
+      <p:sp>
+        <p:nvSpPr>
+          <p:cNvPr id="7" name="Rectangle 6"/>
+          <p:cNvSpPr/>
+          <p:nvPr/>
+        </p:nvSpPr>
+        <p:spPr>
+          <a:xfrm>
+            <a:off x="731520" y="3657600"/>
+            <a:ext cx="45720" cy="868680"/>
+          </a:xfrm>
+          <a:prstGeom prst="rect">
+            <a:avLst/>
+          </a:prstGeom>
+          <a:solidFill>
+            <a:srgbClr val="EA580C"/>
+          </a:solidFill>
+          <a:ln>
+            <a:noFill/>
+          </a:ln>
+        </p:spPr>
+        <p:style>
+          <a:lnRef idx="1">
+            <a:schemeClr val="accent1"/>
+          </a:lnRef>
+          <a:fillRef idx="3">
+            <a:schemeClr val="accent1"/>
+          </a:fillRef>
+          <a:effectRef idx="2">
+            <a:schemeClr val="accent1"/>
+          </a:effectRef>
+          <a:fontRef idx="minor">
+            <a:schemeClr val="lt1"/>
+          </a:fontRef>
+        </p:style>
+        <p:txBody>
+          <a:bodyPr rtlCol="0" anchor="ctr"/>
+          <a:lstStyle/>
+          <a:p>
+            <a:pPr algn="ctr"/>
+          </a:p>
+        </p:txBody>
+      </p:sp>
+      <p:sp>
+        <p:nvSpPr>
+          <p:cNvPr id="8" name="TextBox 7"/>
+          <p:cNvSpPr txBox="1"/>
+          <p:nvPr/>
+        </p:nvSpPr>
+        <p:spPr>
+          <a:xfrm>
+            <a:off x="896112" y="3657600"/>
+            <a:ext cx="10564063" cy="868680"/>
+          </a:xfrm>
+          <a:prstGeom prst="rect">
+            <a:avLst/>
+          </a:prstGeom>
+          <a:noFill/>
+        </p:spPr>
+        <p:txBody>
+          <a:bodyPr wrap="square" lIns="0" tIns="0" rIns="0" bIns="0">
+            <a:spAutoFit/>
+          </a:bodyPr>
+          <a:lstStyle/>
           <a:p>
             <a:pPr>
               <a:spcAft>
-                <a:spcPts val="600"/>
+                <a:spcPts val="300"/>
               </a:spcAft>
-              <a:defRPr b="1" i="0" sz="2600">
+              <a:defRPr b="1" sz="2400">
                 <a:solidFill>
                   <a:srgbClr val="0F172A"/>
                 </a:solidFill>
@@ -4219,15 +5190,94 @@
               </a:defRPr>
             </a:pPr>
             <a:r>
-              <a:t>CÁCH 1 ➔ CHIA ĐÔI KHÔNG GIAN BẮC VÀ NAM</a:t>
-            </a:r>
-          </a:p>
+              <a:t>CÁCH 2 ➔ TRUNG TÂM VÀ CÁC PHÒNG XUNG QUANH</a:t>
+            </a:r>
+          </a:p>
+          <a:p>
+            <a:pPr>
+              <a:defRPr i="1" sz="2400">
+                <a:solidFill>
+                  <a:srgbClr val="0F172A"/>
+                </a:solidFill>
+                <a:latin typeface="Montserrat"/>
+              </a:defRPr>
+            </a:pPr>
+            <a:r>
+              <a:t>Áp dụng cho sơ đồ phòng hoặc hòn đảo du lịch.</a:t>
+            </a:r>
+          </a:p>
+        </p:txBody>
+      </p:sp>
+      <p:sp>
+        <p:nvSpPr>
+          <p:cNvPr id="9" name="Rectangle 8"/>
+          <p:cNvSpPr/>
+          <p:nvPr/>
+        </p:nvSpPr>
+        <p:spPr>
+          <a:xfrm>
+            <a:off x="731520" y="4800600"/>
+            <a:ext cx="45720" cy="868680"/>
+          </a:xfrm>
+          <a:prstGeom prst="rect">
+            <a:avLst/>
+          </a:prstGeom>
+          <a:solidFill>
+            <a:srgbClr val="EA580C"/>
+          </a:solidFill>
+          <a:ln>
+            <a:noFill/>
+          </a:ln>
+        </p:spPr>
+        <p:style>
+          <a:lnRef idx="1">
+            <a:schemeClr val="accent1"/>
+          </a:lnRef>
+          <a:fillRef idx="3">
+            <a:schemeClr val="accent1"/>
+          </a:fillRef>
+          <a:effectRef idx="2">
+            <a:schemeClr val="accent1"/>
+          </a:effectRef>
+          <a:fontRef idx="minor">
+            <a:schemeClr val="lt1"/>
+          </a:fontRef>
+        </p:style>
+        <p:txBody>
+          <a:bodyPr rtlCol="0" anchor="ctr"/>
+          <a:lstStyle/>
+          <a:p>
+            <a:pPr algn="ctr"/>
+          </a:p>
+        </p:txBody>
+      </p:sp>
+      <p:sp>
+        <p:nvSpPr>
+          <p:cNvPr id="10" name="TextBox 9"/>
+          <p:cNvSpPr txBox="1"/>
+          <p:nvPr/>
+        </p:nvSpPr>
+        <p:spPr>
+          <a:xfrm>
+            <a:off x="896112" y="4800600"/>
+            <a:ext cx="10564063" cy="868680"/>
+          </a:xfrm>
+          <a:prstGeom prst="rect">
+            <a:avLst/>
+          </a:prstGeom>
+          <a:noFill/>
+        </p:spPr>
+        <p:txBody>
+          <a:bodyPr wrap="square" lIns="0" tIns="0" rIns="0" bIns="0">
+            <a:spAutoFit/>
+          </a:bodyPr>
+          <a:lstStyle/>
           <a:p>
             <a:pPr>
               <a:spcAft>
-                <a:spcPts val="2000"/>
+                <a:spcPts val="300"/>
               </a:spcAft>
-              <a:defRPr b="0" i="1" sz="2400">
+              <a:defRPr b="1" sz="2400">
                 <a:solidFill>
                   <a:srgbClr val="0F172A"/>
                 </a:solidFill>
@@ -4235,15 +5285,12 @@
               </a:defRPr>
             </a:pPr>
             <a:r>
-              <a:t>Áp dụng khi có con sông hoặc trục đường lớn cắt ngang</a:t>
-            </a:r>
-          </a:p>
-          <a:p>
-            <a:pPr>
-              <a:spcAft>
-                <a:spcPts val="600"/>
-              </a:spcAft>
-              <a:defRPr b="1" i="0" sz="2600">
+              <a:t>CÁCH 3 ➔ CHIA THEO NHÓM CHỨC NĂNG</a:t>
+            </a:r>
+          </a:p>
+          <a:p>
+            <a:pPr>
+              <a:defRPr i="1" sz="2400">
                 <a:solidFill>
                   <a:srgbClr val="0F172A"/>
                 </a:solidFill>
@@ -4251,55 +5298,7 @@
               </a:defRPr>
             </a:pPr>
             <a:r>
-              <a:t>CÁCH 2 ➔ TRUNG TÂM VÀ CÁC PHÒNG XUNG QUANH</a:t>
-            </a:r>
-          </a:p>
-          <a:p>
-            <a:pPr>
-              <a:spcAft>
-                <a:spcPts val="2000"/>
-              </a:spcAft>
-              <a:defRPr b="0" i="1" sz="2400">
-                <a:solidFill>
-                  <a:srgbClr val="0F172A"/>
-                </a:solidFill>
-                <a:latin typeface="Montserrat"/>
-              </a:defRPr>
-            </a:pPr>
-            <a:r>
-              <a:t>Áp dụng cho sơ đồ phòng hoặc hòn đảo du lịch</a:t>
-            </a:r>
-          </a:p>
-          <a:p>
-            <a:pPr>
-              <a:spcAft>
-                <a:spcPts val="600"/>
-              </a:spcAft>
-              <a:defRPr b="1" i="0" sz="2600">
-                <a:solidFill>
-                  <a:srgbClr val="0F172A"/>
-                </a:solidFill>
-                <a:latin typeface="Montserrat"/>
-              </a:defRPr>
-            </a:pPr>
-            <a:r>
-              <a:t>CÁCH 3 ➔ CHIA THEO NHÓM CHỨC NĂNG</a:t>
-            </a:r>
-          </a:p>
-          <a:p>
-            <a:pPr>
-              <a:spcAft>
-                <a:spcPts val="0"/>
-              </a:spcAft>
-              <a:defRPr b="0" i="1" sz="2400">
-                <a:solidFill>
-                  <a:srgbClr val="0F172A"/>
-                </a:solidFill>
-                <a:latin typeface="Montserrat"/>
-              </a:defRPr>
-            </a:pPr>
-            <a:r>
-              <a:t>Body 1 tả hạ tầng và nhà ở ➔ Body 2 tả tiện ích và thiên nhiên</a:t>
+              <a:t>Body 1 tả hạ tầng và nhà ở ➔ Body 2 tả tiện ích và thiên nhiên.</a:t>
             </a:r>
           </a:p>
         </p:txBody>
@@ -4338,8 +5337,8 @@
         </p:nvSpPr>
         <p:spPr>
           <a:xfrm>
-            <a:off x="731520" y="457200"/>
-            <a:ext cx="10728655" cy="731520"/>
+            <a:off x="731520" y="411480"/>
+            <a:ext cx="10728655" cy="685800"/>
           </a:xfrm>
           <a:prstGeom prst="rect">
             <a:avLst/>
@@ -4353,7 +5352,7 @@
           <a:lstStyle/>
           <a:p>
             <a:pPr>
-              <a:defRPr sz="3400" b="1">
+              <a:defRPr sz="3200" b="1">
                 <a:solidFill>
                   <a:srgbClr val="DB2777"/>
                 </a:solidFill>
@@ -4368,14 +5367,57 @@
       </p:sp>
       <p:sp>
         <p:nvSpPr>
-          <p:cNvPr id="3" name="TextBox 2"/>
+          <p:cNvPr id="3" name="Rectangle 2"/>
+          <p:cNvSpPr/>
+          <p:nvPr/>
+        </p:nvSpPr>
+        <p:spPr>
+          <a:xfrm>
+            <a:off x="731520" y="1417320"/>
+            <a:ext cx="45720" cy="1463040"/>
+          </a:xfrm>
+          <a:prstGeom prst="rect">
+            <a:avLst/>
+          </a:prstGeom>
+          <a:solidFill>
+            <a:srgbClr val="DB2777"/>
+          </a:solidFill>
+          <a:ln>
+            <a:noFill/>
+          </a:ln>
+        </p:spPr>
+        <p:style>
+          <a:lnRef idx="1">
+            <a:schemeClr val="accent1"/>
+          </a:lnRef>
+          <a:fillRef idx="3">
+            <a:schemeClr val="accent1"/>
+          </a:fillRef>
+          <a:effectRef idx="2">
+            <a:schemeClr val="accent1"/>
+          </a:effectRef>
+          <a:fontRef idx="minor">
+            <a:schemeClr val="lt1"/>
+          </a:fontRef>
+        </p:style>
+        <p:txBody>
+          <a:bodyPr rtlCol="0" anchor="ctr"/>
+          <a:lstStyle/>
+          <a:p>
+            <a:pPr algn="ctr"/>
+          </a:p>
+        </p:txBody>
+      </p:sp>
+      <p:sp>
+        <p:nvSpPr>
+          <p:cNvPr id="4" name="TextBox 3"/>
           <p:cNvSpPr txBox="1"/>
           <p:nvPr/>
         </p:nvSpPr>
         <p:spPr>
           <a:xfrm>
-            <a:off x="731520" y="1463040"/>
-            <a:ext cx="10728655" cy="4754880"/>
+            <a:off x="896112" y="1417320"/>
+            <a:ext cx="10564063" cy="1463040"/>
           </a:xfrm>
           <a:prstGeom prst="rect">
             <a:avLst/>
@@ -4390,9 +5432,9 @@
           <a:p>
             <a:pPr>
               <a:spcAft>
-                <a:spcPts val="600"/>
+                <a:spcPts val="300"/>
               </a:spcAft>
-              <a:defRPr b="1" i="0" sz="2600">
+              <a:defRPr b="1" sz="2400">
                 <a:solidFill>
                   <a:srgbClr val="0F172A"/>
                 </a:solidFill>
@@ -4405,10 +5447,93 @@
           </a:p>
           <a:p>
             <a:pPr>
+              <a:defRPr i="1" sz="2400">
+                <a:solidFill>
+                  <a:srgbClr val="0F172A"/>
+                </a:solidFill>
+                <a:latin typeface="Montserrat"/>
+              </a:defRPr>
+            </a:pPr>
+            <a:r>
+              <a:t>The two maps illustrate how Stokeford developed over an 80-year period.</a:t>
+            </a:r>
+            <a:br/>
+            <a:r>
+              <a:t>The two floor plans compare the layout of the library with its current configuration.</a:t>
+            </a:r>
+          </a:p>
+        </p:txBody>
+      </p:sp>
+      <p:sp>
+        <p:nvSpPr>
+          <p:cNvPr id="5" name="Rectangle 4"/>
+          <p:cNvSpPr/>
+          <p:nvPr/>
+        </p:nvSpPr>
+        <p:spPr>
+          <a:xfrm>
+            <a:off x="731520" y="3291840"/>
+            <a:ext cx="45720" cy="1645920"/>
+          </a:xfrm>
+          <a:prstGeom prst="rect">
+            <a:avLst/>
+          </a:prstGeom>
+          <a:solidFill>
+            <a:srgbClr val="DB2777"/>
+          </a:solidFill>
+          <a:ln>
+            <a:noFill/>
+          </a:ln>
+        </p:spPr>
+        <p:style>
+          <a:lnRef idx="1">
+            <a:schemeClr val="accent1"/>
+          </a:lnRef>
+          <a:fillRef idx="3">
+            <a:schemeClr val="accent1"/>
+          </a:fillRef>
+          <a:effectRef idx="2">
+            <a:schemeClr val="accent1"/>
+          </a:effectRef>
+          <a:fontRef idx="minor">
+            <a:schemeClr val="lt1"/>
+          </a:fontRef>
+        </p:style>
+        <p:txBody>
+          <a:bodyPr rtlCol="0" anchor="ctr"/>
+          <a:lstStyle/>
+          <a:p>
+            <a:pPr algn="ctr"/>
+          </a:p>
+        </p:txBody>
+      </p:sp>
+      <p:sp>
+        <p:nvSpPr>
+          <p:cNvPr id="6" name="TextBox 5"/>
+          <p:cNvSpPr txBox="1"/>
+          <p:nvPr/>
+        </p:nvSpPr>
+        <p:spPr>
+          <a:xfrm>
+            <a:off x="896112" y="3291840"/>
+            <a:ext cx="10564063" cy="1645920"/>
+          </a:xfrm>
+          <a:prstGeom prst="rect">
+            <a:avLst/>
+          </a:prstGeom>
+          <a:noFill/>
+        </p:spPr>
+        <p:txBody>
+          <a:bodyPr wrap="square" lIns="0" tIns="0" rIns="0" bIns="0">
+            <a:spAutoFit/>
+          </a:bodyPr>
+          <a:lstStyle/>
+          <a:p>
+            <a:pPr>
               <a:spcAft>
-                <a:spcPts val="800"/>
+                <a:spcPts val="300"/>
               </a:spcAft>
-              <a:defRPr b="0" i="1" sz="2400">
+              <a:defRPr b="1" sz="2400">
                 <a:solidFill>
                   <a:srgbClr val="0F172A"/>
                 </a:solidFill>
@@ -4416,15 +5541,12 @@
               </a:defRPr>
             </a:pPr>
             <a:r>
-              <a:t>The two maps illustrate how Stokeford developed over an 80-year period from 1930 to 2010.</a:t>
-            </a:r>
-          </a:p>
-          <a:p>
-            <a:pPr>
-              <a:spcAft>
-                <a:spcPts val="2400"/>
-              </a:spcAft>
-              <a:defRPr b="0" i="1" sz="2400">
+              <a:t>OVERVIEW (2 CÂU BỨC TRANH TỔNG THỂ)</a:t>
+            </a:r>
+          </a:p>
+          <a:p>
+            <a:pPr>
+              <a:defRPr i="1" sz="2400">
                 <a:solidFill>
                   <a:srgbClr val="0F172A"/>
                 </a:solidFill>
@@ -4432,55 +5554,11 @@
               </a:defRPr>
             </a:pPr>
             <a:r>
-              <a:t>The two floor plans compare the layout of the library 20 years ago with its current configuration.</a:t>
-            </a:r>
-          </a:p>
-          <a:p>
-            <a:pPr>
-              <a:spcAft>
-                <a:spcPts val="600"/>
-              </a:spcAft>
-              <a:defRPr b="1" i="0" sz="2600">
-                <a:solidFill>
-                  <a:srgbClr val="0F172A"/>
-                </a:solidFill>
-                <a:latin typeface="Montserrat"/>
-              </a:defRPr>
-            </a:pPr>
-            <a:r>
-              <a:t>OVERVIEW (2 CÂU BỨC TRANH TỔNG THỂ)</a:t>
-            </a:r>
-          </a:p>
-          <a:p>
-            <a:pPr>
-              <a:spcAft>
-                <a:spcPts val="800"/>
-              </a:spcAft>
-              <a:defRPr b="0" i="1" sz="2400">
-                <a:solidFill>
-                  <a:srgbClr val="0F172A"/>
-                </a:solidFill>
-                <a:latin typeface="Montserrat"/>
-              </a:defRPr>
-            </a:pPr>
-            <a:r>
-              <a:t>Overall, the village underwent a dramatic transformation from a rural community into a residential area.</a:t>
-            </a:r>
-          </a:p>
-          <a:p>
-            <a:pPr>
-              <a:spcAft>
-                <a:spcPts val="0"/>
-              </a:spcAft>
-              <a:defRPr b="0" i="1" sz="2400">
-                <a:solidFill>
-                  <a:srgbClr val="0F172A"/>
-                </a:solidFill>
-                <a:latin typeface="Montserrat"/>
-              </a:defRPr>
-            </a:pPr>
-            <a:r>
-              <a:t>The most notable changes include the complete clearance of farmland to construct new housing.</a:t>
+              <a:t>Overall, the village underwent a transformation from a rural into a residential area.</a:t>
+            </a:r>
+            <a:br/>
+            <a:r>
+              <a:t>The most notable changes include the complete clearance of farmland for new housing.</a:t>
             </a:r>
           </a:p>
         </p:txBody>
@@ -4519,8 +5597,8 @@
         </p:nvSpPr>
         <p:spPr>
           <a:xfrm>
-            <a:off x="731520" y="457200"/>
-            <a:ext cx="10728655" cy="731520"/>
+            <a:off x="731520" y="411480"/>
+            <a:ext cx="10728655" cy="685800"/>
           </a:xfrm>
           <a:prstGeom prst="rect">
             <a:avLst/>
@@ -4534,7 +5612,7 @@
           <a:lstStyle/>
           <a:p>
             <a:pPr>
-              <a:defRPr sz="3400" b="1">
+              <a:defRPr sz="3200" b="1">
                 <a:solidFill>
                   <a:srgbClr val="DC2626"/>
                 </a:solidFill>
@@ -4563,8 +5641,8 @@
         </p:blipFill>
         <p:spPr>
           <a:xfrm>
-            <a:off x="731520" y="1554480"/>
-            <a:ext cx="3291840" cy="3340249"/>
+            <a:off x="731520" y="1463040"/>
+            <a:ext cx="3474720" cy="3525819"/>
           </a:xfrm>
           <a:prstGeom prst="rect">
             <a:avLst/>
@@ -4573,14 +5651,57 @@
       </p:pic>
       <p:sp>
         <p:nvSpPr>
-          <p:cNvPr id="4" name="TextBox 3"/>
+          <p:cNvPr id="4" name="Rectangle 3"/>
+          <p:cNvSpPr/>
+          <p:nvPr/>
+        </p:nvSpPr>
+        <p:spPr>
+          <a:xfrm>
+            <a:off x="4572000" y="1371600"/>
+            <a:ext cx="45720" cy="960120"/>
+          </a:xfrm>
+          <a:prstGeom prst="rect">
+            <a:avLst/>
+          </a:prstGeom>
+          <a:solidFill>
+            <a:srgbClr val="DC2626"/>
+          </a:solidFill>
+          <a:ln>
+            <a:noFill/>
+          </a:ln>
+        </p:spPr>
+        <p:style>
+          <a:lnRef idx="1">
+            <a:schemeClr val="accent1"/>
+          </a:lnRef>
+          <a:fillRef idx="3">
+            <a:schemeClr val="accent1"/>
+          </a:fillRef>
+          <a:effectRef idx="2">
+            <a:schemeClr val="accent1"/>
+          </a:effectRef>
+          <a:fontRef idx="minor">
+            <a:schemeClr val="lt1"/>
+          </a:fontRef>
+        </p:style>
+        <p:txBody>
+          <a:bodyPr rtlCol="0" anchor="ctr"/>
+          <a:lstStyle/>
+          <a:p>
+            <a:pPr algn="ctr"/>
+          </a:p>
+        </p:txBody>
+      </p:sp>
+      <p:sp>
+        <p:nvSpPr>
+          <p:cNvPr id="5" name="TextBox 4"/>
           <p:cNvSpPr txBox="1"/>
           <p:nvPr/>
         </p:nvSpPr>
         <p:spPr>
           <a:xfrm>
-            <a:off x="4389120" y="1463040"/>
-            <a:ext cx="7040880" cy="4754880"/>
+            <a:off x="4736592" y="1371600"/>
+            <a:ext cx="6693408" cy="960120"/>
           </a:xfrm>
           <a:prstGeom prst="rect">
             <a:avLst/>
@@ -4595,9 +5716,9 @@
           <a:p>
             <a:pPr>
               <a:spcAft>
-                <a:spcPts val="400"/>
+                <a:spcPts val="300"/>
               </a:spcAft>
-              <a:defRPr b="1" i="0" sz="2600">
+              <a:defRPr b="1" sz="2400">
                 <a:solidFill>
                   <a:srgbClr val="0F172A"/>
                 </a:solidFill>
@@ -4610,10 +5731,89 @@
           </a:p>
           <a:p>
             <a:pPr>
+              <a:defRPr i="1" sz="2400">
+                <a:solidFill>
+                  <a:srgbClr val="0F172A"/>
+                </a:solidFill>
+                <a:latin typeface="Montserrat"/>
+              </a:defRPr>
+            </a:pPr>
+            <a:r>
+              <a:t>in the northern part of the village / in the south-west</a:t>
+            </a:r>
+          </a:p>
+        </p:txBody>
+      </p:sp>
+      <p:sp>
+        <p:nvSpPr>
+          <p:cNvPr id="6" name="Rectangle 5"/>
+          <p:cNvSpPr/>
+          <p:nvPr/>
+        </p:nvSpPr>
+        <p:spPr>
+          <a:xfrm>
+            <a:off x="4572000" y="2560320"/>
+            <a:ext cx="45720" cy="960120"/>
+          </a:xfrm>
+          <a:prstGeom prst="rect">
+            <a:avLst/>
+          </a:prstGeom>
+          <a:solidFill>
+            <a:srgbClr val="DC2626"/>
+          </a:solidFill>
+          <a:ln>
+            <a:noFill/>
+          </a:ln>
+        </p:spPr>
+        <p:style>
+          <a:lnRef idx="1">
+            <a:schemeClr val="accent1"/>
+          </a:lnRef>
+          <a:fillRef idx="3">
+            <a:schemeClr val="accent1"/>
+          </a:fillRef>
+          <a:effectRef idx="2">
+            <a:schemeClr val="accent1"/>
+          </a:effectRef>
+          <a:fontRef idx="minor">
+            <a:schemeClr val="lt1"/>
+          </a:fontRef>
+        </p:style>
+        <p:txBody>
+          <a:bodyPr rtlCol="0" anchor="ctr"/>
+          <a:lstStyle/>
+          <a:p>
+            <a:pPr algn="ctr"/>
+          </a:p>
+        </p:txBody>
+      </p:sp>
+      <p:sp>
+        <p:nvSpPr>
+          <p:cNvPr id="7" name="TextBox 6"/>
+          <p:cNvSpPr txBox="1"/>
+          <p:nvPr/>
+        </p:nvSpPr>
+        <p:spPr>
+          <a:xfrm>
+            <a:off x="4736592" y="2560320"/>
+            <a:ext cx="6693408" cy="960120"/>
+          </a:xfrm>
+          <a:prstGeom prst="rect">
+            <a:avLst/>
+          </a:prstGeom>
+          <a:noFill/>
+        </p:spPr>
+        <p:txBody>
+          <a:bodyPr wrap="square" lIns="0" tIns="0" rIns="0" bIns="0">
+            <a:spAutoFit/>
+          </a:bodyPr>
+          <a:lstStyle/>
+          <a:p>
+            <a:pPr>
               <a:spcAft>
-                <a:spcPts val="1800"/>
+                <a:spcPts val="300"/>
               </a:spcAft>
-              <a:defRPr b="0" i="1" sz="2400">
+              <a:defRPr b="1" sz="2400">
                 <a:solidFill>
                   <a:srgbClr val="0F172A"/>
                 </a:solidFill>
@@ -4621,15 +5821,94 @@
               </a:defRPr>
             </a:pPr>
             <a:r>
-              <a:t>in the northern part of the village / in the south-west</a:t>
-            </a:r>
-          </a:p>
+              <a:t>IN THE NORTH ➔ NẰM TRONG RANH GIỚI</a:t>
+            </a:r>
+          </a:p>
+          <a:p>
+            <a:pPr>
+              <a:defRPr i="1" sz="2400">
+                <a:solidFill>
+                  <a:srgbClr val="0F172A"/>
+                </a:solidFill>
+                <a:latin typeface="Montserrat"/>
+              </a:defRPr>
+            </a:pPr>
+            <a:r>
+              <a:t>A new hospital was built in the north of the town.</a:t>
+            </a:r>
+          </a:p>
+        </p:txBody>
+      </p:sp>
+      <p:sp>
+        <p:nvSpPr>
+          <p:cNvPr id="8" name="Rectangle 7"/>
+          <p:cNvSpPr/>
+          <p:nvPr/>
+        </p:nvSpPr>
+        <p:spPr>
+          <a:xfrm>
+            <a:off x="4572000" y="3749039"/>
+            <a:ext cx="45720" cy="960120"/>
+          </a:xfrm>
+          <a:prstGeom prst="rect">
+            <a:avLst/>
+          </a:prstGeom>
+          <a:solidFill>
+            <a:srgbClr val="DC2626"/>
+          </a:solidFill>
+          <a:ln>
+            <a:noFill/>
+          </a:ln>
+        </p:spPr>
+        <p:style>
+          <a:lnRef idx="1">
+            <a:schemeClr val="accent1"/>
+          </a:lnRef>
+          <a:fillRef idx="3">
+            <a:schemeClr val="accent1"/>
+          </a:fillRef>
+          <a:effectRef idx="2">
+            <a:schemeClr val="accent1"/>
+          </a:effectRef>
+          <a:fontRef idx="minor">
+            <a:schemeClr val="lt1"/>
+          </a:fontRef>
+        </p:style>
+        <p:txBody>
+          <a:bodyPr rtlCol="0" anchor="ctr"/>
+          <a:lstStyle/>
+          <a:p>
+            <a:pPr algn="ctr"/>
+          </a:p>
+        </p:txBody>
+      </p:sp>
+      <p:sp>
+        <p:nvSpPr>
+          <p:cNvPr id="9" name="TextBox 8"/>
+          <p:cNvSpPr txBox="1"/>
+          <p:nvPr/>
+        </p:nvSpPr>
+        <p:spPr>
+          <a:xfrm>
+            <a:off x="4736592" y="3749039"/>
+            <a:ext cx="6693408" cy="960120"/>
+          </a:xfrm>
+          <a:prstGeom prst="rect">
+            <a:avLst/>
+          </a:prstGeom>
+          <a:noFill/>
+        </p:spPr>
+        <p:txBody>
+          <a:bodyPr wrap="square" lIns="0" tIns="0" rIns="0" bIns="0">
+            <a:spAutoFit/>
+          </a:bodyPr>
+          <a:lstStyle/>
           <a:p>
             <a:pPr>
               <a:spcAft>
-                <a:spcPts val="400"/>
+                <a:spcPts val="300"/>
               </a:spcAft>
-              <a:defRPr b="1" i="0" sz="2600">
+              <a:defRPr b="1" sz="2400">
                 <a:solidFill>
                   <a:srgbClr val="0F172A"/>
                 </a:solidFill>
@@ -4637,15 +5916,94 @@
               </a:defRPr>
             </a:pPr>
             <a:r>
-              <a:t>IN THE NORTH ➔ NẰM TRONG RANH GIỚI</a:t>
-            </a:r>
-          </a:p>
+              <a:t>TO THE NORTH ➔ NẰM TÁCH BIỆT BÊN NGOÀI</a:t>
+            </a:r>
+          </a:p>
+          <a:p>
+            <a:pPr>
+              <a:defRPr i="1" sz="2400">
+                <a:solidFill>
+                  <a:srgbClr val="0F172A"/>
+                </a:solidFill>
+                <a:latin typeface="Montserrat"/>
+              </a:defRPr>
+            </a:pPr>
+            <a:r>
+              <a:t>A dense forest lies to the north of the town.</a:t>
+            </a:r>
+          </a:p>
+        </p:txBody>
+      </p:sp>
+      <p:sp>
+        <p:nvSpPr>
+          <p:cNvPr id="10" name="Rectangle 9"/>
+          <p:cNvSpPr/>
+          <p:nvPr/>
+        </p:nvSpPr>
+        <p:spPr>
+          <a:xfrm>
+            <a:off x="4572000" y="4937760"/>
+            <a:ext cx="45720" cy="960120"/>
+          </a:xfrm>
+          <a:prstGeom prst="rect">
+            <a:avLst/>
+          </a:prstGeom>
+          <a:solidFill>
+            <a:srgbClr val="DC2626"/>
+          </a:solidFill>
+          <a:ln>
+            <a:noFill/>
+          </a:ln>
+        </p:spPr>
+        <p:style>
+          <a:lnRef idx="1">
+            <a:schemeClr val="accent1"/>
+          </a:lnRef>
+          <a:fillRef idx="3">
+            <a:schemeClr val="accent1"/>
+          </a:fillRef>
+          <a:effectRef idx="2">
+            <a:schemeClr val="accent1"/>
+          </a:effectRef>
+          <a:fontRef idx="minor">
+            <a:schemeClr val="lt1"/>
+          </a:fontRef>
+        </p:style>
+        <p:txBody>
+          <a:bodyPr rtlCol="0" anchor="ctr"/>
+          <a:lstStyle/>
+          <a:p>
+            <a:pPr algn="ctr"/>
+          </a:p>
+        </p:txBody>
+      </p:sp>
+      <p:sp>
+        <p:nvSpPr>
+          <p:cNvPr id="11" name="TextBox 10"/>
+          <p:cNvSpPr txBox="1"/>
+          <p:nvPr/>
+        </p:nvSpPr>
+        <p:spPr>
+          <a:xfrm>
+            <a:off x="4736592" y="4937760"/>
+            <a:ext cx="6693408" cy="960120"/>
+          </a:xfrm>
+          <a:prstGeom prst="rect">
+            <a:avLst/>
+          </a:prstGeom>
+          <a:noFill/>
+        </p:spPr>
+        <p:txBody>
+          <a:bodyPr wrap="square" lIns="0" tIns="0" rIns="0" bIns="0">
+            <a:spAutoFit/>
+          </a:bodyPr>
+          <a:lstStyle/>
           <a:p>
             <a:pPr>
               <a:spcAft>
-                <a:spcPts val="1800"/>
+                <a:spcPts val="300"/>
               </a:spcAft>
-              <a:defRPr b="0" i="1" sz="2400">
+              <a:defRPr b="1" sz="2400">
                 <a:solidFill>
                   <a:srgbClr val="0F172A"/>
                 </a:solidFill>
@@ -4653,63 +6011,12 @@
               </a:defRPr>
             </a:pPr>
             <a:r>
-              <a:t>A new hospital was built in the north of the town.</a:t>
-            </a:r>
-          </a:p>
-          <a:p>
-            <a:pPr>
-              <a:spcAft>
-                <a:spcPts val="400"/>
-              </a:spcAft>
-              <a:defRPr b="1" i="0" sz="2600">
-                <a:solidFill>
-                  <a:srgbClr val="0F172A"/>
-                </a:solidFill>
-                <a:latin typeface="Montserrat"/>
-              </a:defRPr>
-            </a:pPr>
-            <a:r>
-              <a:t>TO THE NORTH ➔ NẰM TÁCH BIỆT BÊN NGOÀI</a:t>
-            </a:r>
-          </a:p>
-          <a:p>
-            <a:pPr>
-              <a:spcAft>
-                <a:spcPts val="1800"/>
-              </a:spcAft>
-              <a:defRPr b="0" i="1" sz="2400">
-                <a:solidFill>
-                  <a:srgbClr val="0F172A"/>
-                </a:solidFill>
-                <a:latin typeface="Montserrat"/>
-              </a:defRPr>
-            </a:pPr>
-            <a:r>
-              <a:t>A dense forest lies to the north of the town.</a:t>
-            </a:r>
-          </a:p>
-          <a:p>
-            <a:pPr>
-              <a:spcAft>
-                <a:spcPts val="400"/>
-              </a:spcAft>
-              <a:defRPr b="1" i="0" sz="2600">
-                <a:solidFill>
-                  <a:srgbClr val="0F172A"/>
-                </a:solidFill>
-                <a:latin typeface="Montserrat"/>
-              </a:defRPr>
-            </a:pPr>
-            <a:r>
               <a:t>ADJACENT TO (SÁT CẠNH) ➔ OPPOSITE (ĐỐI DIỆN)</a:t>
             </a:r>
           </a:p>
           <a:p>
             <a:pPr>
-              <a:spcAft>
-                <a:spcPts val="0"/>
-              </a:spcAft>
-              <a:defRPr b="0" i="1" sz="2400">
+              <a:defRPr i="1" sz="2400">
                 <a:solidFill>
                   <a:srgbClr val="0F172A"/>
                 </a:solidFill>
@@ -4756,8 +6063,8 @@
         </p:nvSpPr>
         <p:spPr>
           <a:xfrm>
-            <a:off x="731520" y="457200"/>
-            <a:ext cx="10728655" cy="731520"/>
+            <a:off x="731520" y="411480"/>
+            <a:ext cx="10728655" cy="685800"/>
           </a:xfrm>
           <a:prstGeom prst="rect">
             <a:avLst/>
@@ -4771,7 +6078,7 @@
           <a:lstStyle/>
           <a:p>
             <a:pPr>
-              <a:defRPr sz="3400" b="1">
+              <a:defRPr sz="3200" b="1">
                 <a:solidFill>
                   <a:srgbClr val="7C3AED"/>
                 </a:solidFill>
@@ -4800,7 +6107,7 @@
         </p:blipFill>
         <p:spPr>
           <a:xfrm>
-            <a:off x="731520" y="1463040"/>
+            <a:off x="731520" y="1371600"/>
             <a:ext cx="4023360" cy="4571064"/>
           </a:xfrm>
           <a:prstGeom prst="rect">
@@ -4810,14 +6117,57 @@
       </p:pic>
       <p:sp>
         <p:nvSpPr>
-          <p:cNvPr id="4" name="TextBox 3"/>
+          <p:cNvPr id="4" name="Rectangle 3"/>
+          <p:cNvSpPr/>
+          <p:nvPr/>
+        </p:nvSpPr>
+        <p:spPr>
+          <a:xfrm>
+            <a:off x="5120640" y="1371600"/>
+            <a:ext cx="45720" cy="960120"/>
+          </a:xfrm>
+          <a:prstGeom prst="rect">
+            <a:avLst/>
+          </a:prstGeom>
+          <a:solidFill>
+            <a:srgbClr val="7C3AED"/>
+          </a:solidFill>
+          <a:ln>
+            <a:noFill/>
+          </a:ln>
+        </p:spPr>
+        <p:style>
+          <a:lnRef idx="1">
+            <a:schemeClr val="accent1"/>
+          </a:lnRef>
+          <a:fillRef idx="3">
+            <a:schemeClr val="accent1"/>
+          </a:fillRef>
+          <a:effectRef idx="2">
+            <a:schemeClr val="accent1"/>
+          </a:effectRef>
+          <a:fontRef idx="minor">
+            <a:schemeClr val="lt1"/>
+          </a:fontRef>
+        </p:style>
+        <p:txBody>
+          <a:bodyPr rtlCol="0" anchor="ctr"/>
+          <a:lstStyle/>
+          <a:p>
+            <a:pPr algn="ctr"/>
+          </a:p>
+        </p:txBody>
+      </p:sp>
+      <p:sp>
+        <p:nvSpPr>
+          <p:cNvPr id="5" name="TextBox 4"/>
           <p:cNvSpPr txBox="1"/>
           <p:nvPr/>
         </p:nvSpPr>
         <p:spPr>
           <a:xfrm>
-            <a:off x="5120640" y="1463040"/>
-            <a:ext cx="6309360" cy="4754880"/>
+            <a:off x="5285232" y="1371600"/>
+            <a:ext cx="6144768" cy="960120"/>
           </a:xfrm>
           <a:prstGeom prst="rect">
             <a:avLst/>
@@ -4832,9 +6182,9 @@
           <a:p>
             <a:pPr>
               <a:spcAft>
-                <a:spcPts val="400"/>
+                <a:spcPts val="300"/>
               </a:spcAft>
-              <a:defRPr b="1" i="0" sz="2600">
+              <a:defRPr b="1" sz="2400">
                 <a:solidFill>
                   <a:srgbClr val="0F172A"/>
                 </a:solidFill>
@@ -4847,10 +6197,89 @@
           </a:p>
           <a:p>
             <a:pPr>
+              <a:defRPr i="1" sz="2400">
+                <a:solidFill>
+                  <a:srgbClr val="0F172A"/>
+                </a:solidFill>
+                <a:latin typeface="Montserrat"/>
+              </a:defRPr>
+            </a:pPr>
+            <a:r>
+              <a:t>To the immediate left / right of the entrance</a:t>
+            </a:r>
+          </a:p>
+        </p:txBody>
+      </p:sp>
+      <p:sp>
+        <p:nvSpPr>
+          <p:cNvPr id="6" name="Rectangle 5"/>
+          <p:cNvSpPr/>
+          <p:nvPr/>
+        </p:nvSpPr>
+        <p:spPr>
+          <a:xfrm>
+            <a:off x="5120640" y="2560320"/>
+            <a:ext cx="45720" cy="960120"/>
+          </a:xfrm>
+          <a:prstGeom prst="rect">
+            <a:avLst/>
+          </a:prstGeom>
+          <a:solidFill>
+            <a:srgbClr val="7C3AED"/>
+          </a:solidFill>
+          <a:ln>
+            <a:noFill/>
+          </a:ln>
+        </p:spPr>
+        <p:style>
+          <a:lnRef idx="1">
+            <a:schemeClr val="accent1"/>
+          </a:lnRef>
+          <a:fillRef idx="3">
+            <a:schemeClr val="accent1"/>
+          </a:fillRef>
+          <a:effectRef idx="2">
+            <a:schemeClr val="accent1"/>
+          </a:effectRef>
+          <a:fontRef idx="minor">
+            <a:schemeClr val="lt1"/>
+          </a:fontRef>
+        </p:style>
+        <p:txBody>
+          <a:bodyPr rtlCol="0" anchor="ctr"/>
+          <a:lstStyle/>
+          <a:p>
+            <a:pPr algn="ctr"/>
+          </a:p>
+        </p:txBody>
+      </p:sp>
+      <p:sp>
+        <p:nvSpPr>
+          <p:cNvPr id="7" name="TextBox 6"/>
+          <p:cNvSpPr txBox="1"/>
+          <p:nvPr/>
+        </p:nvSpPr>
+        <p:spPr>
+          <a:xfrm>
+            <a:off x="5285232" y="2560320"/>
+            <a:ext cx="6144768" cy="960120"/>
+          </a:xfrm>
+          <a:prstGeom prst="rect">
+            <a:avLst/>
+          </a:prstGeom>
+          <a:noFill/>
+        </p:spPr>
+        <p:txBody>
+          <a:bodyPr wrap="square" lIns="0" tIns="0" rIns="0" bIns="0">
+            <a:spAutoFit/>
+          </a:bodyPr>
+          <a:lstStyle/>
+          <a:p>
+            <a:pPr>
               <a:spcAft>
-                <a:spcPts val="1800"/>
+                <a:spcPts val="300"/>
               </a:spcAft>
-              <a:defRPr b="0" i="1" sz="2400">
+              <a:defRPr b="1" sz="2400">
                 <a:solidFill>
                   <a:srgbClr val="0F172A"/>
                 </a:solidFill>
@@ -4858,15 +6287,94 @@
               </a:defRPr>
             </a:pPr>
             <a:r>
-              <a:t>To the immediate left / right of the entrance</a:t>
-            </a:r>
-          </a:p>
+              <a:t>KHU VỰC CHÍNH GIỮA PHÒNG</a:t>
+            </a:r>
+          </a:p>
+          <a:p>
+            <a:pPr>
+              <a:defRPr i="1" sz="2400">
+                <a:solidFill>
+                  <a:srgbClr val="0F172A"/>
+                </a:solidFill>
+                <a:latin typeface="Montserrat"/>
+              </a:defRPr>
+            </a:pPr>
+            <a:r>
+              <a:t>In the center / middle / heart of the library</a:t>
+            </a:r>
+          </a:p>
+        </p:txBody>
+      </p:sp>
+      <p:sp>
+        <p:nvSpPr>
+          <p:cNvPr id="8" name="Rectangle 7"/>
+          <p:cNvSpPr/>
+          <p:nvPr/>
+        </p:nvSpPr>
+        <p:spPr>
+          <a:xfrm>
+            <a:off x="5120640" y="3749039"/>
+            <a:ext cx="45720" cy="960120"/>
+          </a:xfrm>
+          <a:prstGeom prst="rect">
+            <a:avLst/>
+          </a:prstGeom>
+          <a:solidFill>
+            <a:srgbClr val="7C3AED"/>
+          </a:solidFill>
+          <a:ln>
+            <a:noFill/>
+          </a:ln>
+        </p:spPr>
+        <p:style>
+          <a:lnRef idx="1">
+            <a:schemeClr val="accent1"/>
+          </a:lnRef>
+          <a:fillRef idx="3">
+            <a:schemeClr val="accent1"/>
+          </a:fillRef>
+          <a:effectRef idx="2">
+            <a:schemeClr val="accent1"/>
+          </a:effectRef>
+          <a:fontRef idx="minor">
+            <a:schemeClr val="lt1"/>
+          </a:fontRef>
+        </p:style>
+        <p:txBody>
+          <a:bodyPr rtlCol="0" anchor="ctr"/>
+          <a:lstStyle/>
+          <a:p>
+            <a:pPr algn="ctr"/>
+          </a:p>
+        </p:txBody>
+      </p:sp>
+      <p:sp>
+        <p:nvSpPr>
+          <p:cNvPr id="9" name="TextBox 8"/>
+          <p:cNvSpPr txBox="1"/>
+          <p:nvPr/>
+        </p:nvSpPr>
+        <p:spPr>
+          <a:xfrm>
+            <a:off x="5285232" y="3749039"/>
+            <a:ext cx="6144768" cy="960120"/>
+          </a:xfrm>
+          <a:prstGeom prst="rect">
+            <a:avLst/>
+          </a:prstGeom>
+          <a:noFill/>
+        </p:spPr>
+        <p:txBody>
+          <a:bodyPr wrap="square" lIns="0" tIns="0" rIns="0" bIns="0">
+            <a:spAutoFit/>
+          </a:bodyPr>
+          <a:lstStyle/>
           <a:p>
             <a:pPr>
               <a:spcAft>
-                <a:spcPts val="400"/>
+                <a:spcPts val="300"/>
               </a:spcAft>
-              <a:defRPr b="1" i="0" sz="2600">
+              <a:defRPr b="1" sz="2400">
                 <a:solidFill>
                   <a:srgbClr val="0F172A"/>
                 </a:solidFill>
@@ -4874,15 +6382,94 @@
               </a:defRPr>
             </a:pPr>
             <a:r>
-              <a:t>KHU VỰC CHÍNH GIỮA PHÒNG</a:t>
-            </a:r>
-          </a:p>
+              <a:t>DỌC THEO CÁC BỨC TƯỜNG HAI BÊN</a:t>
+            </a:r>
+          </a:p>
+          <a:p>
+            <a:pPr>
+              <a:defRPr i="1" sz="2400">
+                <a:solidFill>
+                  <a:srgbClr val="0F172A"/>
+                </a:solidFill>
+                <a:latin typeface="Montserrat"/>
+              </a:defRPr>
+            </a:pPr>
+            <a:r>
+              <a:t>Along the left-hand / right-hand wall</a:t>
+            </a:r>
+          </a:p>
+        </p:txBody>
+      </p:sp>
+      <p:sp>
+        <p:nvSpPr>
+          <p:cNvPr id="10" name="Rectangle 9"/>
+          <p:cNvSpPr/>
+          <p:nvPr/>
+        </p:nvSpPr>
+        <p:spPr>
+          <a:xfrm>
+            <a:off x="5120640" y="4937760"/>
+            <a:ext cx="45720" cy="960120"/>
+          </a:xfrm>
+          <a:prstGeom prst="rect">
+            <a:avLst/>
+          </a:prstGeom>
+          <a:solidFill>
+            <a:srgbClr val="7C3AED"/>
+          </a:solidFill>
+          <a:ln>
+            <a:noFill/>
+          </a:ln>
+        </p:spPr>
+        <p:style>
+          <a:lnRef idx="1">
+            <a:schemeClr val="accent1"/>
+          </a:lnRef>
+          <a:fillRef idx="3">
+            <a:schemeClr val="accent1"/>
+          </a:fillRef>
+          <a:effectRef idx="2">
+            <a:schemeClr val="accent1"/>
+          </a:effectRef>
+          <a:fontRef idx="minor">
+            <a:schemeClr val="lt1"/>
+          </a:fontRef>
+        </p:style>
+        <p:txBody>
+          <a:bodyPr rtlCol="0" anchor="ctr"/>
+          <a:lstStyle/>
+          <a:p>
+            <a:pPr algn="ctr"/>
+          </a:p>
+        </p:txBody>
+      </p:sp>
+      <p:sp>
+        <p:nvSpPr>
+          <p:cNvPr id="11" name="TextBox 10"/>
+          <p:cNvSpPr txBox="1"/>
+          <p:nvPr/>
+        </p:nvSpPr>
+        <p:spPr>
+          <a:xfrm>
+            <a:off x="5285232" y="4937760"/>
+            <a:ext cx="6144768" cy="960120"/>
+          </a:xfrm>
+          <a:prstGeom prst="rect">
+            <a:avLst/>
+          </a:prstGeom>
+          <a:noFill/>
+        </p:spPr>
+        <p:txBody>
+          <a:bodyPr wrap="square" lIns="0" tIns="0" rIns="0" bIns="0">
+            <a:spAutoFit/>
+          </a:bodyPr>
+          <a:lstStyle/>
           <a:p>
             <a:pPr>
               <a:spcAft>
-                <a:spcPts val="1800"/>
+                <a:spcPts val="300"/>
               </a:spcAft>
-              <a:defRPr b="0" i="1" sz="2400">
+              <a:defRPr b="1" sz="2400">
                 <a:solidFill>
                   <a:srgbClr val="0F172A"/>
                 </a:solidFill>
@@ -4890,63 +6477,12 @@
               </a:defRPr>
             </a:pPr>
             <a:r>
-              <a:t>In the center / middle / heart of the library</a:t>
-            </a:r>
-          </a:p>
-          <a:p>
-            <a:pPr>
-              <a:spcAft>
-                <a:spcPts val="400"/>
-              </a:spcAft>
-              <a:defRPr b="1" i="0" sz="2600">
-                <a:solidFill>
-                  <a:srgbClr val="0F172A"/>
-                </a:solidFill>
-                <a:latin typeface="Montserrat"/>
-              </a:defRPr>
-            </a:pPr>
-            <a:r>
-              <a:t>DỌC THEO CÁC BỨC TƯỜNG HAI BÊN</a:t>
-            </a:r>
-          </a:p>
-          <a:p>
-            <a:pPr>
-              <a:spcAft>
-                <a:spcPts val="1800"/>
-              </a:spcAft>
-              <a:defRPr b="0" i="1" sz="2400">
-                <a:solidFill>
-                  <a:srgbClr val="0F172A"/>
-                </a:solidFill>
-                <a:latin typeface="Montserrat"/>
-              </a:defRPr>
-            </a:pPr>
-            <a:r>
-              <a:t>Along the left-hand / right-hand wall</a:t>
-            </a:r>
-          </a:p>
-          <a:p>
-            <a:pPr>
-              <a:spcAft>
-                <a:spcPts val="400"/>
-              </a:spcAft>
-              <a:defRPr b="1" i="0" sz="2600">
-                <a:solidFill>
-                  <a:srgbClr val="0F172A"/>
-                </a:solidFill>
-                <a:latin typeface="Montserrat"/>
-              </a:defRPr>
-            </a:pPr>
-            <a:r>
               <a:t>HAI GÓC VÀ PHÍA CUỐI CĂN PHÒNG</a:t>
             </a:r>
           </a:p>
           <a:p>
             <a:pPr>
-              <a:spcAft>
-                <a:spcPts val="0"/>
-              </a:spcAft>
-              <a:defRPr b="0" i="1" sz="2400">
+              <a:defRPr i="1" sz="2400">
                 <a:solidFill>
                   <a:srgbClr val="0F172A"/>
                 </a:solidFill>
@@ -4993,8 +6529,8 @@
         </p:nvSpPr>
         <p:spPr>
           <a:xfrm>
-            <a:off x="731520" y="457200"/>
-            <a:ext cx="10728655" cy="731520"/>
+            <a:off x="731520" y="411480"/>
+            <a:ext cx="10728655" cy="685800"/>
           </a:xfrm>
           <a:prstGeom prst="rect">
             <a:avLst/>
@@ -5008,7 +6544,7 @@
           <a:lstStyle/>
           <a:p>
             <a:pPr>
-              <a:defRPr sz="3400" b="1">
+              <a:defRPr sz="3200" b="1">
                 <a:solidFill>
                   <a:srgbClr val="EA580C"/>
                 </a:solidFill>
@@ -5023,14 +6559,57 @@
       </p:sp>
       <p:sp>
         <p:nvSpPr>
-          <p:cNvPr id="3" name="TextBox 2"/>
+          <p:cNvPr id="3" name="Rectangle 2"/>
+          <p:cNvSpPr/>
+          <p:nvPr/>
+        </p:nvSpPr>
+        <p:spPr>
+          <a:xfrm>
+            <a:off x="731520" y="1463040"/>
+            <a:ext cx="45720" cy="1645920"/>
+          </a:xfrm>
+          <a:prstGeom prst="rect">
+            <a:avLst/>
+          </a:prstGeom>
+          <a:solidFill>
+            <a:srgbClr val="EA580C"/>
+          </a:solidFill>
+          <a:ln>
+            <a:noFill/>
+          </a:ln>
+        </p:spPr>
+        <p:style>
+          <a:lnRef idx="1">
+            <a:schemeClr val="accent1"/>
+          </a:lnRef>
+          <a:fillRef idx="3">
+            <a:schemeClr val="accent1"/>
+          </a:fillRef>
+          <a:effectRef idx="2">
+            <a:schemeClr val="accent1"/>
+          </a:effectRef>
+          <a:fontRef idx="minor">
+            <a:schemeClr val="lt1"/>
+          </a:fontRef>
+        </p:style>
+        <p:txBody>
+          <a:bodyPr rtlCol="0" anchor="ctr"/>
+          <a:lstStyle/>
+          <a:p>
+            <a:pPr algn="ctr"/>
+          </a:p>
+        </p:txBody>
+      </p:sp>
+      <p:sp>
+        <p:nvSpPr>
+          <p:cNvPr id="4" name="TextBox 3"/>
           <p:cNvSpPr txBox="1"/>
           <p:nvPr/>
         </p:nvSpPr>
         <p:spPr>
           <a:xfrm>
-            <a:off x="731520" y="1463040"/>
-            <a:ext cx="5120640" cy="4754880"/>
+            <a:off x="896112" y="1463040"/>
+            <a:ext cx="4956048" cy="1645920"/>
           </a:xfrm>
           <a:prstGeom prst="rect">
             <a:avLst/>
@@ -5045,9 +6624,9 @@
           <a:p>
             <a:pPr>
               <a:spcAft>
-                <a:spcPts val="400"/>
+                <a:spcPts val="300"/>
               </a:spcAft>
-              <a:defRPr b="1" i="0" sz="2600">
+              <a:defRPr b="1" sz="2400">
                 <a:solidFill>
                   <a:srgbClr val="0F172A"/>
                 </a:solidFill>
@@ -5060,10 +6639,7 @@
           </a:p>
           <a:p>
             <a:pPr>
-              <a:spcAft>
-                <a:spcPts val="400"/>
-              </a:spcAft>
-              <a:defRPr b="0" i="1" sz="2400">
+              <a:defRPr i="1" sz="2400">
                 <a:solidFill>
                   <a:srgbClr val="0F172A"/>
                 </a:solidFill>
@@ -5073,99 +6649,66 @@
             <a:r>
               <a:t>be constructed / erected / added</a:t>
             </a:r>
-          </a:p>
-          <a:p>
-            <a:pPr>
-              <a:spcAft>
-                <a:spcPts val="2000"/>
-              </a:spcAft>
-              <a:defRPr b="1" i="1" sz="2400">
-                <a:solidFill>
-                  <a:srgbClr val="0F172A"/>
-                </a:solidFill>
-                <a:latin typeface="Montserrat"/>
-              </a:defRPr>
-            </a:pPr>
+            <a:br/>
             <a:r>
               <a:t>the construction / addition of</a:t>
             </a:r>
           </a:p>
-          <a:p>
-            <a:pPr>
-              <a:spcAft>
-                <a:spcPts val="400"/>
-              </a:spcAft>
-              <a:defRPr b="1" i="0" sz="2600">
-                <a:solidFill>
-                  <a:srgbClr val="0F172A"/>
-                </a:solidFill>
-                <a:latin typeface="Montserrat"/>
-              </a:defRPr>
-            </a:pPr>
-            <a:r>
-              <a:t>2. PHÁ BỎ HOẶC DỌN TRỐNG</a:t>
-            </a:r>
-          </a:p>
-          <a:p>
-            <a:pPr>
-              <a:spcAft>
-                <a:spcPts val="400"/>
-              </a:spcAft>
-              <a:defRPr b="0" i="1" sz="2400">
-                <a:solidFill>
-                  <a:srgbClr val="0F172A"/>
-                </a:solidFill>
-                <a:latin typeface="Montserrat"/>
-              </a:defRPr>
-            </a:pPr>
-            <a:r>
-              <a:t>be demolished / knocked down (nhà)</a:t>
-            </a:r>
-          </a:p>
-          <a:p>
-            <a:pPr>
-              <a:spcAft>
-                <a:spcPts val="400"/>
-              </a:spcAft>
-              <a:defRPr b="0" i="1" sz="2400">
-                <a:solidFill>
-                  <a:srgbClr val="0F172A"/>
-                </a:solidFill>
-                <a:latin typeface="Montserrat"/>
-              </a:defRPr>
-            </a:pPr>
-            <a:r>
-              <a:t>be cleared (cây) / be removed (đồ)</a:t>
-            </a:r>
-          </a:p>
-          <a:p>
-            <a:pPr>
-              <a:spcAft>
-                <a:spcPts val="0"/>
-              </a:spcAft>
-              <a:defRPr b="1" i="1" sz="2400">
-                <a:solidFill>
-                  <a:srgbClr val="0F172A"/>
-                </a:solidFill>
-                <a:latin typeface="Montserrat"/>
-              </a:defRPr>
-            </a:pPr>
-            <a:r>
-              <a:t>the demolition / clearance / removal of</a:t>
-            </a:r>
-          </a:p>
-        </p:txBody>
-      </p:sp>
-      <p:sp>
-        <p:nvSpPr>
-          <p:cNvPr id="4" name="TextBox 3"/>
+        </p:txBody>
+      </p:sp>
+      <p:sp>
+        <p:nvSpPr>
+          <p:cNvPr id="5" name="Rectangle 4"/>
+          <p:cNvSpPr/>
+          <p:nvPr/>
+        </p:nvSpPr>
+        <p:spPr>
+          <a:xfrm>
+            <a:off x="731520" y="3474720"/>
+            <a:ext cx="45720" cy="1920240"/>
+          </a:xfrm>
+          <a:prstGeom prst="rect">
+            <a:avLst/>
+          </a:prstGeom>
+          <a:solidFill>
+            <a:srgbClr val="EA580C"/>
+          </a:solidFill>
+          <a:ln>
+            <a:noFill/>
+          </a:ln>
+        </p:spPr>
+        <p:style>
+          <a:lnRef idx="1">
+            <a:schemeClr val="accent1"/>
+          </a:lnRef>
+          <a:fillRef idx="3">
+            <a:schemeClr val="accent1"/>
+          </a:fillRef>
+          <a:effectRef idx="2">
+            <a:schemeClr val="accent1"/>
+          </a:effectRef>
+          <a:fontRef idx="minor">
+            <a:schemeClr val="lt1"/>
+          </a:fontRef>
+        </p:style>
+        <p:txBody>
+          <a:bodyPr rtlCol="0" anchor="ctr"/>
+          <a:lstStyle/>
+          <a:p>
+            <a:pPr algn="ctr"/>
+          </a:p>
+        </p:txBody>
+      </p:sp>
+      <p:sp>
+        <p:nvSpPr>
+          <p:cNvPr id="6" name="TextBox 5"/>
           <p:cNvSpPr txBox="1"/>
           <p:nvPr/>
         </p:nvSpPr>
         <p:spPr>
           <a:xfrm>
-            <a:off x="6217920" y="1463040"/>
-            <a:ext cx="5120640" cy="4754880"/>
+            <a:off x="896112" y="3474720"/>
+            <a:ext cx="4956048" cy="1920240"/>
           </a:xfrm>
           <a:prstGeom prst="rect">
             <a:avLst/>
@@ -5180,9 +6723,9 @@
           <a:p>
             <a:pPr>
               <a:spcAft>
-                <a:spcPts val="400"/>
+                <a:spcPts val="300"/>
               </a:spcAft>
-              <a:defRPr b="1" i="0" sz="2600">
+              <a:defRPr b="1" sz="2400">
                 <a:solidFill>
                   <a:srgbClr val="0F172A"/>
                 </a:solidFill>
@@ -5190,15 +6733,201 @@
               </a:defRPr>
             </a:pPr>
             <a:r>
+              <a:t>2. PHÁ BỎ HOẶC DỌN TRỐNG</a:t>
+            </a:r>
+          </a:p>
+          <a:p>
+            <a:pPr>
+              <a:defRPr i="1" sz="2400">
+                <a:solidFill>
+                  <a:srgbClr val="0F172A"/>
+                </a:solidFill>
+                <a:latin typeface="Montserrat"/>
+              </a:defRPr>
+            </a:pPr>
+            <a:r>
+              <a:t>be demolished / knocked down (nhà)</a:t>
+            </a:r>
+            <a:br/>
+            <a:r>
+              <a:t>be cleared (cây) / be removed (đồ)</a:t>
+            </a:r>
+            <a:br/>
+            <a:r>
+              <a:t>the demolition / clearance / removal of</a:t>
+            </a:r>
+          </a:p>
+        </p:txBody>
+      </p:sp>
+      <p:sp>
+        <p:nvSpPr>
+          <p:cNvPr id="7" name="Rectangle 6"/>
+          <p:cNvSpPr/>
+          <p:nvPr/>
+        </p:nvSpPr>
+        <p:spPr>
+          <a:xfrm>
+            <a:off x="6217920" y="1463040"/>
+            <a:ext cx="45720" cy="1280160"/>
+          </a:xfrm>
+          <a:prstGeom prst="rect">
+            <a:avLst/>
+          </a:prstGeom>
+          <a:solidFill>
+            <a:srgbClr val="EA580C"/>
+          </a:solidFill>
+          <a:ln>
+            <a:noFill/>
+          </a:ln>
+        </p:spPr>
+        <p:style>
+          <a:lnRef idx="1">
+            <a:schemeClr val="accent1"/>
+          </a:lnRef>
+          <a:fillRef idx="3">
+            <a:schemeClr val="accent1"/>
+          </a:fillRef>
+          <a:effectRef idx="2">
+            <a:schemeClr val="accent1"/>
+          </a:effectRef>
+          <a:fontRef idx="minor">
+            <a:schemeClr val="lt1"/>
+          </a:fontRef>
+        </p:style>
+        <p:txBody>
+          <a:bodyPr rtlCol="0" anchor="ctr"/>
+          <a:lstStyle/>
+          <a:p>
+            <a:pPr algn="ctr"/>
+          </a:p>
+        </p:txBody>
+      </p:sp>
+      <p:sp>
+        <p:nvSpPr>
+          <p:cNvPr id="8" name="TextBox 7"/>
+          <p:cNvSpPr txBox="1"/>
+          <p:nvPr/>
+        </p:nvSpPr>
+        <p:spPr>
+          <a:xfrm>
+            <a:off x="6382512" y="1463040"/>
+            <a:ext cx="4956048" cy="1280160"/>
+          </a:xfrm>
+          <a:prstGeom prst="rect">
+            <a:avLst/>
+          </a:prstGeom>
+          <a:noFill/>
+        </p:spPr>
+        <p:txBody>
+          <a:bodyPr wrap="square" lIns="0" tIns="0" rIns="0" bIns="0">
+            <a:spAutoFit/>
+          </a:bodyPr>
+          <a:lstStyle/>
+          <a:p>
+            <a:pPr>
+              <a:spcAft>
+                <a:spcPts val="300"/>
+              </a:spcAft>
+              <a:defRPr b="1" sz="2400">
+                <a:solidFill>
+                  <a:srgbClr val="0F172A"/>
+                </a:solidFill>
+                <a:latin typeface="Montserrat"/>
+              </a:defRPr>
+            </a:pPr>
+            <a:r>
               <a:t>3. THAY THẾ VÀ CHUYỂN ĐỔI</a:t>
             </a:r>
           </a:p>
           <a:p>
             <a:pPr>
+              <a:defRPr i="1" sz="2400">
+                <a:solidFill>
+                  <a:srgbClr val="0F172A"/>
+                </a:solidFill>
+                <a:latin typeface="Montserrat"/>
+              </a:defRPr>
+            </a:pPr>
+            <a:r>
+              <a:t>be converted into / be replaced by</a:t>
+            </a:r>
+            <a:br/>
+            <a:r>
+              <a:t>gave way to / made way for</a:t>
+            </a:r>
+          </a:p>
+        </p:txBody>
+      </p:sp>
+      <p:sp>
+        <p:nvSpPr>
+          <p:cNvPr id="9" name="Rectangle 8"/>
+          <p:cNvSpPr/>
+          <p:nvPr/>
+        </p:nvSpPr>
+        <p:spPr>
+          <a:xfrm>
+            <a:off x="6217920" y="3017520"/>
+            <a:ext cx="45720" cy="1280160"/>
+          </a:xfrm>
+          <a:prstGeom prst="rect">
+            <a:avLst/>
+          </a:prstGeom>
+          <a:solidFill>
+            <a:srgbClr val="EA580C"/>
+          </a:solidFill>
+          <a:ln>
+            <a:noFill/>
+          </a:ln>
+        </p:spPr>
+        <p:style>
+          <a:lnRef idx="1">
+            <a:schemeClr val="accent1"/>
+          </a:lnRef>
+          <a:fillRef idx="3">
+            <a:schemeClr val="accent1"/>
+          </a:fillRef>
+          <a:effectRef idx="2">
+            <a:schemeClr val="accent1"/>
+          </a:effectRef>
+          <a:fontRef idx="minor">
+            <a:schemeClr val="lt1"/>
+          </a:fontRef>
+        </p:style>
+        <p:txBody>
+          <a:bodyPr rtlCol="0" anchor="ctr"/>
+          <a:lstStyle/>
+          <a:p>
+            <a:pPr algn="ctr"/>
+          </a:p>
+        </p:txBody>
+      </p:sp>
+      <p:sp>
+        <p:nvSpPr>
+          <p:cNvPr id="10" name="TextBox 9"/>
+          <p:cNvSpPr txBox="1"/>
+          <p:nvPr/>
+        </p:nvSpPr>
+        <p:spPr>
+          <a:xfrm>
+            <a:off x="6382512" y="3017520"/>
+            <a:ext cx="4956048" cy="1280160"/>
+          </a:xfrm>
+          <a:prstGeom prst="rect">
+            <a:avLst/>
+          </a:prstGeom>
+          <a:noFill/>
+        </p:spPr>
+        <p:txBody>
+          <a:bodyPr wrap="square" lIns="0" tIns="0" rIns="0" bIns="0">
+            <a:spAutoFit/>
+          </a:bodyPr>
+          <a:lstStyle/>
+          <a:p>
+            <a:pPr>
               <a:spcAft>
-                <a:spcPts val="400"/>
+                <a:spcPts val="300"/>
               </a:spcAft>
-              <a:defRPr b="0" i="1" sz="2400">
+              <a:defRPr b="1" sz="2400">
                 <a:solidFill>
                   <a:srgbClr val="0F172A"/>
                 </a:solidFill>
@@ -5206,15 +6935,98 @@
               </a:defRPr>
             </a:pPr>
             <a:r>
-              <a:t>be converted into / be replaced by</a:t>
-            </a:r>
-          </a:p>
+              <a:t>4. MỞ RỘNG HOẶC THU HẸP</a:t>
+            </a:r>
+          </a:p>
+          <a:p>
+            <a:pPr>
+              <a:defRPr i="1" sz="2400">
+                <a:solidFill>
+                  <a:srgbClr val="0F172A"/>
+                </a:solidFill>
+                <a:latin typeface="Montserrat"/>
+              </a:defRPr>
+            </a:pPr>
+            <a:r>
+              <a:t>be expanded / extended / enlarged</a:t>
+            </a:r>
+            <a:br/>
+            <a:r>
+              <a:t>be reduced in size / narrowed</a:t>
+            </a:r>
+          </a:p>
+        </p:txBody>
+      </p:sp>
+      <p:sp>
+        <p:nvSpPr>
+          <p:cNvPr id="11" name="Rectangle 10"/>
+          <p:cNvSpPr/>
+          <p:nvPr/>
+        </p:nvSpPr>
+        <p:spPr>
+          <a:xfrm>
+            <a:off x="6217920" y="4572000"/>
+            <a:ext cx="45720" cy="1005840"/>
+          </a:xfrm>
+          <a:prstGeom prst="rect">
+            <a:avLst/>
+          </a:prstGeom>
+          <a:solidFill>
+            <a:srgbClr val="EA580C"/>
+          </a:solidFill>
+          <a:ln>
+            <a:noFill/>
+          </a:ln>
+        </p:spPr>
+        <p:style>
+          <a:lnRef idx="1">
+            <a:schemeClr val="accent1"/>
+          </a:lnRef>
+          <a:fillRef idx="3">
+            <a:schemeClr val="accent1"/>
+          </a:fillRef>
+          <a:effectRef idx="2">
+            <a:schemeClr val="accent1"/>
+          </a:effectRef>
+          <a:fontRef idx="minor">
+            <a:schemeClr val="lt1"/>
+          </a:fontRef>
+        </p:style>
+        <p:txBody>
+          <a:bodyPr rtlCol="0" anchor="ctr"/>
+          <a:lstStyle/>
+          <a:p>
+            <a:pPr algn="ctr"/>
+          </a:p>
+        </p:txBody>
+      </p:sp>
+      <p:sp>
+        <p:nvSpPr>
+          <p:cNvPr id="12" name="TextBox 11"/>
+          <p:cNvSpPr txBox="1"/>
+          <p:nvPr/>
+        </p:nvSpPr>
+        <p:spPr>
+          <a:xfrm>
+            <a:off x="6382512" y="4572000"/>
+            <a:ext cx="4956048" cy="1005840"/>
+          </a:xfrm>
+          <a:prstGeom prst="rect">
+            <a:avLst/>
+          </a:prstGeom>
+          <a:noFill/>
+        </p:spPr>
+        <p:txBody>
+          <a:bodyPr wrap="square" lIns="0" tIns="0" rIns="0" bIns="0">
+            <a:spAutoFit/>
+          </a:bodyPr>
+          <a:lstStyle/>
           <a:p>
             <a:pPr>
               <a:spcAft>
-                <a:spcPts val="2000"/>
+                <a:spcPts val="300"/>
               </a:spcAft>
-              <a:defRPr b="1" i="1" sz="2400">
+              <a:defRPr b="1" sz="2400">
                 <a:solidFill>
                   <a:srgbClr val="0F172A"/>
                 </a:solidFill>
@@ -5222,79 +7034,12 @@
               </a:defRPr>
             </a:pPr>
             <a:r>
-              <a:t>gave way to / made way for</a:t>
-            </a:r>
-          </a:p>
-          <a:p>
-            <a:pPr>
-              <a:spcAft>
-                <a:spcPts val="400"/>
-              </a:spcAft>
-              <a:defRPr b="1" i="0" sz="2600">
-                <a:solidFill>
-                  <a:srgbClr val="0F172A"/>
-                </a:solidFill>
-                <a:latin typeface="Montserrat"/>
-              </a:defRPr>
-            </a:pPr>
-            <a:r>
-              <a:t>4. MỞ RỘNG HOẶC THU HẸP</a:t>
-            </a:r>
-          </a:p>
-          <a:p>
-            <a:pPr>
-              <a:spcAft>
-                <a:spcPts val="400"/>
-              </a:spcAft>
-              <a:defRPr b="0" i="1" sz="2400">
-                <a:solidFill>
-                  <a:srgbClr val="0F172A"/>
-                </a:solidFill>
-                <a:latin typeface="Montserrat"/>
-              </a:defRPr>
-            </a:pPr>
-            <a:r>
-              <a:t>be expanded / extended / enlarged</a:t>
-            </a:r>
-          </a:p>
-          <a:p>
-            <a:pPr>
-              <a:spcAft>
-                <a:spcPts val="2000"/>
-              </a:spcAft>
-              <a:defRPr b="0" i="1" sz="2400">
-                <a:solidFill>
-                  <a:srgbClr val="0F172A"/>
-                </a:solidFill>
-                <a:latin typeface="Montserrat"/>
-              </a:defRPr>
-            </a:pPr>
-            <a:r>
-              <a:t>be reduced in size / narrowed</a:t>
-            </a:r>
-          </a:p>
-          <a:p>
-            <a:pPr>
-              <a:spcAft>
-                <a:spcPts val="400"/>
-              </a:spcAft>
-              <a:defRPr b="1" i="0" sz="2600">
-                <a:solidFill>
-                  <a:srgbClr val="0F172A"/>
-                </a:solidFill>
-                <a:latin typeface="Montserrat"/>
-              </a:defRPr>
-            </a:pPr>
-            <a:r>
               <a:t>5. GIỮ NGUYÊN KHÔNG ĐỔI</a:t>
             </a:r>
           </a:p>
           <a:p>
             <a:pPr>
-              <a:spcAft>
-                <a:spcPts val="0"/>
-              </a:spcAft>
-              <a:defRPr b="1" i="1" sz="2400">
+              <a:defRPr i="1" sz="2400">
                 <a:solidFill>
                   <a:srgbClr val="0F172A"/>
                 </a:solidFill>
@@ -5341,8 +7086,8 @@
         </p:nvSpPr>
         <p:spPr>
           <a:xfrm>
-            <a:off x="731520" y="457200"/>
-            <a:ext cx="10728655" cy="731520"/>
+            <a:off x="731520" y="411480"/>
+            <a:ext cx="10728655" cy="685800"/>
           </a:xfrm>
           <a:prstGeom prst="rect">
             <a:avLst/>
@@ -5356,7 +7101,7 @@
           <a:lstStyle/>
           <a:p>
             <a:pPr>
-              <a:defRPr sz="3400" b="1">
+              <a:defRPr sz="3200" b="1">
                 <a:solidFill>
                   <a:srgbClr val="DB2777"/>
                 </a:solidFill>
@@ -5371,14 +7116,57 @@
       </p:sp>
       <p:sp>
         <p:nvSpPr>
-          <p:cNvPr id="3" name="TextBox 2"/>
+          <p:cNvPr id="3" name="Rectangle 2"/>
+          <p:cNvSpPr/>
+          <p:nvPr/>
+        </p:nvSpPr>
+        <p:spPr>
+          <a:xfrm>
+            <a:off x="731520" y="1371600"/>
+            <a:ext cx="45720" cy="960120"/>
+          </a:xfrm>
+          <a:prstGeom prst="rect">
+            <a:avLst/>
+          </a:prstGeom>
+          <a:solidFill>
+            <a:srgbClr val="DB2777"/>
+          </a:solidFill>
+          <a:ln>
+            <a:noFill/>
+          </a:ln>
+        </p:spPr>
+        <p:style>
+          <a:lnRef idx="1">
+            <a:schemeClr val="accent1"/>
+          </a:lnRef>
+          <a:fillRef idx="3">
+            <a:schemeClr val="accent1"/>
+          </a:fillRef>
+          <a:effectRef idx="2">
+            <a:schemeClr val="accent1"/>
+          </a:effectRef>
+          <a:fontRef idx="minor">
+            <a:schemeClr val="lt1"/>
+          </a:fontRef>
+        </p:style>
+        <p:txBody>
+          <a:bodyPr rtlCol="0" anchor="ctr"/>
+          <a:lstStyle/>
+          <a:p>
+            <a:pPr algn="ctr"/>
+          </a:p>
+        </p:txBody>
+      </p:sp>
+      <p:sp>
+        <p:nvSpPr>
+          <p:cNvPr id="4" name="TextBox 3"/>
           <p:cNvSpPr txBox="1"/>
           <p:nvPr/>
         </p:nvSpPr>
         <p:spPr>
           <a:xfrm>
-            <a:off x="731520" y="1463040"/>
-            <a:ext cx="10728655" cy="4754880"/>
+            <a:off x="896112" y="1371600"/>
+            <a:ext cx="10564063" cy="960120"/>
           </a:xfrm>
           <a:prstGeom prst="rect">
             <a:avLst/>
@@ -5393,9 +7181,9 @@
           <a:p>
             <a:pPr>
               <a:spcAft>
-                <a:spcPts val="400"/>
+                <a:spcPts val="300"/>
               </a:spcAft>
-              <a:defRPr b="1" i="0" sz="2600">
+              <a:defRPr b="1" sz="2400">
                 <a:solidFill>
                   <a:srgbClr val="0F172A"/>
                 </a:solidFill>
@@ -5408,10 +7196,89 @@
           </a:p>
           <a:p>
             <a:pPr>
+              <a:defRPr i="1" sz="2400">
+                <a:solidFill>
+                  <a:srgbClr val="0F172A"/>
+                </a:solidFill>
+                <a:latin typeface="Montserrat"/>
+              </a:defRPr>
+            </a:pPr>
+            <a:r>
+              <a:t>Located to the east of the road, the primary school was significantly extended.</a:t>
+            </a:r>
+          </a:p>
+        </p:txBody>
+      </p:sp>
+      <p:sp>
+        <p:nvSpPr>
+          <p:cNvPr id="5" name="Rectangle 4"/>
+          <p:cNvSpPr/>
+          <p:nvPr/>
+        </p:nvSpPr>
+        <p:spPr>
+          <a:xfrm>
+            <a:off x="731520" y="2514600"/>
+            <a:ext cx="45720" cy="960120"/>
+          </a:xfrm>
+          <a:prstGeom prst="rect">
+            <a:avLst/>
+          </a:prstGeom>
+          <a:solidFill>
+            <a:srgbClr val="DB2777"/>
+          </a:solidFill>
+          <a:ln>
+            <a:noFill/>
+          </a:ln>
+        </p:spPr>
+        <p:style>
+          <a:lnRef idx="1">
+            <a:schemeClr val="accent1"/>
+          </a:lnRef>
+          <a:fillRef idx="3">
+            <a:schemeClr val="accent1"/>
+          </a:fillRef>
+          <a:effectRef idx="2">
+            <a:schemeClr val="accent1"/>
+          </a:effectRef>
+          <a:fontRef idx="minor">
+            <a:schemeClr val="lt1"/>
+          </a:fontRef>
+        </p:style>
+        <p:txBody>
+          <a:bodyPr rtlCol="0" anchor="ctr"/>
+          <a:lstStyle/>
+          <a:p>
+            <a:pPr algn="ctr"/>
+          </a:p>
+        </p:txBody>
+      </p:sp>
+      <p:sp>
+        <p:nvSpPr>
+          <p:cNvPr id="6" name="TextBox 5"/>
+          <p:cNvSpPr txBox="1"/>
+          <p:nvPr/>
+        </p:nvSpPr>
+        <p:spPr>
+          <a:xfrm>
+            <a:off x="896112" y="2514600"/>
+            <a:ext cx="10564063" cy="960120"/>
+          </a:xfrm>
+          <a:prstGeom prst="rect">
+            <a:avLst/>
+          </a:prstGeom>
+          <a:noFill/>
+        </p:spPr>
+        <p:txBody>
+          <a:bodyPr wrap="square" lIns="0" tIns="0" rIns="0" bIns="0">
+            <a:spAutoFit/>
+          </a:bodyPr>
+          <a:lstStyle/>
+          <a:p>
+            <a:pPr>
               <a:spcAft>
-                <a:spcPts val="1800"/>
+                <a:spcPts val="300"/>
               </a:spcAft>
-              <a:defRPr b="0" i="1" sz="2400">
+              <a:defRPr b="1" sz="2400">
                 <a:solidFill>
                   <a:srgbClr val="0F172A"/>
                 </a:solidFill>
@@ -5419,15 +7286,94 @@
               </a:defRPr>
             </a:pPr>
             <a:r>
-              <a:t>Located to the east of the road, the primary school was significantly extended.</a:t>
-            </a:r>
-          </a:p>
+              <a:t>2. ĐẢO NGỮ CỤM GIỚI TỪ CHỈ NƠI CHỐN</a:t>
+            </a:r>
+          </a:p>
+          <a:p>
+            <a:pPr>
+              <a:defRPr i="1" sz="2400">
+                <a:solidFill>
+                  <a:srgbClr val="0F172A"/>
+                </a:solidFill>
+                <a:latin typeface="Montserrat"/>
+              </a:defRPr>
+            </a:pPr>
+            <a:r>
+              <a:t>In the top-right corner of the library now stands a newly constructed lecture room.</a:t>
+            </a:r>
+          </a:p>
+        </p:txBody>
+      </p:sp>
+      <p:sp>
+        <p:nvSpPr>
+          <p:cNvPr id="7" name="Rectangle 6"/>
+          <p:cNvSpPr/>
+          <p:nvPr/>
+        </p:nvSpPr>
+        <p:spPr>
+          <a:xfrm>
+            <a:off x="731520" y="3657600"/>
+            <a:ext cx="45720" cy="960120"/>
+          </a:xfrm>
+          <a:prstGeom prst="rect">
+            <a:avLst/>
+          </a:prstGeom>
+          <a:solidFill>
+            <a:srgbClr val="DB2777"/>
+          </a:solidFill>
+          <a:ln>
+            <a:noFill/>
+          </a:ln>
+        </p:spPr>
+        <p:style>
+          <a:lnRef idx="1">
+            <a:schemeClr val="accent1"/>
+          </a:lnRef>
+          <a:fillRef idx="3">
+            <a:schemeClr val="accent1"/>
+          </a:fillRef>
+          <a:effectRef idx="2">
+            <a:schemeClr val="accent1"/>
+          </a:effectRef>
+          <a:fontRef idx="minor">
+            <a:schemeClr val="lt1"/>
+          </a:fontRef>
+        </p:style>
+        <p:txBody>
+          <a:bodyPr rtlCol="0" anchor="ctr"/>
+          <a:lstStyle/>
+          <a:p>
+            <a:pPr algn="ctr"/>
+          </a:p>
+        </p:txBody>
+      </p:sp>
+      <p:sp>
+        <p:nvSpPr>
+          <p:cNvPr id="8" name="TextBox 7"/>
+          <p:cNvSpPr txBox="1"/>
+          <p:nvPr/>
+        </p:nvSpPr>
+        <p:spPr>
+          <a:xfrm>
+            <a:off x="896112" y="3657600"/>
+            <a:ext cx="10564063" cy="960120"/>
+          </a:xfrm>
+          <a:prstGeom prst="rect">
+            <a:avLst/>
+          </a:prstGeom>
+          <a:noFill/>
+        </p:spPr>
+        <p:txBody>
+          <a:bodyPr wrap="square" lIns="0" tIns="0" rIns="0" bIns="0">
+            <a:spAutoFit/>
+          </a:bodyPr>
+          <a:lstStyle/>
           <a:p>
             <a:pPr>
               <a:spcAft>
-                <a:spcPts val="400"/>
+                <a:spcPts val="300"/>
               </a:spcAft>
-              <a:defRPr b="1" i="0" sz="2600">
+              <a:defRPr b="1" sz="2400">
                 <a:solidFill>
                   <a:srgbClr val="0F172A"/>
                 </a:solidFill>
@@ -5435,15 +7381,94 @@
               </a:defRPr>
             </a:pPr>
             <a:r>
-              <a:t>2. ĐẢO NGỮ CỤM GIỚI TỪ CHỈ NƠI CHỐN</a:t>
-            </a:r>
-          </a:p>
+              <a:t>3. CẤU TRÚC ĐÁNH ĐỔI AT THE EXPENSE OF</a:t>
+            </a:r>
+          </a:p>
+          <a:p>
+            <a:pPr>
+              <a:defRPr i="1" sz="2400">
+                <a:solidFill>
+                  <a:srgbClr val="0F172A"/>
+                </a:solidFill>
+                <a:latin typeface="Montserrat"/>
+              </a:defRPr>
+            </a:pPr>
+            <a:r>
+              <a:t>The retirement home was expanded at the expense of the surrounding gardens.</a:t>
+            </a:r>
+          </a:p>
+        </p:txBody>
+      </p:sp>
+      <p:sp>
+        <p:nvSpPr>
+          <p:cNvPr id="9" name="Rectangle 8"/>
+          <p:cNvSpPr/>
+          <p:nvPr/>
+        </p:nvSpPr>
+        <p:spPr>
+          <a:xfrm>
+            <a:off x="731520" y="4800600"/>
+            <a:ext cx="45720" cy="960120"/>
+          </a:xfrm>
+          <a:prstGeom prst="rect">
+            <a:avLst/>
+          </a:prstGeom>
+          <a:solidFill>
+            <a:srgbClr val="DB2777"/>
+          </a:solidFill>
+          <a:ln>
+            <a:noFill/>
+          </a:ln>
+        </p:spPr>
+        <p:style>
+          <a:lnRef idx="1">
+            <a:schemeClr val="accent1"/>
+          </a:lnRef>
+          <a:fillRef idx="3">
+            <a:schemeClr val="accent1"/>
+          </a:fillRef>
+          <a:effectRef idx="2">
+            <a:schemeClr val="accent1"/>
+          </a:effectRef>
+          <a:fontRef idx="minor">
+            <a:schemeClr val="lt1"/>
+          </a:fontRef>
+        </p:style>
+        <p:txBody>
+          <a:bodyPr rtlCol="0" anchor="ctr"/>
+          <a:lstStyle/>
+          <a:p>
+            <a:pPr algn="ctr"/>
+          </a:p>
+        </p:txBody>
+      </p:sp>
+      <p:sp>
+        <p:nvSpPr>
+          <p:cNvPr id="10" name="TextBox 9"/>
+          <p:cNvSpPr txBox="1"/>
+          <p:nvPr/>
+        </p:nvSpPr>
+        <p:spPr>
+          <a:xfrm>
+            <a:off x="896112" y="4800600"/>
+            <a:ext cx="10564063" cy="960120"/>
+          </a:xfrm>
+          <a:prstGeom prst="rect">
+            <a:avLst/>
+          </a:prstGeom>
+          <a:noFill/>
+        </p:spPr>
+        <p:txBody>
+          <a:bodyPr wrap="square" lIns="0" tIns="0" rIns="0" bIns="0">
+            <a:spAutoFit/>
+          </a:bodyPr>
+          <a:lstStyle/>
           <a:p>
             <a:pPr>
               <a:spcAft>
-                <a:spcPts val="1800"/>
+                <a:spcPts val="300"/>
               </a:spcAft>
-              <a:defRPr b="0" i="1" sz="2400">
+              <a:defRPr b="1" sz="2400">
                 <a:solidFill>
                   <a:srgbClr val="0F172A"/>
                 </a:solidFill>
@@ -5451,63 +7476,12 @@
               </a:defRPr>
             </a:pPr>
             <a:r>
-              <a:t>In the top-right corner of the library now stands a newly constructed lecture room.</a:t>
-            </a:r>
-          </a:p>
-          <a:p>
-            <a:pPr>
-              <a:spcAft>
-                <a:spcPts val="400"/>
-              </a:spcAft>
-              <a:defRPr b="1" i="0" sz="2600">
-                <a:solidFill>
-                  <a:srgbClr val="0F172A"/>
-                </a:solidFill>
-                <a:latin typeface="Montserrat"/>
-              </a:defRPr>
-            </a:pPr>
-            <a:r>
-              <a:t>3. CẤU TRÚC ĐÁNH ĐỔI AT THE EXPENSE OF</a:t>
-            </a:r>
-          </a:p>
-          <a:p>
-            <a:pPr>
-              <a:spcAft>
-                <a:spcPts val="1800"/>
-              </a:spcAft>
-              <a:defRPr b="0" i="1" sz="2400">
-                <a:solidFill>
-                  <a:srgbClr val="0F172A"/>
-                </a:solidFill>
-                <a:latin typeface="Montserrat"/>
-              </a:defRPr>
-            </a:pPr>
-            <a:r>
-              <a:t>The retirement home was expanded at the expense of the surrounding gardens.</a:t>
-            </a:r>
-          </a:p>
-          <a:p>
-            <a:pPr>
-              <a:spcAft>
-                <a:spcPts val="400"/>
-              </a:spcAft>
-              <a:defRPr b="1" i="0" sz="2600">
-                <a:solidFill>
-                  <a:srgbClr val="0F172A"/>
-                </a:solidFill>
-                <a:latin typeface="Montserrat"/>
-              </a:defRPr>
-            </a:pPr>
-            <a:r>
               <a:t>4. DANH TỪ HÓA VỚI ĐỘNG TỪ WITNESSED</a:t>
             </a:r>
           </a:p>
           <a:p>
             <a:pPr>
-              <a:spcAft>
-                <a:spcPts val="0"/>
-              </a:spcAft>
-              <a:defRPr b="0" i="1" sz="2400">
+              <a:defRPr i="1" sz="2400">
                 <a:solidFill>
                   <a:srgbClr val="0F172A"/>
                 </a:solidFill>
@@ -5554,8 +7528,8 @@
         </p:nvSpPr>
         <p:spPr>
           <a:xfrm>
-            <a:off x="731520" y="457200"/>
-            <a:ext cx="10728655" cy="731520"/>
+            <a:off x="731520" y="411480"/>
+            <a:ext cx="10728655" cy="685800"/>
           </a:xfrm>
           <a:prstGeom prst="rect">
             <a:avLst/>
@@ -5569,7 +7543,7 @@
           <a:lstStyle/>
           <a:p>
             <a:pPr>
-              <a:defRPr sz="3400" b="1">
+              <a:defRPr sz="3200" b="1">
                 <a:solidFill>
                   <a:srgbClr val="DC2626"/>
                 </a:solidFill>
@@ -5598,8 +7572,8 @@
         </p:blipFill>
         <p:spPr>
           <a:xfrm>
-            <a:off x="731520" y="1463040"/>
-            <a:ext cx="4114800" cy="2153512"/>
+            <a:off x="731520" y="1371600"/>
+            <a:ext cx="4023360" cy="2105656"/>
           </a:xfrm>
           <a:prstGeom prst="rect">
             <a:avLst/>
@@ -5608,14 +7582,57 @@
       </p:pic>
       <p:sp>
         <p:nvSpPr>
-          <p:cNvPr id="4" name="TextBox 3"/>
+          <p:cNvPr id="4" name="Rectangle 3"/>
+          <p:cNvSpPr/>
+          <p:nvPr/>
+        </p:nvSpPr>
+        <p:spPr>
+          <a:xfrm>
+            <a:off x="5120640" y="1371600"/>
+            <a:ext cx="45720" cy="1554480"/>
+          </a:xfrm>
+          <a:prstGeom prst="rect">
+            <a:avLst/>
+          </a:prstGeom>
+          <a:solidFill>
+            <a:srgbClr val="DC2626"/>
+          </a:solidFill>
+          <a:ln>
+            <a:noFill/>
+          </a:ln>
+        </p:spPr>
+        <p:style>
+          <a:lnRef idx="1">
+            <a:schemeClr val="accent1"/>
+          </a:lnRef>
+          <a:fillRef idx="3">
+            <a:schemeClr val="accent1"/>
+          </a:fillRef>
+          <a:effectRef idx="2">
+            <a:schemeClr val="accent1"/>
+          </a:effectRef>
+          <a:fontRef idx="minor">
+            <a:schemeClr val="lt1"/>
+          </a:fontRef>
+        </p:style>
+        <p:txBody>
+          <a:bodyPr rtlCol="0" anchor="ctr"/>
+          <a:lstStyle/>
+          <a:p>
+            <a:pPr algn="ctr"/>
+          </a:p>
+        </p:txBody>
+      </p:sp>
+      <p:sp>
+        <p:nvSpPr>
+          <p:cNvPr id="5" name="TextBox 4"/>
           <p:cNvSpPr txBox="1"/>
           <p:nvPr/>
         </p:nvSpPr>
         <p:spPr>
           <a:xfrm>
-            <a:off x="5120640" y="1463040"/>
-            <a:ext cx="6309360" cy="4754880"/>
+            <a:off x="5285232" y="1371600"/>
+            <a:ext cx="6144768" cy="1554480"/>
           </a:xfrm>
           <a:prstGeom prst="rect">
             <a:avLst/>
@@ -5630,9 +7647,9 @@
           <a:p>
             <a:pPr>
               <a:spcAft>
-                <a:spcPts val="400"/>
+                <a:spcPts val="300"/>
               </a:spcAft>
-              <a:defRPr b="1" i="0" sz="2600">
+              <a:defRPr b="1" sz="2400">
                 <a:solidFill>
                   <a:srgbClr val="0F172A"/>
                 </a:solidFill>
@@ -5645,10 +7662,89 @@
           </a:p>
           <a:p>
             <a:pPr>
+              <a:defRPr i="1" sz="2400">
+                <a:solidFill>
+                  <a:srgbClr val="0F172A"/>
+                </a:solidFill>
+                <a:latin typeface="Montserrat"/>
+              </a:defRPr>
+            </a:pPr>
+            <a:r>
+              <a:t>The two maps illustrate how Stokeford developed over an 80-year period from 1930 to 2010.</a:t>
+            </a:r>
+          </a:p>
+        </p:txBody>
+      </p:sp>
+      <p:sp>
+        <p:nvSpPr>
+          <p:cNvPr id="6" name="Rectangle 5"/>
+          <p:cNvSpPr/>
+          <p:nvPr/>
+        </p:nvSpPr>
+        <p:spPr>
+          <a:xfrm>
+            <a:off x="5120640" y="3200400"/>
+            <a:ext cx="45720" cy="2377440"/>
+          </a:xfrm>
+          <a:prstGeom prst="rect">
+            <a:avLst/>
+          </a:prstGeom>
+          <a:solidFill>
+            <a:srgbClr val="DC2626"/>
+          </a:solidFill>
+          <a:ln>
+            <a:noFill/>
+          </a:ln>
+        </p:spPr>
+        <p:style>
+          <a:lnRef idx="1">
+            <a:schemeClr val="accent1"/>
+          </a:lnRef>
+          <a:fillRef idx="3">
+            <a:schemeClr val="accent1"/>
+          </a:fillRef>
+          <a:effectRef idx="2">
+            <a:schemeClr val="accent1"/>
+          </a:effectRef>
+          <a:fontRef idx="minor">
+            <a:schemeClr val="lt1"/>
+          </a:fontRef>
+        </p:style>
+        <p:txBody>
+          <a:bodyPr rtlCol="0" anchor="ctr"/>
+          <a:lstStyle/>
+          <a:p>
+            <a:pPr algn="ctr"/>
+          </a:p>
+        </p:txBody>
+      </p:sp>
+      <p:sp>
+        <p:nvSpPr>
+          <p:cNvPr id="7" name="TextBox 6"/>
+          <p:cNvSpPr txBox="1"/>
+          <p:nvPr/>
+        </p:nvSpPr>
+        <p:spPr>
+          <a:xfrm>
+            <a:off x="5285232" y="3200400"/>
+            <a:ext cx="6144768" cy="2377440"/>
+          </a:xfrm>
+          <a:prstGeom prst="rect">
+            <a:avLst/>
+          </a:prstGeom>
+          <a:noFill/>
+        </p:spPr>
+        <p:txBody>
+          <a:bodyPr wrap="square" lIns="0" tIns="0" rIns="0" bIns="0">
+            <a:spAutoFit/>
+          </a:bodyPr>
+          <a:lstStyle/>
+          <a:p>
+            <a:pPr>
               <a:spcAft>
-                <a:spcPts val="2200"/>
+                <a:spcPts val="300"/>
               </a:spcAft>
-              <a:defRPr b="0" i="1" sz="2400">
+              <a:defRPr b="1" sz="2400">
                 <a:solidFill>
                   <a:srgbClr val="0F172A"/>
                 </a:solidFill>
@@ -5656,15 +7752,12 @@
               </a:defRPr>
             </a:pPr>
             <a:r>
-              <a:t>The two maps illustrate how Stokeford developed over an 80-year period from 1930 to 2010.</a:t>
-            </a:r>
-          </a:p>
-          <a:p>
-            <a:pPr>
-              <a:spcAft>
-                <a:spcPts val="400"/>
-              </a:spcAft>
-              <a:defRPr b="1" i="0" sz="2600">
+              <a:t>OVERVIEW (BỨC TRANH TỔNG THỂ)</a:t>
+            </a:r>
+          </a:p>
+          <a:p>
+            <a:pPr>
+              <a:defRPr i="1" sz="2400">
                 <a:solidFill>
                   <a:srgbClr val="0F172A"/>
                 </a:solidFill>
@@ -5672,39 +7765,12 @@
               </a:defRPr>
             </a:pPr>
             <a:r>
-              <a:t>OVERVIEW (2 CÂU BỨC TRANH TỔNG THỂ)</a:t>
-            </a:r>
-          </a:p>
-          <a:p>
-            <a:pPr>
-              <a:spcAft>
-                <a:spcPts val="800"/>
-              </a:spcAft>
-              <a:defRPr b="0" i="1" sz="2400">
-                <a:solidFill>
-                  <a:srgbClr val="0F172A"/>
-                </a:solidFill>
-                <a:latin typeface="Montserrat"/>
-              </a:defRPr>
-            </a:pPr>
-            <a:r>
-              <a:t>Overall, the village underwent a dramatic transformation from a rural agricultural community into a residential area.</a:t>
-            </a:r>
-          </a:p>
-          <a:p>
-            <a:pPr>
-              <a:spcAft>
-                <a:spcPts val="0"/>
-              </a:spcAft>
-              <a:defRPr b="0" i="1" sz="2400">
-                <a:solidFill>
-                  <a:srgbClr val="0F172A"/>
-                </a:solidFill>
-                <a:latin typeface="Montserrat"/>
-              </a:defRPr>
-            </a:pPr>
-            <a:r>
-              <a:t>The most notable changes include the complete clearance of farmland to construct new housing.</a:t>
+              <a:t>Overall, the village underwent a transformation from a rural into a densely populated residential area.</a:t>
+            </a:r>
+            <a:br/>
+            <a:br/>
+            <a:r>
+              <a:t>The most notable changes include the complete clearance of farmland for new housing.</a:t>
             </a:r>
           </a:p>
         </p:txBody>

</xml_diff>